<commit_message>
Rebuild talk deck as ten slides with the term figures
Co-Authored-By: Claude Fable 5.1 <noreply@anthropic.com>
Claude-Session: https://claude.ai/code/session_019q8NWWmgCfoxLvyzmCH4VN
</commit_message>
<xml_diff>
--- a/D2D/docs/TALK.pptx
+++ b/D2D/docs/TALK.pptx
@@ -12,9 +12,12 @@
     <p:sldId id="260" r:id="rId6"/>
     <p:sldId id="261" r:id="rId7"/>
     <p:sldId id="262" r:id="rId8"/>
+    <p:sldId id="263" r:id="rId9"/>
+    <p:sldId id="264" r:id="rId10"/>
+    <p:sldId id="265" r:id="rId11"/>
   </p:sldIdLst>
   <p:notesMasterIdLst>
-    <p:notesMasterId r:id="rId9"/>
+    <p:notesMasterId r:id="rId12"/>
   </p:notesMasterIdLst>
   <p:sldSz cx="9144000" cy="5143500"/>
   <p:notesSz cx="5143500" cy="9144000"/>
@@ -550,6 +553,95 @@
 </p:notes>
 </file>
 
+<file path=ppt/notesSlides/notesSlide10.xml><?xml version="1.0" encoding="utf-8"?>
+<p:notes xmlns:a="http://schemas.openxmlformats.org/drawingml/2006/main" xmlns:r="http://schemas.openxmlformats.org/officeDocument/2006/relationships" xmlns:p="http://schemas.openxmlformats.org/presentationml/2006/main">
+  <p:cSld>
+    <p:spTree>
+      <p:nvGrpSpPr>
+        <p:cNvPr id="1" name=""/>
+        <p:cNvGrpSpPr/>
+        <p:nvPr/>
+      </p:nvGrpSpPr>
+      <p:grpSpPr>
+        <a:xfrm>
+          <a:off x="0" y="0"/>
+          <a:ext cx="0" cy="0"/>
+          <a:chOff x="0" y="0"/>
+          <a:chExt cx="0" cy="0"/>
+        </a:xfrm>
+      </p:grpSpPr>
+      <p:sp>
+        <p:nvSpPr>
+          <p:cNvPr id="2" name="Slide Image Placeholder 1"/>
+          <p:cNvSpPr>
+            <a:spLocks noGrp="1" noRot="1" noChangeAspect="1"/>
+          </p:cNvSpPr>
+          <p:nvPr>
+            <p:ph type="sldImg"/>
+          </p:nvPr>
+        </p:nvSpPr>
+        <p:spPr/>
+      </p:sp>
+      <p:sp>
+        <p:nvSpPr>
+          <p:cNvPr id="3" name="Notes Placeholder 2"/>
+          <p:cNvSpPr>
+            <a:spLocks noGrp="1"/>
+          </p:cNvSpPr>
+          <p:nvPr>
+            <p:ph type="body" idx="1"/>
+          </p:nvPr>
+        </p:nvSpPr>
+        <p:spPr/>
+        <p:txBody>
+          <a:bodyPr/>
+          <a:lstStyle/>
+          <a:p>
+            <a:r>
+              <a:rPr lang="en-US" dirty="0"/>
+              <a:t>Honest limits: we use standard levels, not Hart's 50 hectopascal spacing, so magnitudes are near his but not identical. The window is a square, which carries a small cold bias on a strong gradient. B and the transition-onset field are implemented but not yet validated. And it's three cases, not a season.
+Next is a season of use, a model-comparison product for transition timing, and a storm-centered diagram inside GFE. The package, guides, and tests are in the repository. Questions.</a:t>
+            </a:r>
+            <a:endParaRPr lang="en-US" dirty="0"/>
+          </a:p>
+        </p:txBody>
+      </p:sp>
+      <p:sp>
+        <p:nvSpPr>
+          <p:cNvPr id="4" name="Slide Number Placeholder 3"/>
+          <p:cNvSpPr>
+            <a:spLocks noGrp="1"/>
+          </p:cNvSpPr>
+          <p:nvPr>
+            <p:ph type="sldNum" sz="quarter" idx="10"/>
+          </p:nvPr>
+        </p:nvSpPr>
+        <p:spPr/>
+        <p:txBody>
+          <a:bodyPr/>
+          <a:lstStyle/>
+          <a:p>
+            <a:fld id="{F7021451-1387-4CA6-816F-3879F97B5CBC}" type="slidenum">
+              <a:rPr lang="en-US"/>
+              <a:t>10</a:t>
+            </a:fld>
+            <a:endParaRPr lang="en-US"/>
+          </a:p>
+        </p:txBody>
+      </p:sp>
+    </p:spTree>
+    <p:extLst>
+      <p:ext uri="{BB962C8B-B14F-4D97-AF65-F5344CB8AC3E}">
+        <p14:creationId xmlns:p14="http://schemas.microsoft.com/office/powerpoint/2010/main" val="1024086991"/>
+      </p:ext>
+    </p:extLst>
+  </p:cSld>
+  <p:clrMapOvr>
+    <a:masterClrMapping/>
+  </p:clrMapOvr>
+</p:notes>
+</file>
+
 <file path=ppt/notesSlides/notesSlide2.xml><?xml version="1.0" encoding="utf-8"?>
 <p:notes xmlns:a="http://schemas.openxmlformats.org/drawingml/2006/main" xmlns:r="http://schemas.openxmlformats.org/officeDocument/2006/relationships" xmlns:p="http://schemas.openxmlformats.org/presentationml/2006/main">
   <p:cSld>
@@ -596,8 +688,7 @@
           <a:p>
             <a:r>
               <a:rPr lang="en-US" dirty="0"/>
-              <a:t>The science is Bob Hart's cyclone phase space from 2003. It describes a cyclone with three numbers from the height field alone. Two are thermal wind terms, lower and upper troposphere, which say whether the core is warmer or colder than its surroundings. Positive is warm core, a hurricane. Negative is cold core, an extratropical low. The third, B, measures the temperature contrast across the storm's track, which is whether it's frontal.
-Plotted against each other, a storm traces a path. A hurricane starts in the deep warm core corner. During extratropical transition it loses the upper warm core, then the lower one, and ends up cold core. Evans and Hart showed the crossings give objective onset and completion times for transition. And transition is when the wind field expands, so for a marine center this is the forecast question.</a:t>
+              <a:t>The science is Bob Hart's cyclone phase space from 2003. It describes a cyclone with three numbers from the height field alone, all taken inside a 500 kilometer circle around the center. Two are thermal wind terms, one for the lower troposphere and one for the upper, and they say whether the core is warmer or colder than its surroundings. The third, B, says whether the storm is frontal. Together they place any cyclone on a diagram, and a storm traces a path through it as it evolves.</a:t>
             </a:r>
             <a:endParaRPr lang="en-US" dirty="0"/>
           </a:p>
@@ -685,8 +776,8 @@
           <a:p>
             <a:r>
               <a:rPr lang="en-US" dirty="0"/>
-              <a:t>Until now the only operational access was FSU's web page: static plots, computed externally, for tracked tropical cyclones only. The hybrid, post-tropical, and non-tropical systems that OPC actually warns on aren't on it.
-We reformulated the parameters as gridded fields and implemented them as AWIPS derived parameters. At every grid point, the code takes the height range inside a 500 kilometer window at each level and regresses it against log pressure. That is Hart's exact quantity, evaluated everywhere instead of at one tracked center. It needs only geopotential height on standard levels, surface pressure, and winds, so it works on every model in D2D with no tracker and no advisory. A closed-low detector on the 1000 hPa height blanks everything that isn't a real low, and terrain is masked below ground.</a:t>
+              <a:t>Here is what the thermal wind terms actually measure. Take a cross-section through a storm. The height of a pressure surface dips over the low. In a warm-core storm, a hurricane, the column is warm, so it is thick, so the dip is deepest at the surface and fills in with altitude. The pressure surfaces flatten out aloft. In a cold-core low the column is cold and thin, so the dip deepens with altitude and the trough is strongest at the top.
+Hart measures that with one number per level: the height range inside the circle, max minus min. Then he looks at how that range changes with height. Shrinking upward is warm core, positive. Growing upward is cold core, negative. He does it twice, once for the lower troposphere and once for the upper, and that split is what lets you tell a hurricane, warm all the way up, from a subtropical storm or a warm seclusion, which is warm only in the lower layer.</a:t>
             </a:r>
             <a:endParaRPr lang="en-US" dirty="0"/>
           </a:p>
@@ -774,7 +865,8 @@
           <a:p>
             <a:r>
               <a:rPr lang="en-US" dirty="0"/>
-              <a:t>We tried a cheaper version first, differencing vorticity between levels. It fails in a specific way worth knowing. A baroclinic low is tilted: its upper trough sits west of the surface center. At the surface low the upper vorticity is weak, so the proxy reads warm, and the cold signal shows up displaced to the west as a dipole. Hart's window spans the tilt and reads cold at the center. This figure is that comparison on a synthetic tilted low: the proxy near zero at the center, the Hart field at minus 285 meters.</a:t>
+              <a:t>The third number, B, is about the environment rather than the core. Thickness between two pressure levels is a measure of the mean temperature of the layer. Draw the 500 kilometer circle around the storm, split it into left and right of the direction of motion, and subtract the mean thickness of the two halves.
+For a hurricane the thickness contours close around the storm, both halves are the same, and B is near zero. For a storm that has moved into a front, warm air sits on one flank and cold air on the other, and B is large. Hart's threshold is 10 meters. Evans and Hart use the hour B first exceeds it as the objective onset of extratropical transition, and the hour the lower thermal wind turns negative as completion.</a:t>
             </a:r>
             <a:endParaRPr lang="en-US" dirty="0"/>
           </a:p>
@@ -862,7 +954,7 @@
           <a:p>
             <a:r>
               <a:rPr lang="en-US" dirty="0"/>
-              <a:t>This is the operational display. Four panels: the lower and upper terms, a category field, and an index. The category reads at the storm's center: 4 is deep warm core, 3 shallow, 1 cold, blank means no closed low. Step through the frames and the first hour the category leaves 4 is the loss of the deep warm core. Load a second model beside it and where they disagree on that hour is your transition uncertainty. That is a product nobody had before, because it needed a tracker for every model.</a:t>
+              <a:t>Put those together and you get Hart's two diagrams. On the left, B against the lower thermal wind: symmetric or frontal, warm or cold. On the right, lower against upper thermal wind: deep warm, shallow warm, or cold. A hurricane starts in the deep warm corner. During transition it crosses the B line first, then loses the upper warm core, then the lower one, and ends in the cold corner. Some storms then hook back toward shallow warm core: that is a warm seclusion re-forming a warm core at the surface, and those are the ones that deepen unexpectedly over cold water. For a marine center, transition is when the wind field expands, so these crossings are the forecast question.</a:t>
             </a:r>
             <a:endParaRPr lang="en-US" dirty="0"/>
           </a:p>
@@ -950,7 +1042,8 @@
           <a:p>
             <a:r>
               <a:rPr lang="en-US" dirty="0"/>
-              <a:t>Three checks so far. A typhoon at 984 millibars read 120 and 180 meters, class 4, squarely in the range Hart published for hurricanes. For Typhoon Dujuan, the hour our class dropped below 4 matched the hour FSU's page showed the same GFS run moving from deep to shallow warm core. And a deep North Atlantic low classified cold core, which the vorticity shortcut could not do. Greenland and the Rockies come out blank rather than contaminated. Compute cost is about a second per frame on the full global grid.</a:t>
+              <a:t>Until now the only operational access was FSU's web page: static plots, computed externally, for tracked tropical cyclones only. The hybrid, post-tropical, and non-tropical systems that OPC actually warns on aren't on it.
+We reformulated the parameters as gridded fields and implemented them as AWIPS derived parameters. At every grid point the code evaluates the height range inside a 500 kilometer window at each level and regresses it against log pressure. That is Hart's exact quantity, everywhere instead of at one tracked center. It needs only geopotential height on standard levels, surface pressure, and winds for the motion in B, so it works on every model in D2D with no tracker and no advisory. A closed-low detector on the 1000 hPa height blanks everything that isn't a real low, and terrain is masked below ground.</a:t>
             </a:r>
             <a:endParaRPr lang="en-US" dirty="0"/>
           </a:p>
@@ -1038,8 +1131,7 @@
           <a:p>
             <a:r>
               <a:rPr lang="en-US" dirty="0"/>
-              <a:t>Honest limits: we use standard levels, not Hart's 50 hectopascal spacing, so magnitudes are near his but not identical. The window is a square, which carries a small cold bias on a strong gradient. B and the transition-onset field are implemented but not yet validated. And it's three cases, not a season.
-Next is a season of use, a model-comparison product for transition timing, and a storm-centered diagram inside GFE. The package, guides, and tests are in the repository. Questions.</a:t>
+              <a:t>We tried a cheaper version first, differencing vorticity between levels. It fails in a specific way worth knowing. A baroclinic low is tilted: its upper trough sits west of the surface center. At the surface low the upper vorticity is weak, so the proxy reads warm, and the cold signal shows up displaced to the west as a dipole. Hart's window spans the tilt and reads cold at the center. On a synthetic tilted low the proxy reads near zero at the center and the Hart field reads minus 285 meters.</a:t>
             </a:r>
             <a:endParaRPr lang="en-US" dirty="0"/>
           </a:p>
@@ -1063,6 +1155,182 @@
             <a:fld id="{F7021451-1387-4CA6-816F-3879F97B5CBC}" type="slidenum">
               <a:rPr lang="en-US"/>
               <a:t>7</a:t>
+            </a:fld>
+            <a:endParaRPr lang="en-US"/>
+          </a:p>
+        </p:txBody>
+      </p:sp>
+    </p:spTree>
+    <p:extLst>
+      <p:ext uri="{BB962C8B-B14F-4D97-AF65-F5344CB8AC3E}">
+        <p14:creationId xmlns:p14="http://schemas.microsoft.com/office/powerpoint/2010/main" val="1024086991"/>
+      </p:ext>
+    </p:extLst>
+  </p:cSld>
+  <p:clrMapOvr>
+    <a:masterClrMapping/>
+  </p:clrMapOvr>
+</p:notes>
+</file>
+
+<file path=ppt/notesSlides/notesSlide8.xml><?xml version="1.0" encoding="utf-8"?>
+<p:notes xmlns:a="http://schemas.openxmlformats.org/drawingml/2006/main" xmlns:r="http://schemas.openxmlformats.org/officeDocument/2006/relationships" xmlns:p="http://schemas.openxmlformats.org/presentationml/2006/main">
+  <p:cSld>
+    <p:spTree>
+      <p:nvGrpSpPr>
+        <p:cNvPr id="1" name=""/>
+        <p:cNvGrpSpPr/>
+        <p:nvPr/>
+      </p:nvGrpSpPr>
+      <p:grpSpPr>
+        <a:xfrm>
+          <a:off x="0" y="0"/>
+          <a:ext cx="0" cy="0"/>
+          <a:chOff x="0" y="0"/>
+          <a:chExt cx="0" cy="0"/>
+        </a:xfrm>
+      </p:grpSpPr>
+      <p:sp>
+        <p:nvSpPr>
+          <p:cNvPr id="2" name="Slide Image Placeholder 1"/>
+          <p:cNvSpPr>
+            <a:spLocks noGrp="1" noRot="1" noChangeAspect="1"/>
+          </p:cNvSpPr>
+          <p:nvPr>
+            <p:ph type="sldImg"/>
+          </p:nvPr>
+        </p:nvSpPr>
+        <p:spPr/>
+      </p:sp>
+      <p:sp>
+        <p:nvSpPr>
+          <p:cNvPr id="3" name="Notes Placeholder 2"/>
+          <p:cNvSpPr>
+            <a:spLocks noGrp="1"/>
+          </p:cNvSpPr>
+          <p:nvPr>
+            <p:ph type="body" idx="1"/>
+          </p:nvPr>
+        </p:nvSpPr>
+        <p:spPr/>
+        <p:txBody>
+          <a:bodyPr/>
+          <a:lstStyle/>
+          <a:p>
+            <a:r>
+              <a:rPr lang="en-US" dirty="0"/>
+              <a:t>This is the operational display. Four panels: the lower and upper terms, a category field, and an index. The category reads at the storm's center: 4 is deep warm core, 3 shallow, 1 cold, blank means no closed low. Step through the frames and the first hour the category leaves 4 is the loss of the deep warm core. Load a second model beside it and where they disagree on that hour is your transition uncertainty. That is a product nobody had before, because it needed a tracker for every model.</a:t>
+            </a:r>
+            <a:endParaRPr lang="en-US" dirty="0"/>
+          </a:p>
+        </p:txBody>
+      </p:sp>
+      <p:sp>
+        <p:nvSpPr>
+          <p:cNvPr id="4" name="Slide Number Placeholder 3"/>
+          <p:cNvSpPr>
+            <a:spLocks noGrp="1"/>
+          </p:cNvSpPr>
+          <p:nvPr>
+            <p:ph type="sldNum" sz="quarter" idx="10"/>
+          </p:nvPr>
+        </p:nvSpPr>
+        <p:spPr/>
+        <p:txBody>
+          <a:bodyPr/>
+          <a:lstStyle/>
+          <a:p>
+            <a:fld id="{F7021451-1387-4CA6-816F-3879F97B5CBC}" type="slidenum">
+              <a:rPr lang="en-US"/>
+              <a:t>8</a:t>
+            </a:fld>
+            <a:endParaRPr lang="en-US"/>
+          </a:p>
+        </p:txBody>
+      </p:sp>
+    </p:spTree>
+    <p:extLst>
+      <p:ext uri="{BB962C8B-B14F-4D97-AF65-F5344CB8AC3E}">
+        <p14:creationId xmlns:p14="http://schemas.microsoft.com/office/powerpoint/2010/main" val="1024086991"/>
+      </p:ext>
+    </p:extLst>
+  </p:cSld>
+  <p:clrMapOvr>
+    <a:masterClrMapping/>
+  </p:clrMapOvr>
+</p:notes>
+</file>
+
+<file path=ppt/notesSlides/notesSlide9.xml><?xml version="1.0" encoding="utf-8"?>
+<p:notes xmlns:a="http://schemas.openxmlformats.org/drawingml/2006/main" xmlns:r="http://schemas.openxmlformats.org/officeDocument/2006/relationships" xmlns:p="http://schemas.openxmlformats.org/presentationml/2006/main">
+  <p:cSld>
+    <p:spTree>
+      <p:nvGrpSpPr>
+        <p:cNvPr id="1" name=""/>
+        <p:cNvGrpSpPr/>
+        <p:nvPr/>
+      </p:nvGrpSpPr>
+      <p:grpSpPr>
+        <a:xfrm>
+          <a:off x="0" y="0"/>
+          <a:ext cx="0" cy="0"/>
+          <a:chOff x="0" y="0"/>
+          <a:chExt cx="0" cy="0"/>
+        </a:xfrm>
+      </p:grpSpPr>
+      <p:sp>
+        <p:nvSpPr>
+          <p:cNvPr id="2" name="Slide Image Placeholder 1"/>
+          <p:cNvSpPr>
+            <a:spLocks noGrp="1" noRot="1" noChangeAspect="1"/>
+          </p:cNvSpPr>
+          <p:nvPr>
+            <p:ph type="sldImg"/>
+          </p:nvPr>
+        </p:nvSpPr>
+        <p:spPr/>
+      </p:sp>
+      <p:sp>
+        <p:nvSpPr>
+          <p:cNvPr id="3" name="Notes Placeholder 2"/>
+          <p:cNvSpPr>
+            <a:spLocks noGrp="1"/>
+          </p:cNvSpPr>
+          <p:nvPr>
+            <p:ph type="body" idx="1"/>
+          </p:nvPr>
+        </p:nvSpPr>
+        <p:spPr/>
+        <p:txBody>
+          <a:bodyPr/>
+          <a:lstStyle/>
+          <a:p>
+            <a:r>
+              <a:rPr lang="en-US" dirty="0"/>
+              <a:t>Three checks so far. A typhoon at 984 millibars read 120 and 180 meters, class 4, comparable to what Hart published for hurricanes. For Typhoon Dujuan, the hour our class dropped below 4 matched the hour FSU's page showed the same GFS run moving from deep to shallow warm core. And a deep North Atlantic low classified cold core, which the vorticity shortcut could not do. Greenland and the Rockies come out blank rather than contaminated. Compute cost is about a second per frame on the full global grid.</a:t>
+            </a:r>
+            <a:endParaRPr lang="en-US" dirty="0"/>
+          </a:p>
+        </p:txBody>
+      </p:sp>
+      <p:sp>
+        <p:nvSpPr>
+          <p:cNvPr id="4" name="Slide Number Placeholder 3"/>
+          <p:cNvSpPr>
+            <a:spLocks noGrp="1"/>
+          </p:cNvSpPr>
+          <p:nvPr>
+            <p:ph type="sldNum" sz="quarter" idx="10"/>
+          </p:nvPr>
+        </p:nvSpPr>
+        <p:spPr/>
+        <p:txBody>
+          <a:bodyPr/>
+          <a:lstStyle/>
+          <a:p>
+            <a:fld id="{F7021451-1387-4CA6-816F-3879F97B5CBC}" type="slidenum">
+              <a:rPr lang="en-US"/>
+              <a:t>9</a:t>
             </a:fld>
             <a:endParaRPr lang="en-US"/>
           </a:p>
@@ -1561,6 +1829,396 @@
 </p:sld>
 </file>
 
+<file path=ppt/slides/slide10.xml><?xml version="1.0" encoding="utf-8"?>
+<p:sld xmlns:a="http://schemas.openxmlformats.org/drawingml/2006/main" xmlns:r="http://schemas.openxmlformats.org/officeDocument/2006/relationships" xmlns:p="http://schemas.openxmlformats.org/presentationml/2006/main">
+  <p:cSld name="Slide 10">
+    <p:bg>
+      <p:bgPr>
+        <a:solidFill>
+          <a:srgbClr val="0F2A44"/>
+        </a:solidFill>
+      </p:bgPr>
+    </p:bg>
+    <p:spTree>
+      <p:nvGrpSpPr>
+        <p:cNvPr id="1" name=""/>
+        <p:cNvGrpSpPr/>
+        <p:nvPr/>
+      </p:nvGrpSpPr>
+      <p:grpSpPr>
+        <a:xfrm>
+          <a:off x="0" y="0"/>
+          <a:ext cx="0" cy="0"/>
+          <a:chOff x="0" y="0"/>
+          <a:chExt cx="0" cy="0"/>
+        </a:xfrm>
+      </p:grpSpPr>
+      <p:sp>
+        <p:nvSpPr>
+          <p:cNvPr id="2" name="Text 0"/>
+          <p:cNvSpPr txBox="1"/>
+          <p:nvPr/>
+        </p:nvSpPr>
+        <p:spPr>
+          <a:xfrm>
+            <a:off x="457200" y="365760"/>
+            <a:ext cx="8229600" cy="548640"/>
+          </a:xfrm>
+          <a:prstGeom prst="rect">
+            <a:avLst/>
+          </a:prstGeom>
+          <a:noFill/>
+          <a:ln/>
+        </p:spPr>
+        <p:txBody>
+          <a:bodyPr wrap="square" lIns="0" tIns="0" rIns="0" bIns="0" rtlCol="0" anchor="t"/>
+          <a:lstStyle/>
+          <a:p>
+            <a:pPr algn="l" indent="0" marL="0">
+              <a:buNone/>
+            </a:pPr>
+            <a:r>
+              <a:rPr lang="en-US" sz="3600" b="1" dirty="0">
+                <a:solidFill>
+                  <a:srgbClr val="FFFFFF"/>
+                </a:solidFill>
+                <a:latin typeface="Cambria" pitchFamily="34" charset="0"/>
+                <a:ea typeface="Cambria" pitchFamily="34" charset="-122"/>
+                <a:cs typeface="Cambria" pitchFamily="34" charset="-120"/>
+              </a:rPr>
+              <a:t>Limits and next</a:t>
+            </a:r>
+            <a:endParaRPr lang="en-US" sz="3600" dirty="0"/>
+          </a:p>
+        </p:txBody>
+      </p:sp>
+      <p:sp>
+        <p:nvSpPr>
+          <p:cNvPr id="3" name="Text 1"/>
+          <p:cNvSpPr txBox="1"/>
+          <p:nvPr/>
+        </p:nvSpPr>
+        <p:spPr>
+          <a:xfrm>
+            <a:off x="457200" y="1188720"/>
+            <a:ext cx="3931920" cy="411480"/>
+          </a:xfrm>
+          <a:prstGeom prst="rect">
+            <a:avLst/>
+          </a:prstGeom>
+          <a:noFill/>
+          <a:ln/>
+        </p:spPr>
+        <p:txBody>
+          <a:bodyPr wrap="square" lIns="0" tIns="0" rIns="0" bIns="0" rtlCol="0" anchor="t"/>
+          <a:lstStyle/>
+          <a:p>
+            <a:pPr algn="l" indent="0" marL="0">
+              <a:buNone/>
+            </a:pPr>
+            <a:r>
+              <a:rPr lang="en-US" sz="2000" b="1" dirty="0">
+                <a:solidFill>
+                  <a:srgbClr val="FFFFFF"/>
+                </a:solidFill>
+                <a:latin typeface="Cambria" pitchFamily="34" charset="0"/>
+                <a:ea typeface="Cambria" pitchFamily="34" charset="-122"/>
+                <a:cs typeface="Cambria" pitchFamily="34" charset="-120"/>
+              </a:rPr>
+              <a:t>Limits</a:t>
+            </a:r>
+            <a:endParaRPr lang="en-US" sz="2000" dirty="0"/>
+          </a:p>
+        </p:txBody>
+      </p:sp>
+      <p:sp>
+        <p:nvSpPr>
+          <p:cNvPr id="4" name="Text 2"/>
+          <p:cNvSpPr txBox="1"/>
+          <p:nvPr/>
+        </p:nvSpPr>
+        <p:spPr>
+          <a:xfrm>
+            <a:off x="457200" y="1691640"/>
+            <a:ext cx="3931920" cy="2377440"/>
+          </a:xfrm>
+          <a:prstGeom prst="rect">
+            <a:avLst/>
+          </a:prstGeom>
+          <a:noFill/>
+          <a:ln/>
+        </p:spPr>
+        <p:txBody>
+          <a:bodyPr wrap="square" lIns="0" tIns="0" rIns="0" bIns="0" rtlCol="0" anchor="t"/>
+          <a:lstStyle/>
+          <a:p>
+            <a:pPr algn="l" marL="342900" indent="-342900">
+              <a:spcAft>
+                <a:spcPts val="1000"/>
+              </a:spcAft>
+              <a:buSzPct val="100000"/>
+              <a:buChar char="•"/>
+            </a:pPr>
+            <a:r>
+              <a:rPr lang="en-US" sz="1600" dirty="0">
+                <a:solidFill>
+                  <a:srgbClr val="FFFFFF"/>
+                </a:solidFill>
+                <a:latin typeface="Calibri" pitchFamily="34" charset="0"/>
+                <a:ea typeface="Calibri" pitchFamily="34" charset="-122"/>
+                <a:cs typeface="Calibri" pitchFamily="34" charset="-120"/>
+              </a:rPr>
+              <a:t>Standard levels, not Hart's 50 hPa spacing</a:t>
+            </a:r>
+            <a:endParaRPr lang="en-US" sz="1600" dirty="0"/>
+          </a:p>
+          <a:p>
+            <a:pPr algn="l" marL="342900" indent="-342900">
+              <a:spcAft>
+                <a:spcPts val="1000"/>
+              </a:spcAft>
+              <a:buSzPct val="100000"/>
+              <a:buChar char="•"/>
+            </a:pPr>
+            <a:r>
+              <a:rPr lang="en-US" sz="1600" dirty="0">
+                <a:solidFill>
+                  <a:srgbClr val="FFFFFF"/>
+                </a:solidFill>
+                <a:latin typeface="Calibri" pitchFamily="34" charset="0"/>
+                <a:ea typeface="Calibri" pitchFamily="34" charset="-122"/>
+                <a:cs typeface="Calibri" pitchFamily="34" charset="-120"/>
+              </a:rPr>
+              <a:t>Square window: small cold bias on strong gradients</a:t>
+            </a:r>
+            <a:endParaRPr lang="en-US" sz="1600" dirty="0"/>
+          </a:p>
+          <a:p>
+            <a:pPr algn="l" marL="342900" indent="-342900">
+              <a:spcAft>
+                <a:spcPts val="1000"/>
+              </a:spcAft>
+              <a:buSzPct val="100000"/>
+              <a:buChar char="•"/>
+            </a:pPr>
+            <a:r>
+              <a:rPr lang="en-US" sz="1600" dirty="0">
+                <a:solidFill>
+                  <a:srgbClr val="FFFFFF"/>
+                </a:solidFill>
+                <a:latin typeface="Calibri" pitchFamily="34" charset="0"/>
+                <a:ea typeface="Calibri" pitchFamily="34" charset="-122"/>
+                <a:cs typeface="Calibri" pitchFamily="34" charset="-120"/>
+              </a:rPr>
+              <a:t>B and transition onset implemented, not yet validated</a:t>
+            </a:r>
+            <a:endParaRPr lang="en-US" sz="1600" dirty="0"/>
+          </a:p>
+          <a:p>
+            <a:pPr algn="l" marL="342900" indent="-342900">
+              <a:buSzPct val="100000"/>
+              <a:buChar char="•"/>
+            </a:pPr>
+            <a:r>
+              <a:rPr lang="en-US" sz="1600" dirty="0">
+                <a:solidFill>
+                  <a:srgbClr val="FFFFFF"/>
+                </a:solidFill>
+                <a:latin typeface="Calibri" pitchFamily="34" charset="0"/>
+                <a:ea typeface="Calibri" pitchFamily="34" charset="-122"/>
+                <a:cs typeface="Calibri" pitchFamily="34" charset="-120"/>
+              </a:rPr>
+              <a:t>Three cases, not a season</a:t>
+            </a:r>
+            <a:endParaRPr lang="en-US" sz="1600" dirty="0"/>
+          </a:p>
+        </p:txBody>
+      </p:sp>
+      <p:sp>
+        <p:nvSpPr>
+          <p:cNvPr id="5" name="Text 3"/>
+          <p:cNvSpPr txBox="1"/>
+          <p:nvPr/>
+        </p:nvSpPr>
+        <p:spPr>
+          <a:xfrm>
+            <a:off x="4754880" y="1188720"/>
+            <a:ext cx="3931920" cy="411480"/>
+          </a:xfrm>
+          <a:prstGeom prst="rect">
+            <a:avLst/>
+          </a:prstGeom>
+          <a:noFill/>
+          <a:ln/>
+        </p:spPr>
+        <p:txBody>
+          <a:bodyPr wrap="square" lIns="0" tIns="0" rIns="0" bIns="0" rtlCol="0" anchor="t"/>
+          <a:lstStyle/>
+          <a:p>
+            <a:pPr algn="l" indent="0" marL="0">
+              <a:buNone/>
+            </a:pPr>
+            <a:r>
+              <a:rPr lang="en-US" sz="2000" b="1" dirty="0">
+                <a:solidFill>
+                  <a:srgbClr val="FFFFFF"/>
+                </a:solidFill>
+                <a:latin typeface="Cambria" pitchFamily="34" charset="0"/>
+                <a:ea typeface="Cambria" pitchFamily="34" charset="-122"/>
+                <a:cs typeface="Cambria" pitchFamily="34" charset="-120"/>
+              </a:rPr>
+              <a:t>Next</a:t>
+            </a:r>
+            <a:endParaRPr lang="en-US" sz="2000" dirty="0"/>
+          </a:p>
+        </p:txBody>
+      </p:sp>
+      <p:sp>
+        <p:nvSpPr>
+          <p:cNvPr id="6" name="Text 4"/>
+          <p:cNvSpPr txBox="1"/>
+          <p:nvPr/>
+        </p:nvSpPr>
+        <p:spPr>
+          <a:xfrm>
+            <a:off x="4754880" y="1691640"/>
+            <a:ext cx="3931920" cy="2377440"/>
+          </a:xfrm>
+          <a:prstGeom prst="rect">
+            <a:avLst/>
+          </a:prstGeom>
+          <a:noFill/>
+          <a:ln/>
+        </p:spPr>
+        <p:txBody>
+          <a:bodyPr wrap="square" lIns="0" tIns="0" rIns="0" bIns="0" rtlCol="0" anchor="t"/>
+          <a:lstStyle/>
+          <a:p>
+            <a:pPr algn="l" marL="342900" indent="-342900">
+              <a:spcAft>
+                <a:spcPts val="1000"/>
+              </a:spcAft>
+              <a:buSzPct val="100000"/>
+              <a:buChar char="•"/>
+            </a:pPr>
+            <a:r>
+              <a:rPr lang="en-US" sz="1600" dirty="0">
+                <a:solidFill>
+                  <a:srgbClr val="FFFFFF"/>
+                </a:solidFill>
+                <a:latin typeface="Calibri" pitchFamily="34" charset="0"/>
+                <a:ea typeface="Calibri" pitchFamily="34" charset="-122"/>
+                <a:cs typeface="Calibri" pitchFamily="34" charset="-120"/>
+              </a:rPr>
+              <a:t>A season of operational use</a:t>
+            </a:r>
+            <a:endParaRPr lang="en-US" sz="1600" dirty="0"/>
+          </a:p>
+          <a:p>
+            <a:pPr algn="l" marL="342900" indent="-342900">
+              <a:spcAft>
+                <a:spcPts val="1000"/>
+              </a:spcAft>
+              <a:buSzPct val="100000"/>
+              <a:buChar char="•"/>
+            </a:pPr>
+            <a:r>
+              <a:rPr lang="en-US" sz="1600" dirty="0">
+                <a:solidFill>
+                  <a:srgbClr val="FFFFFF"/>
+                </a:solidFill>
+                <a:latin typeface="Calibri" pitchFamily="34" charset="0"/>
+                <a:ea typeface="Calibri" pitchFamily="34" charset="-122"/>
+                <a:cs typeface="Calibri" pitchFamily="34" charset="-120"/>
+              </a:rPr>
+              <a:t>Model comparison of transition timing</a:t>
+            </a:r>
+            <a:endParaRPr lang="en-US" sz="1600" dirty="0"/>
+          </a:p>
+          <a:p>
+            <a:pPr algn="l" marL="342900" indent="-342900">
+              <a:buSzPct val="100000"/>
+              <a:buChar char="•"/>
+            </a:pPr>
+            <a:r>
+              <a:rPr lang="en-US" sz="1600" dirty="0">
+                <a:solidFill>
+                  <a:srgbClr val="FFFFFF"/>
+                </a:solidFill>
+                <a:latin typeface="Calibri" pitchFamily="34" charset="0"/>
+                <a:ea typeface="Calibri" pitchFamily="34" charset="-122"/>
+                <a:cs typeface="Calibri" pitchFamily="34" charset="-120"/>
+              </a:rPr>
+              <a:t>Storm-centered diagram inside GFE</a:t>
+            </a:r>
+            <a:endParaRPr lang="en-US" sz="1600" dirty="0"/>
+          </a:p>
+        </p:txBody>
+      </p:sp>
+      <p:sp>
+        <p:nvSpPr>
+          <p:cNvPr id="7" name="Text 5"/>
+          <p:cNvSpPr txBox="1"/>
+          <p:nvPr/>
+        </p:nvSpPr>
+        <p:spPr>
+          <a:xfrm>
+            <a:off x="457200" y="4434840"/>
+            <a:ext cx="8229600" cy="548640"/>
+          </a:xfrm>
+          <a:prstGeom prst="rect">
+            <a:avLst/>
+          </a:prstGeom>
+          <a:noFill/>
+          <a:ln/>
+        </p:spPr>
+        <p:txBody>
+          <a:bodyPr wrap="square" lIns="0" tIns="0" rIns="0" bIns="0" rtlCol="0" anchor="t"/>
+          <a:lstStyle/>
+          <a:p>
+            <a:pPr algn="l" indent="0" marL="0">
+              <a:buNone/>
+            </a:pPr>
+            <a:r>
+              <a:rPr lang="en-US" sz="1500" dirty="0">
+                <a:solidFill>
+                  <a:srgbClr val="CADCFC"/>
+                </a:solidFill>
+                <a:latin typeface="Calibri" pitchFamily="34" charset="0"/>
+                <a:ea typeface="Calibri" pitchFamily="34" charset="-122"/>
+                <a:cs typeface="Calibri" pitchFamily="34" charset="-120"/>
+              </a:rPr>
+              <a:t>github.com/jkrek17/awips-tools, directory D2D</a:t>
+            </a:r>
+            <a:endParaRPr lang="en-US" sz="1500" dirty="0"/>
+          </a:p>
+          <a:p>
+            <a:pPr algn="l" indent="0" marL="0">
+              <a:buNone/>
+            </a:pPr>
+            <a:r>
+              <a:rPr lang="en-US" sz="1500" dirty="0">
+                <a:solidFill>
+                  <a:srgbClr val="CADCFC"/>
+                </a:solidFill>
+                <a:latin typeface="Calibri" pitchFamily="34" charset="0"/>
+                <a:ea typeface="Calibri" pitchFamily="34" charset="-122"/>
+                <a:cs typeface="Calibri" pitchFamily="34" charset="-120"/>
+              </a:rPr>
+              <a:t>Questions</a:t>
+            </a:r>
+            <a:endParaRPr lang="en-US" sz="1500" dirty="0"/>
+          </a:p>
+        </p:txBody>
+      </p:sp>
+    </p:spTree>
+  </p:cSld>
+  <p:clrMapOvr>
+    <a:masterClrMapping/>
+  </p:clrMapOvr>
+</p:sld>
+</file>
+
 <file path=ppt/slides/slide2.xml><?xml version="1.0" encoding="utf-8"?>
 <p:sld xmlns:a="http://schemas.openxmlformats.org/drawingml/2006/main" xmlns:r="http://schemas.openxmlformats.org/officeDocument/2006/relationships" xmlns:p="http://schemas.openxmlformats.org/presentationml/2006/main">
   <p:cSld name="Slide 2">
@@ -1626,7 +2284,7 @@
       </p:sp>
       <p:pic>
         <p:nvPicPr>
-          <p:cNvPr id="3" name="Image 0" descr="/home/user/awips-tools/docs/cps/figures/fig1_phase_space.png">    </p:cNvPr>
+          <p:cNvPr id="3" name="Image 0" descr="/home/user/awips-tools/docs/cps/figures/fig10_two_diagrams.png">    </p:cNvPr>
           <p:cNvPicPr>
             <a:picLocks noChangeAspect="1"/>
           </p:cNvPicPr>
@@ -1640,8 +2298,8 @@
         </p:blipFill>
         <p:spPr>
           <a:xfrm>
-            <a:off x="3931920" y="937590"/>
-            <a:ext cx="4754880" cy="3382620"/>
+            <a:off x="3931920" y="1418754"/>
+            <a:ext cx="4754880" cy="2420292"/>
           </a:xfrm>
           <a:prstGeom prst="rect">
             <a:avLst/>
@@ -1656,8 +2314,8 @@
         </p:nvSpPr>
         <p:spPr>
           <a:xfrm>
-            <a:off x="457200" y="937590"/>
-            <a:ext cx="3200400" cy="2194560"/>
+            <a:off x="457200" y="1418754"/>
+            <a:ext cx="3200400" cy="2743200"/>
           </a:xfrm>
           <a:prstGeom prst="rect">
             <a:avLst/>
@@ -1671,13 +2329,13 @@
           <a:p>
             <a:pPr algn="l" marL="342900" indent="-342900">
               <a:spcAft>
-                <a:spcPts val="1000"/>
+                <a:spcPts val="1200"/>
               </a:spcAft>
               <a:buSzPct val="100000"/>
               <a:buChar char="•"/>
             </a:pPr>
             <a:r>
-              <a:rPr lang="en-US" sz="1600" dirty="0">
+              <a:rPr lang="en-US" sz="1700" dirty="0">
                 <a:solidFill>
                   <a:srgbClr val="0B0B0B"/>
                 </a:solidFill>
@@ -1685,20 +2343,20 @@
                 <a:ea typeface="Calibri" pitchFamily="34" charset="-122"/>
                 <a:cs typeface="Calibri" pitchFamily="34" charset="-120"/>
               </a:rPr>
-              <a:t>Lower thermal wind: warm or cold core, 925 to 700 hPa</a:t>
-            </a:r>
-            <a:endParaRPr lang="en-US" sz="1600" dirty="0"/>
+              <a:t>Two thermal wind terms: is the core warm or cold, lower and upper troposphere</a:t>
+            </a:r>
+            <a:endParaRPr lang="en-US" sz="1700" dirty="0"/>
           </a:p>
           <a:p>
             <a:pPr algn="l" marL="342900" indent="-342900">
               <a:spcAft>
-                <a:spcPts val="1000"/>
+                <a:spcPts val="1200"/>
               </a:spcAft>
               <a:buSzPct val="100000"/>
               <a:buChar char="•"/>
             </a:pPr>
             <a:r>
-              <a:rPr lang="en-US" sz="1600" dirty="0">
+              <a:rPr lang="en-US" sz="1700" dirty="0">
                 <a:solidFill>
                   <a:srgbClr val="0B0B0B"/>
                 </a:solidFill>
@@ -1706,9 +2364,9 @@
                 <a:ea typeface="Calibri" pitchFamily="34" charset="-122"/>
                 <a:cs typeface="Calibri" pitchFamily="34" charset="-120"/>
               </a:rPr>
-              <a:t>Upper thermal wind: warm or cold core, 500 to 300 hPa</a:t>
-            </a:r>
-            <a:endParaRPr lang="en-US" sz="1600" dirty="0"/>
+              <a:t>B: is the storm frontal</a:t>
+            </a:r>
+            <a:endParaRPr lang="en-US" sz="1700" dirty="0"/>
           </a:p>
           <a:p>
             <a:pPr algn="l" marL="342900" indent="-342900">
@@ -1716,7 +2374,7 @@
               <a:buChar char="•"/>
             </a:pPr>
             <a:r>
-              <a:rPr lang="en-US" sz="1600" dirty="0">
+              <a:rPr lang="en-US" sz="1700" dirty="0">
                 <a:solidFill>
                   <a:srgbClr val="0B0B0B"/>
                 </a:solidFill>
@@ -1724,54 +2382,15 @@
                 <a:ea typeface="Calibri" pitchFamily="34" charset="-122"/>
                 <a:cs typeface="Calibri" pitchFamily="34" charset="-120"/>
               </a:rPr>
-              <a:t>B: temperature contrast across the track (frontal or not)</a:t>
-            </a:r>
-            <a:endParaRPr lang="en-US" sz="1600" dirty="0"/>
+              <a:t>All three from the height field inside a 500 km circle</a:t>
+            </a:r>
+            <a:endParaRPr lang="en-US" sz="1700" dirty="0"/>
           </a:p>
         </p:txBody>
       </p:sp>
       <p:sp>
         <p:nvSpPr>
           <p:cNvPr id="5" name="Text 2"/>
-          <p:cNvSpPr txBox="1"/>
-          <p:nvPr/>
-        </p:nvSpPr>
-        <p:spPr>
-          <a:xfrm>
-            <a:off x="457200" y="3360750"/>
-            <a:ext cx="3200400" cy="1005840"/>
-          </a:xfrm>
-          <a:prstGeom prst="rect">
-            <a:avLst/>
-          </a:prstGeom>
-          <a:noFill/>
-          <a:ln/>
-        </p:spPr>
-        <p:txBody>
-          <a:bodyPr wrap="square" lIns="0" tIns="0" rIns="0" bIns="0" rtlCol="0" anchor="t"/>
-          <a:lstStyle/>
-          <a:p>
-            <a:pPr algn="l" indent="0" marL="0">
-              <a:buNone/>
-            </a:pPr>
-            <a:r>
-              <a:rPr lang="en-US" sz="1400" i="1" dirty="0">
-                <a:solidFill>
-                  <a:srgbClr val="52514E"/>
-                </a:solidFill>
-                <a:latin typeface="Calibri" pitchFamily="34" charset="0"/>
-                <a:ea typeface="Calibri" pitchFamily="34" charset="-122"/>
-                <a:cs typeface="Calibri" pitchFamily="34" charset="-120"/>
-              </a:rPr>
-              <a:t>Transition = the path from deep warm core to cold core. That is when the wind field expands.</a:t>
-            </a:r>
-            <a:endParaRPr lang="en-US" sz="1400" dirty="0"/>
-          </a:p>
-        </p:txBody>
-      </p:sp>
-      <p:sp>
-        <p:nvSpPr>
-          <p:cNvPr id="6" name="Text 3"/>
           <p:cNvSpPr txBox="1"/>
           <p:nvPr/>
         </p:nvSpPr>
@@ -1810,7 +2429,7 @@
       </p:sp>
       <p:sp>
         <p:nvSpPr>
-          <p:cNvPr id="7" name="Text 4"/>
+          <p:cNvPr id="6" name="Text 3"/>
           <p:cNvSpPr txBox="1"/>
           <p:nvPr/>
         </p:nvSpPr>
@@ -1887,8 +2506,8 @@
         </p:nvSpPr>
         <p:spPr>
           <a:xfrm>
-            <a:off x="457200" y="274320"/>
-            <a:ext cx="8229600" cy="502920"/>
+            <a:off x="457200" y="228600"/>
+            <a:ext cx="8229600" cy="411480"/>
           </a:xfrm>
           <a:prstGeom prst="rect">
             <a:avLst/>
@@ -1904,7 +2523,7 @@
               <a:buNone/>
             </a:pPr>
             <a:r>
-              <a:rPr lang="en-US" sz="3600" b="1" dirty="0">
+              <a:rPr lang="en-US" sz="3400" b="1" dirty="0">
                 <a:solidFill>
                   <a:srgbClr val="0B0B0B"/>
                 </a:solidFill>
@@ -1912,15 +2531,15 @@
                 <a:ea typeface="Cambria" pitchFamily="34" charset="-122"/>
                 <a:cs typeface="Cambria" pitchFamily="34" charset="-120"/>
               </a:rPr>
-              <a:t>What we built</a:t>
-            </a:r>
-            <a:endParaRPr lang="en-US" sz="3600" dirty="0"/>
+              <a:t>The thermal wind terms</a:t>
+            </a:r>
+            <a:endParaRPr lang="en-US" sz="3400" dirty="0"/>
           </a:p>
         </p:txBody>
       </p:sp>
       <p:pic>
         <p:nvPicPr>
-          <p:cNvPr id="3" name="Image 0" descr="/home/user/awips-tools/docs/cps/figures/fig3_gridded.png">    </p:cNvPr>
+          <p:cNvPr id="3" name="Image 0" descr="/home/user/awips-tools/docs/cps/figures/fig8_thermal_wind_concept.png">    </p:cNvPr>
           <p:cNvPicPr>
             <a:picLocks noChangeAspect="1"/>
           </p:cNvPicPr>
@@ -1934,8 +2553,8 @@
         </p:blipFill>
         <p:spPr>
           <a:xfrm>
-            <a:off x="457200" y="858260"/>
-            <a:ext cx="4572000" cy="3541281"/>
+            <a:off x="822960" y="685800"/>
+            <a:ext cx="7498080" cy="3172473"/>
           </a:xfrm>
           <a:prstGeom prst="rect">
             <a:avLst/>
@@ -1950,8 +2569,8 @@
         </p:nvSpPr>
         <p:spPr>
           <a:xfrm>
-            <a:off x="5303520" y="858260"/>
-            <a:ext cx="3383280" cy="2651760"/>
+            <a:off x="457200" y="3931425"/>
+            <a:ext cx="8229600" cy="502920"/>
           </a:xfrm>
           <a:prstGeom prst="rect">
             <a:avLst/>
@@ -1963,130 +2582,27 @@
           <a:bodyPr wrap="square" lIns="0" tIns="0" rIns="0" bIns="0" rtlCol="0" anchor="t"/>
           <a:lstStyle/>
           <a:p>
-            <a:pPr algn="l" marL="342900" indent="-342900">
-              <a:spcAft>
-                <a:spcPts val="1000"/>
-              </a:spcAft>
-              <a:buSzPct val="100000"/>
-              <a:buChar char="•"/>
-            </a:pPr>
-            <a:r>
-              <a:rPr lang="en-US" sz="1600" dirty="0">
-                <a:solidFill>
-                  <a:srgbClr val="0B0B0B"/>
-                </a:solidFill>
-                <a:latin typeface="Calibri" pitchFamily="34" charset="0"/>
-                <a:ea typeface="Calibri" pitchFamily="34" charset="-122"/>
-                <a:cs typeface="Calibri" pitchFamily="34" charset="-120"/>
-              </a:rPr>
-              <a:t>Hart's height-range regression at every grid point</a:t>
-            </a:r>
-            <a:endParaRPr lang="en-US" sz="1600" dirty="0"/>
-          </a:p>
-          <a:p>
-            <a:pPr algn="l" marL="342900" indent="-342900">
-              <a:spcAft>
-                <a:spcPts val="1000"/>
-              </a:spcAft>
-              <a:buSzPct val="100000"/>
-              <a:buChar char="•"/>
-            </a:pPr>
-            <a:r>
-              <a:rPr lang="en-US" sz="1600" dirty="0">
-                <a:solidFill>
-                  <a:srgbClr val="0B0B0B"/>
-                </a:solidFill>
-                <a:latin typeface="Calibri" pitchFamily="34" charset="0"/>
-                <a:ea typeface="Calibri" pitchFamily="34" charset="-122"/>
-                <a:cs typeface="Calibri" pitchFamily="34" charset="-120"/>
-              </a:rPr>
-              <a:t>500 km window, standard levels, surface pressure for terrain</a:t>
-            </a:r>
-            <a:endParaRPr lang="en-US" sz="1600" dirty="0"/>
-          </a:p>
-          <a:p>
-            <a:pPr algn="l" marL="342900" indent="-342900">
-              <a:spcAft>
-                <a:spcPts val="1000"/>
-              </a:spcAft>
-              <a:buSzPct val="100000"/>
-              <a:buChar char="•"/>
-            </a:pPr>
-            <a:r>
-              <a:rPr lang="en-US" sz="1600" dirty="0">
-                <a:solidFill>
-                  <a:srgbClr val="0B0B0B"/>
-                </a:solidFill>
-                <a:latin typeface="Calibri" pitchFamily="34" charset="0"/>
-                <a:ea typeface="Calibri" pitchFamily="34" charset="-122"/>
-                <a:cs typeface="Calibri" pitchFamily="34" charset="-120"/>
-              </a:rPr>
-              <a:t>Closed-low detector: only real lows get a class</a:t>
-            </a:r>
-            <a:endParaRPr lang="en-US" sz="1600" dirty="0"/>
-          </a:p>
-          <a:p>
-            <a:pPr algn="l" marL="342900" indent="-342900">
-              <a:buSzPct val="100000"/>
-              <a:buChar char="•"/>
-            </a:pPr>
-            <a:r>
-              <a:rPr lang="en-US" sz="1600" dirty="0">
-                <a:solidFill>
-                  <a:srgbClr val="0B0B0B"/>
-                </a:solidFill>
-                <a:latin typeface="Calibri" pitchFamily="34" charset="0"/>
-                <a:ea typeface="Calibri" pitchFamily="34" charset="-122"/>
-                <a:cs typeface="Calibri" pitchFamily="34" charset="-120"/>
-              </a:rPr>
-              <a:t>Every model in D2D, no tracker, no advisory</a:t>
-            </a:r>
-            <a:endParaRPr lang="en-US" sz="1600" dirty="0"/>
+            <a:pPr algn="ctr" indent="0" marL="0">
+              <a:buNone/>
+            </a:pPr>
+            <a:r>
+              <a:rPr lang="en-US" sz="1100" i="1" dirty="0">
+                <a:solidFill>
+                  <a:srgbClr val="52514E"/>
+                </a:solidFill>
+                <a:latin typeface="Calibri" pitchFamily="34" charset="0"/>
+                <a:ea typeface="Calibri" pitchFamily="34" charset="-122"/>
+                <a:cs typeface="Calibri" pitchFamily="34" charset="-120"/>
+              </a:rPr>
+              <a:t>Warm core: the height dip fills with altitude, the range shrinks, the slope is positive. Cold core: the dip deepens, the range grows, the slope is negative. Two layers separate deep warm core from shallow.</a:t>
+            </a:r>
+            <a:endParaRPr lang="en-US" sz="1100" dirty="0"/>
           </a:p>
         </p:txBody>
       </p:sp>
       <p:sp>
         <p:nvSpPr>
           <p:cNvPr id="5" name="Text 2"/>
-          <p:cNvSpPr txBox="1"/>
-          <p:nvPr/>
-        </p:nvSpPr>
-        <p:spPr>
-          <a:xfrm>
-            <a:off x="5303520" y="3647180"/>
-            <a:ext cx="3383280" cy="640080"/>
-          </a:xfrm>
-          <a:prstGeom prst="rect">
-            <a:avLst/>
-          </a:prstGeom>
-          <a:noFill/>
-          <a:ln/>
-        </p:spPr>
-        <p:txBody>
-          <a:bodyPr wrap="square" lIns="0" tIns="0" rIns="0" bIns="0" rtlCol="0" anchor="t"/>
-          <a:lstStyle/>
-          <a:p>
-            <a:pPr algn="l" indent="0" marL="0">
-              <a:buNone/>
-            </a:pPr>
-            <a:r>
-              <a:rPr lang="en-US" sz="1200" dirty="0">
-                <a:solidFill>
-                  <a:srgbClr val="52514E"/>
-                </a:solidFill>
-                <a:latin typeface="Calibri" pitchFamily="34" charset="0"/>
-                <a:ea typeface="Calibri" pitchFamily="34" charset="-122"/>
-                <a:cs typeface="Calibri" pitchFamily="34" charset="-120"/>
-              </a:rPr>
-              <a:t>Synthetic demonstration: a warm-core vortex, a tilted cold-core low, and a terrain block.</a:t>
-            </a:r>
-            <a:endParaRPr lang="en-US" sz="1200" dirty="0"/>
-          </a:p>
-        </p:txBody>
-      </p:sp>
-      <p:sp>
-        <p:nvSpPr>
-          <p:cNvPr id="6" name="Text 3"/>
           <p:cNvSpPr txBox="1"/>
           <p:nvPr/>
         </p:nvSpPr>
@@ -2125,7 +2641,7 @@
       </p:sp>
       <p:sp>
         <p:nvSpPr>
-          <p:cNvPr id="7" name="Text 4"/>
+          <p:cNvPr id="6" name="Text 3"/>
           <p:cNvSpPr txBox="1"/>
           <p:nvPr/>
         </p:nvSpPr>
@@ -2227,7 +2743,7 @@
                 <a:ea typeface="Cambria" pitchFamily="34" charset="-122"/>
                 <a:cs typeface="Cambria" pitchFamily="34" charset="-120"/>
               </a:rPr>
-              <a:t>Why not the vorticity shortcut</a:t>
+              <a:t>Parameter B, the asymmetry</a:t>
             </a:r>
             <a:endParaRPr lang="en-US" sz="3600" dirty="0"/>
           </a:p>
@@ -2235,7 +2751,7 @@
       </p:sp>
       <p:pic>
         <p:nvPicPr>
-          <p:cNvPr id="3" name="Image 0" descr="/home/user/awips-tools/docs/cps/figures/fig4_tilt.png">    </p:cNvPr>
+          <p:cNvPr id="3" name="Image 0" descr="/home/user/awips-tools/docs/cps/figures/fig9_b_concept.png">    </p:cNvPr>
           <p:cNvPicPr>
             <a:picLocks noChangeAspect="1"/>
           </p:cNvPicPr>
@@ -2249,8 +2765,8 @@
         </p:blipFill>
         <p:spPr>
           <a:xfrm>
-            <a:off x="5553670" y="891540"/>
-            <a:ext cx="3133130" cy="3474720"/>
+            <a:off x="457200" y="1406005"/>
+            <a:ext cx="5120640" cy="2445789"/>
           </a:xfrm>
           <a:prstGeom prst="rect">
             <a:avLst/>
@@ -2265,8 +2781,8 @@
         </p:nvSpPr>
         <p:spPr>
           <a:xfrm>
-            <a:off x="457200" y="891540"/>
-            <a:ext cx="4822150" cy="1005840"/>
+            <a:off x="5852160" y="914400"/>
+            <a:ext cx="2834640" cy="2468880"/>
           </a:xfrm>
           <a:prstGeom prst="rect">
             <a:avLst/>
@@ -2278,202 +2794,109 @@
           <a:bodyPr wrap="square" lIns="0" tIns="0" rIns="0" bIns="0" rtlCol="0" anchor="t"/>
           <a:lstStyle/>
           <a:p>
+            <a:pPr algn="l" marL="342900" indent="-342900">
+              <a:spcAft>
+                <a:spcPts val="1000"/>
+              </a:spcAft>
+              <a:buSzPct val="100000"/>
+              <a:buChar char="•"/>
+            </a:pPr>
+            <a:r>
+              <a:rPr lang="en-US" sz="1500" dirty="0">
+                <a:solidFill>
+                  <a:srgbClr val="0B0B0B"/>
+                </a:solidFill>
+                <a:latin typeface="Calibri" pitchFamily="34" charset="0"/>
+                <a:ea typeface="Calibri" pitchFamily="34" charset="-122"/>
+                <a:cs typeface="Calibri" pitchFamily="34" charset="-120"/>
+              </a:rPr>
+              <a:t>Thickness is the layer's mean temperature</a:t>
+            </a:r>
+            <a:endParaRPr lang="en-US" sz="1500" dirty="0"/>
+          </a:p>
+          <a:p>
+            <a:pPr algn="l" marL="342900" indent="-342900">
+              <a:spcAft>
+                <a:spcPts val="1000"/>
+              </a:spcAft>
+              <a:buSzPct val="100000"/>
+              <a:buChar char="•"/>
+            </a:pPr>
+            <a:r>
+              <a:rPr lang="en-US" sz="1500" dirty="0">
+                <a:solidFill>
+                  <a:srgbClr val="0B0B0B"/>
+                </a:solidFill>
+                <a:latin typeface="Calibri" pitchFamily="34" charset="0"/>
+                <a:ea typeface="Calibri" pitchFamily="34" charset="-122"/>
+                <a:cs typeface="Calibri" pitchFamily="34" charset="-120"/>
+              </a:rPr>
+              <a:t>Split the 500 km circle left and right of the motion, subtract</a:t>
+            </a:r>
+            <a:endParaRPr lang="en-US" sz="1500" dirty="0"/>
+          </a:p>
+          <a:p>
+            <a:pPr algn="l" marL="342900" indent="-342900">
+              <a:buSzPct val="100000"/>
+              <a:buChar char="•"/>
+            </a:pPr>
+            <a:r>
+              <a:rPr lang="en-US" sz="1500" dirty="0">
+                <a:solidFill>
+                  <a:srgbClr val="0B0B0B"/>
+                </a:solidFill>
+                <a:latin typeface="Calibri" pitchFamily="34" charset="0"/>
+                <a:ea typeface="Calibri" pitchFamily="34" charset="-122"/>
+                <a:cs typeface="Calibri" pitchFamily="34" charset="-120"/>
+              </a:rPr>
+              <a:t>Symmetric storm: B near 0. Storm in a front: B large. Threshold 10 m</a:t>
+            </a:r>
+            <a:endParaRPr lang="en-US" sz="1500" dirty="0"/>
+          </a:p>
+        </p:txBody>
+      </p:sp>
+      <p:sp>
+        <p:nvSpPr>
+          <p:cNvPr id="5" name="Text 2"/>
+          <p:cNvSpPr txBox="1"/>
+          <p:nvPr/>
+        </p:nvSpPr>
+        <p:spPr>
+          <a:xfrm>
+            <a:off x="5852160" y="3520440"/>
+            <a:ext cx="2834640" cy="914400"/>
+          </a:xfrm>
+          <a:prstGeom prst="rect">
+            <a:avLst/>
+          </a:prstGeom>
+          <a:noFill/>
+          <a:ln/>
+        </p:spPr>
+        <p:txBody>
+          <a:bodyPr wrap="square" lIns="0" tIns="0" rIns="0" bIns="0" rtlCol="0" anchor="t"/>
+          <a:lstStyle/>
+          <a:p>
             <a:pPr algn="l" indent="0" marL="0">
               <a:buNone/>
             </a:pPr>
             <a:r>
-              <a:rPr lang="en-US" sz="1600" dirty="0">
-                <a:solidFill>
-                  <a:srgbClr val="0B0B0B"/>
-                </a:solidFill>
-                <a:latin typeface="Calibri" pitchFamily="34" charset="0"/>
-                <a:ea typeface="Calibri" pitchFamily="34" charset="-122"/>
-                <a:cs typeface="Calibri" pitchFamily="34" charset="-120"/>
-              </a:rPr>
-              <a:t>A tilted low puts its upper trough west of the surface center. Vorticity differencing reads near zero or warm at the center and shows the cold signal as a dipole to the west.</a:t>
-            </a:r>
-            <a:endParaRPr lang="en-US" sz="1600" dirty="0"/>
-          </a:p>
-        </p:txBody>
-      </p:sp>
-      <p:sp>
-        <p:nvSpPr>
-          <p:cNvPr id="5" name="Text 2"/>
-          <p:cNvSpPr txBox="1"/>
-          <p:nvPr/>
-        </p:nvSpPr>
-        <p:spPr>
-          <a:xfrm>
-            <a:off x="457200" y="2034540"/>
-            <a:ext cx="4822150" cy="640080"/>
-          </a:xfrm>
-          <a:prstGeom prst="rect">
-            <a:avLst/>
-          </a:prstGeom>
-          <a:noFill/>
-          <a:ln/>
-        </p:spPr>
-        <p:txBody>
-          <a:bodyPr wrap="square" lIns="0" tIns="0" rIns="0" bIns="0" rtlCol="0" anchor="t"/>
-          <a:lstStyle/>
-          <a:p>
-            <a:pPr algn="l" indent="0" marL="0">
-              <a:buNone/>
-            </a:pPr>
-            <a:r>
-              <a:rPr lang="en-US" sz="1600" dirty="0">
-                <a:solidFill>
-                  <a:srgbClr val="0B0B0B"/>
-                </a:solidFill>
-                <a:latin typeface="Calibri" pitchFamily="34" charset="0"/>
-                <a:ea typeface="Calibri" pitchFamily="34" charset="-122"/>
-                <a:cs typeface="Calibri" pitchFamily="34" charset="-120"/>
-              </a:rPr>
-              <a:t>Hart's 500 km window spans the tilt and reads cold at the center.</a:t>
-            </a:r>
-            <a:endParaRPr lang="en-US" sz="1600" dirty="0"/>
-          </a:p>
-        </p:txBody>
-      </p:sp>
-      <p:sp>
-        <p:nvSpPr>
-          <p:cNvPr id="6" name="Shape 3"/>
-          <p:cNvSpPr/>
-          <p:nvPr/>
-        </p:nvSpPr>
-        <p:spPr>
-          <a:xfrm>
-            <a:off x="457200" y="2857500"/>
-            <a:ext cx="2273915" cy="1005840"/>
-          </a:xfrm>
-          <a:prstGeom prst="roundRect">
-            <a:avLst>
-              <a:gd name="adj" fmla="val 7273"/>
-            </a:avLst>
-          </a:prstGeom>
-          <a:solidFill>
-            <a:srgbClr val="F0EFEC"/>
-          </a:solidFill>
-          <a:ln/>
-        </p:spPr>
-      </p:sp>
-      <p:sp>
-        <p:nvSpPr>
-          <p:cNvPr id="7" name="Text 4"/>
-          <p:cNvSpPr txBox="1"/>
-          <p:nvPr/>
-        </p:nvSpPr>
-        <p:spPr>
-          <a:xfrm>
-            <a:off x="594360" y="2857500"/>
-            <a:ext cx="1999595" cy="1005840"/>
-          </a:xfrm>
-          <a:prstGeom prst="rect">
-            <a:avLst/>
-          </a:prstGeom>
-          <a:noFill/>
-          <a:ln/>
-        </p:spPr>
-        <p:txBody>
-          <a:bodyPr wrap="square" lIns="0" tIns="0" rIns="0" bIns="0" rtlCol="0" anchor="ctr"/>
-          <a:lstStyle/>
-          <a:p>
-            <a:pPr algn="l" indent="0" marL="0">
-              <a:buNone/>
-            </a:pPr>
-            <a:r>
-              <a:rPr lang="en-US" sz="1400" dirty="0">
-                <a:solidFill>
-                  <a:srgbClr val="0B0B0B"/>
-                </a:solidFill>
-                <a:latin typeface="Calibri" pitchFamily="34" charset="0"/>
-                <a:ea typeface="Calibri" pitchFamily="34" charset="-122"/>
-                <a:cs typeface="Calibri" pitchFamily="34" charset="-120"/>
-              </a:rPr>
-              <a:t>Vorticity proxy at center: about 0</a:t>
-            </a:r>
-            <a:endParaRPr lang="en-US" sz="1400" dirty="0"/>
-          </a:p>
-        </p:txBody>
-      </p:sp>
-      <p:sp>
-        <p:nvSpPr>
-          <p:cNvPr id="8" name="Shape 5"/>
-          <p:cNvSpPr/>
-          <p:nvPr/>
-        </p:nvSpPr>
-        <p:spPr>
-          <a:xfrm>
-            <a:off x="3005435" y="2857500"/>
-            <a:ext cx="2273915" cy="1005840"/>
-          </a:xfrm>
-          <a:prstGeom prst="roundRect">
-            <a:avLst>
-              <a:gd name="adj" fmla="val 7273"/>
-            </a:avLst>
-          </a:prstGeom>
-          <a:solidFill>
-            <a:srgbClr val="F0EFEC"/>
-          </a:solidFill>
-          <a:ln/>
-        </p:spPr>
-      </p:sp>
-      <p:sp>
-        <p:nvSpPr>
-          <p:cNvPr id="9" name="Text 6"/>
-          <p:cNvSpPr txBox="1"/>
-          <p:nvPr/>
-        </p:nvSpPr>
-        <p:spPr>
-          <a:xfrm>
-            <a:off x="3142595" y="2857500"/>
-            <a:ext cx="1999595" cy="1005840"/>
-          </a:xfrm>
-          <a:prstGeom prst="rect">
-            <a:avLst/>
-          </a:prstGeom>
-          <a:noFill/>
-          <a:ln/>
-        </p:spPr>
-        <p:txBody>
-          <a:bodyPr wrap="square" lIns="0" tIns="0" rIns="0" bIns="0" rtlCol="0" anchor="ctr"/>
-          <a:lstStyle/>
-          <a:p>
-            <a:pPr algn="l" indent="0" marL="0">
-              <a:buNone/>
-            </a:pPr>
-            <a:r>
-              <a:rPr lang="en-US" sz="1400" dirty="0">
-                <a:solidFill>
-                  <a:srgbClr val="0B0B0B"/>
-                </a:solidFill>
-                <a:latin typeface="Calibri" pitchFamily="34" charset="0"/>
-                <a:ea typeface="Calibri" pitchFamily="34" charset="-122"/>
-                <a:cs typeface="Calibri" pitchFamily="34" charset="-120"/>
-              </a:rPr>
-              <a:t>Hart field at center: </a:t>
-            </a:r>
-            <a:pPr algn="l" indent="0" marL="0">
-              <a:buNone/>
-            </a:pPr>
-            <a:r>
-              <a:rPr lang="en-US" sz="1400" b="1" dirty="0">
-                <a:solidFill>
-                  <a:srgbClr val="2A78D6"/>
-                </a:solidFill>
-                <a:latin typeface="Calibri" pitchFamily="34" charset="0"/>
-                <a:ea typeface="Calibri" pitchFamily="34" charset="-122"/>
-                <a:cs typeface="Calibri" pitchFamily="34" charset="-120"/>
-              </a:rPr>
-              <a:t>minus 285 m</a:t>
-            </a:r>
-            <a:endParaRPr lang="en-US" sz="1400" dirty="0"/>
-          </a:p>
-        </p:txBody>
-      </p:sp>
-      <p:sp>
-        <p:nvSpPr>
-          <p:cNvPr id="10" name="Text 7"/>
+              <a:rPr lang="en-US" sz="1200" dirty="0">
+                <a:solidFill>
+                  <a:srgbClr val="52514E"/>
+                </a:solidFill>
+                <a:latin typeface="Calibri" pitchFamily="34" charset="0"/>
+                <a:ea typeface="Calibri" pitchFamily="34" charset="-122"/>
+                <a:cs typeface="Calibri" pitchFamily="34" charset="-120"/>
+              </a:rPr>
+              <a:t>Evans and Hart (2003): onset when B passes 10 m, completion when the lower term turns negative.</a:t>
+            </a:r>
+            <a:endParaRPr lang="en-US" sz="1200" dirty="0"/>
+          </a:p>
+        </p:txBody>
+      </p:sp>
+      <p:sp>
+        <p:nvSpPr>
+          <p:cNvPr id="6" name="Text 3"/>
           <p:cNvSpPr txBox="1"/>
           <p:nvPr/>
         </p:nvSpPr>
@@ -2512,7 +2935,7 @@
       </p:sp>
       <p:sp>
         <p:nvSpPr>
-          <p:cNvPr id="11" name="Text 8"/>
+          <p:cNvPr id="7" name="Text 4"/>
           <p:cNvSpPr txBox="1"/>
           <p:nvPr/>
         </p:nvSpPr>
@@ -2589,8 +3012,8 @@
         </p:nvSpPr>
         <p:spPr>
           <a:xfrm>
-            <a:off x="457200" y="274320"/>
-            <a:ext cx="8229600" cy="502920"/>
+            <a:off x="457200" y="182880"/>
+            <a:ext cx="8229600" cy="365760"/>
           </a:xfrm>
           <a:prstGeom prst="rect">
             <a:avLst/>
@@ -2606,7 +3029,7 @@
               <a:buNone/>
             </a:pPr>
             <a:r>
-              <a:rPr lang="en-US" sz="3600" b="1" dirty="0">
+              <a:rPr lang="en-US" sz="3000" b="1" dirty="0">
                 <a:solidFill>
                   <a:srgbClr val="0B0B0B"/>
                 </a:solidFill>
@@ -2614,15 +3037,15 @@
                 <a:ea typeface="Cambria" pitchFamily="34" charset="-122"/>
                 <a:cs typeface="Cambria" pitchFamily="34" charset="-120"/>
               </a:rPr>
-              <a:t>On shift</a:t>
-            </a:r>
-            <a:endParaRPr lang="en-US" sz="3600" dirty="0"/>
+              <a:t>The two diagrams and the life cycle</a:t>
+            </a:r>
+            <a:endParaRPr lang="en-US" sz="3000" dirty="0"/>
           </a:p>
         </p:txBody>
       </p:sp>
       <p:pic>
         <p:nvPicPr>
-          <p:cNvPr id="3" name="Image 0" descr="/home/user/awips-tools/docs/cps/figures/fig6_cave_typhoon.jpg">    </p:cNvPr>
+          <p:cNvPr id="3" name="Image 0" descr="/home/user/awips-tools/docs/cps/figures/fig10_two_diagrams.png">    </p:cNvPr>
           <p:cNvPicPr>
             <a:picLocks noChangeAspect="1"/>
           </p:cNvPicPr>
@@ -2636,8 +3059,8 @@
         </p:blipFill>
         <p:spPr>
           <a:xfrm>
-            <a:off x="2066544" y="777240"/>
-            <a:ext cx="5010912" cy="2900065"/>
+            <a:off x="1234440" y="713232"/>
+            <a:ext cx="6675120" cy="3397718"/>
           </a:xfrm>
           <a:prstGeom prst="rect">
             <a:avLst/>
@@ -2652,8 +3075,8 @@
         </p:nvSpPr>
         <p:spPr>
           <a:xfrm>
-            <a:off x="457200" y="3749040"/>
-            <a:ext cx="8229600" cy="228600"/>
+            <a:off x="457200" y="4165814"/>
+            <a:ext cx="8229600" cy="320040"/>
           </a:xfrm>
           <a:prstGeom prst="rect">
             <a:avLst/>
@@ -2669,7 +3092,7 @@
               <a:buNone/>
             </a:pPr>
             <a:r>
-              <a:rPr lang="en-US" sz="1100" i="1" dirty="0">
+              <a:rPr lang="en-US" sz="1200" i="1" dirty="0">
                 <a:solidFill>
                   <a:srgbClr val="52514E"/>
                 </a:solidFill>
@@ -2677,54 +3100,15 @@
                 <a:ea typeface="Calibri" pitchFamily="34" charset="-122"/>
                 <a:cs typeface="Calibri" pitchFamily="34" charset="-120"/>
               </a:rPr>
-              <a:t>Operational CAVE display: lower term, upper term, class, index. Photograph of the live display.</a:t>
-            </a:r>
-            <a:endParaRPr lang="en-US" sz="1100" dirty="0"/>
+              <a:t>Deep warm core, then the B line, then the upper warm core goes, then the lower. Some storms hook back: warm seclusion.</a:t>
+            </a:r>
+            <a:endParaRPr lang="en-US" sz="1200" dirty="0"/>
           </a:p>
         </p:txBody>
       </p:sp>
       <p:sp>
         <p:nvSpPr>
           <p:cNvPr id="5" name="Text 2"/>
-          <p:cNvSpPr txBox="1"/>
-          <p:nvPr/>
-        </p:nvSpPr>
-        <p:spPr>
-          <a:xfrm>
-            <a:off x="457200" y="4023360"/>
-            <a:ext cx="8229600" cy="457200"/>
-          </a:xfrm>
-          <a:prstGeom prst="rect">
-            <a:avLst/>
-          </a:prstGeom>
-          <a:noFill/>
-          <a:ln/>
-        </p:spPr>
-        <p:txBody>
-          <a:bodyPr wrap="square" lIns="0" tIns="0" rIns="0" bIns="0" rtlCol="0" anchor="t"/>
-          <a:lstStyle/>
-          <a:p>
-            <a:pPr algn="l" indent="0" marL="0">
-              <a:buNone/>
-            </a:pPr>
-            <a:r>
-              <a:rPr lang="en-US" sz="1600" dirty="0">
-                <a:solidFill>
-                  <a:srgbClr val="0B0B0B"/>
-                </a:solidFill>
-                <a:latin typeface="Calibri" pitchFamily="34" charset="0"/>
-                <a:ea typeface="Calibri" pitchFamily="34" charset="-122"/>
-                <a:cs typeface="Calibri" pitchFamily="34" charset="-120"/>
-              </a:rPr>
-              <a:t>Read the class at the center: 4 deep warm, 3 shallow warm, 1 cold, blank means no closed low. Compare models on the hour the class leaves 4.</a:t>
-            </a:r>
-            <a:endParaRPr lang="en-US" sz="1600" dirty="0"/>
-          </a:p>
-        </p:txBody>
-      </p:sp>
-      <p:sp>
-        <p:nvSpPr>
-          <p:cNvPr id="6" name="Text 3"/>
           <p:cNvSpPr txBox="1"/>
           <p:nvPr/>
         </p:nvSpPr>
@@ -2763,7 +3147,7 @@
       </p:sp>
       <p:sp>
         <p:nvSpPr>
-          <p:cNvPr id="7" name="Text 4"/>
+          <p:cNvPr id="6" name="Text 3"/>
           <p:cNvSpPr txBox="1"/>
           <p:nvPr/>
         </p:nvSpPr>
@@ -2865,83 +3249,46 @@
                 <a:ea typeface="Cambria" pitchFamily="34" charset="-122"/>
                 <a:cs typeface="Cambria" pitchFamily="34" charset="-120"/>
               </a:rPr>
-              <a:t>Validation so far</a:t>
+              <a:t>What we built</a:t>
             </a:r>
             <a:endParaRPr lang="en-US" sz="3600" dirty="0"/>
           </a:p>
         </p:txBody>
       </p:sp>
-      <p:sp>
-        <p:nvSpPr>
-          <p:cNvPr id="3" name="Shape 1"/>
-          <p:cNvSpPr/>
-          <p:nvPr/>
-        </p:nvSpPr>
-        <p:spPr>
-          <a:xfrm>
-            <a:off x="457200" y="914400"/>
-            <a:ext cx="4023360" cy="1554480"/>
-          </a:xfrm>
-          <a:prstGeom prst="roundRect">
-            <a:avLst>
-              <a:gd name="adj" fmla="val 5882"/>
-            </a:avLst>
-          </a:prstGeom>
-          <a:solidFill>
-            <a:srgbClr val="F0EFEC"/>
-          </a:solidFill>
-          <a:ln/>
-        </p:spPr>
-      </p:sp>
-      <p:sp>
-        <p:nvSpPr>
-          <p:cNvPr id="4" name="Text 2"/>
-          <p:cNvSpPr txBox="1"/>
-          <p:nvPr/>
-        </p:nvSpPr>
-        <p:spPr>
-          <a:xfrm>
-            <a:off x="640080" y="1051560"/>
-            <a:ext cx="3657600" cy="548640"/>
-          </a:xfrm>
-          <a:prstGeom prst="rect">
-            <a:avLst/>
-          </a:prstGeom>
-          <a:noFill/>
-          <a:ln/>
-        </p:spPr>
-        <p:txBody>
-          <a:bodyPr wrap="square" lIns="0" tIns="0" rIns="0" bIns="0" rtlCol="0" anchor="b"/>
-          <a:lstStyle/>
-          <a:p>
-            <a:pPr algn="ctr" indent="0" marL="0">
-              <a:buNone/>
-            </a:pPr>
-            <a:r>
-              <a:rPr lang="en-US" sz="3000" b="1" dirty="0">
-                <a:solidFill>
-                  <a:srgbClr val="E34948"/>
-                </a:solidFill>
-                <a:latin typeface="Cambria" pitchFamily="34" charset="0"/>
-                <a:ea typeface="Cambria" pitchFamily="34" charset="-122"/>
-                <a:cs typeface="Cambria" pitchFamily="34" charset="-120"/>
-              </a:rPr>
-              <a:t>120 m / 180 m</a:t>
-            </a:r>
-            <a:endParaRPr lang="en-US" sz="3000" dirty="0"/>
-          </a:p>
-        </p:txBody>
-      </p:sp>
-      <p:sp>
-        <p:nvSpPr>
-          <p:cNvPr id="5" name="Text 3"/>
-          <p:cNvSpPr txBox="1"/>
-          <p:nvPr/>
-        </p:nvSpPr>
-        <p:spPr>
-          <a:xfrm>
-            <a:off x="731520" y="1691640"/>
-            <a:ext cx="3474720" cy="685800"/>
+      <p:pic>
+        <p:nvPicPr>
+          <p:cNvPr id="3" name="Image 0" descr="/home/user/awips-tools/docs/cps/figures/fig3_gridded.png">    </p:cNvPr>
+          <p:cNvPicPr>
+            <a:picLocks noChangeAspect="1"/>
+          </p:cNvPicPr>
+          <p:nvPr/>
+        </p:nvPicPr>
+        <p:blipFill>
+          <a:blip r:embed="rId1"/>
+          <a:stretch>
+            <a:fillRect/>
+          </a:stretch>
+        </p:blipFill>
+        <p:spPr>
+          <a:xfrm>
+            <a:off x="457200" y="858260"/>
+            <a:ext cx="4572000" cy="3541281"/>
+          </a:xfrm>
+          <a:prstGeom prst="rect">
+            <a:avLst/>
+          </a:prstGeom>
+        </p:spPr>
+      </p:pic>
+      <p:sp>
+        <p:nvSpPr>
+          <p:cNvPr id="4" name="Text 1"/>
+          <p:cNvSpPr txBox="1"/>
+          <p:nvPr/>
+        </p:nvSpPr>
+        <p:spPr>
+          <a:xfrm>
+            <a:off x="5303520" y="858260"/>
+            <a:ext cx="3383280" cy="2651760"/>
           </a:xfrm>
           <a:prstGeom prst="rect">
             <a:avLst/>
@@ -2953,11 +3300,114 @@
           <a:bodyPr wrap="square" lIns="0" tIns="0" rIns="0" bIns="0" rtlCol="0" anchor="t"/>
           <a:lstStyle/>
           <a:p>
-            <a:pPr algn="ctr" indent="0" marL="0">
-              <a:buNone/>
-            </a:pPr>
-            <a:r>
-              <a:rPr lang="en-US" sz="1300" dirty="0">
+            <a:pPr algn="l" marL="342900" indent="-342900">
+              <a:spcAft>
+                <a:spcPts val="1000"/>
+              </a:spcAft>
+              <a:buSzPct val="100000"/>
+              <a:buChar char="•"/>
+            </a:pPr>
+            <a:r>
+              <a:rPr lang="en-US" sz="1600" dirty="0">
+                <a:solidFill>
+                  <a:srgbClr val="0B0B0B"/>
+                </a:solidFill>
+                <a:latin typeface="Calibri" pitchFamily="34" charset="0"/>
+                <a:ea typeface="Calibri" pitchFamily="34" charset="-122"/>
+                <a:cs typeface="Calibri" pitchFamily="34" charset="-120"/>
+              </a:rPr>
+              <a:t>Hart's height-range regression at every grid point</a:t>
+            </a:r>
+            <a:endParaRPr lang="en-US" sz="1600" dirty="0"/>
+          </a:p>
+          <a:p>
+            <a:pPr algn="l" marL="342900" indent="-342900">
+              <a:spcAft>
+                <a:spcPts val="1000"/>
+              </a:spcAft>
+              <a:buSzPct val="100000"/>
+              <a:buChar char="•"/>
+            </a:pPr>
+            <a:r>
+              <a:rPr lang="en-US" sz="1600" dirty="0">
+                <a:solidFill>
+                  <a:srgbClr val="0B0B0B"/>
+                </a:solidFill>
+                <a:latin typeface="Calibri" pitchFamily="34" charset="0"/>
+                <a:ea typeface="Calibri" pitchFamily="34" charset="-122"/>
+                <a:cs typeface="Calibri" pitchFamily="34" charset="-120"/>
+              </a:rPr>
+              <a:t>500 km window, standard levels, surface pressure for terrain</a:t>
+            </a:r>
+            <a:endParaRPr lang="en-US" sz="1600" dirty="0"/>
+          </a:p>
+          <a:p>
+            <a:pPr algn="l" marL="342900" indent="-342900">
+              <a:spcAft>
+                <a:spcPts val="1000"/>
+              </a:spcAft>
+              <a:buSzPct val="100000"/>
+              <a:buChar char="•"/>
+            </a:pPr>
+            <a:r>
+              <a:rPr lang="en-US" sz="1600" dirty="0">
+                <a:solidFill>
+                  <a:srgbClr val="0B0B0B"/>
+                </a:solidFill>
+                <a:latin typeface="Calibri" pitchFamily="34" charset="0"/>
+                <a:ea typeface="Calibri" pitchFamily="34" charset="-122"/>
+                <a:cs typeface="Calibri" pitchFamily="34" charset="-120"/>
+              </a:rPr>
+              <a:t>Closed-low detector: only real lows get a class</a:t>
+            </a:r>
+            <a:endParaRPr lang="en-US" sz="1600" dirty="0"/>
+          </a:p>
+          <a:p>
+            <a:pPr algn="l" marL="342900" indent="-342900">
+              <a:buSzPct val="100000"/>
+              <a:buChar char="•"/>
+            </a:pPr>
+            <a:r>
+              <a:rPr lang="en-US" sz="1600" dirty="0">
+                <a:solidFill>
+                  <a:srgbClr val="0B0B0B"/>
+                </a:solidFill>
+                <a:latin typeface="Calibri" pitchFamily="34" charset="0"/>
+                <a:ea typeface="Calibri" pitchFamily="34" charset="-122"/>
+                <a:cs typeface="Calibri" pitchFamily="34" charset="-120"/>
+              </a:rPr>
+              <a:t>Every model in D2D, no tracker, no advisory</a:t>
+            </a:r>
+            <a:endParaRPr lang="en-US" sz="1600" dirty="0"/>
+          </a:p>
+        </p:txBody>
+      </p:sp>
+      <p:sp>
+        <p:nvSpPr>
+          <p:cNvPr id="5" name="Text 2"/>
+          <p:cNvSpPr txBox="1"/>
+          <p:nvPr/>
+        </p:nvSpPr>
+        <p:spPr>
+          <a:xfrm>
+            <a:off x="5303520" y="3647180"/>
+            <a:ext cx="3383280" cy="640080"/>
+          </a:xfrm>
+          <a:prstGeom prst="rect">
+            <a:avLst/>
+          </a:prstGeom>
+          <a:noFill/>
+          <a:ln/>
+        </p:spPr>
+        <p:txBody>
+          <a:bodyPr wrap="square" lIns="0" tIns="0" rIns="0" bIns="0" rtlCol="0" anchor="t"/>
+          <a:lstStyle/>
+          <a:p>
+            <a:pPr algn="l" indent="0" marL="0">
+              <a:buNone/>
+            </a:pPr>
+            <a:r>
+              <a:rPr lang="en-US" sz="1200" dirty="0">
                 <a:solidFill>
                   <a:srgbClr val="52514E"/>
                 </a:solidFill>
@@ -2965,315 +3415,15 @@
                 <a:ea typeface="Calibri" pitchFamily="34" charset="-122"/>
                 <a:cs typeface="Calibri" pitchFamily="34" charset="-120"/>
               </a:rPr>
-              <a:t>typhoon, lower and upper term, class 4</a:t>
-            </a:r>
-            <a:endParaRPr lang="en-US" sz="1300" dirty="0"/>
-          </a:p>
-        </p:txBody>
-      </p:sp>
-      <p:sp>
-        <p:nvSpPr>
-          <p:cNvPr id="6" name="Shape 4"/>
-          <p:cNvSpPr/>
-          <p:nvPr/>
-        </p:nvSpPr>
-        <p:spPr>
-          <a:xfrm>
-            <a:off x="4709160" y="914400"/>
-            <a:ext cx="4023360" cy="1554480"/>
-          </a:xfrm>
-          <a:prstGeom prst="roundRect">
-            <a:avLst>
-              <a:gd name="adj" fmla="val 5882"/>
-            </a:avLst>
-          </a:prstGeom>
-          <a:solidFill>
-            <a:srgbClr val="F0EFEC"/>
-          </a:solidFill>
-          <a:ln/>
-        </p:spPr>
-      </p:sp>
-      <p:sp>
-        <p:nvSpPr>
-          <p:cNvPr id="7" name="Text 5"/>
-          <p:cNvSpPr txBox="1"/>
-          <p:nvPr/>
-        </p:nvSpPr>
-        <p:spPr>
-          <a:xfrm>
-            <a:off x="4892040" y="1051560"/>
-            <a:ext cx="3657600" cy="548640"/>
-          </a:xfrm>
-          <a:prstGeom prst="rect">
-            <a:avLst/>
-          </a:prstGeom>
-          <a:noFill/>
-          <a:ln/>
-        </p:spPr>
-        <p:txBody>
-          <a:bodyPr wrap="square" lIns="0" tIns="0" rIns="0" bIns="0" rtlCol="0" anchor="b"/>
-          <a:lstStyle/>
-          <a:p>
-            <a:pPr algn="ctr" indent="0" marL="0">
-              <a:buNone/>
-            </a:pPr>
-            <a:r>
-              <a:rPr lang="en-US" sz="3000" b="1" dirty="0">
-                <a:solidFill>
-                  <a:srgbClr val="0B0B0B"/>
-                </a:solidFill>
-                <a:latin typeface="Cambria" pitchFamily="34" charset="0"/>
-                <a:ea typeface="Cambria" pitchFamily="34" charset="-122"/>
-                <a:cs typeface="Cambria" pitchFamily="34" charset="-120"/>
-              </a:rPr>
-              <a:t>18Z 21 Sep</a:t>
-            </a:r>
-            <a:endParaRPr lang="en-US" sz="3000" dirty="0"/>
-          </a:p>
-        </p:txBody>
-      </p:sp>
-      <p:sp>
-        <p:nvSpPr>
-          <p:cNvPr id="8" name="Text 6"/>
-          <p:cNvSpPr txBox="1"/>
-          <p:nvPr/>
-        </p:nvSpPr>
-        <p:spPr>
-          <a:xfrm>
-            <a:off x="4983480" y="1691640"/>
-            <a:ext cx="3474720" cy="685800"/>
-          </a:xfrm>
-          <a:prstGeom prst="rect">
-            <a:avLst/>
-          </a:prstGeom>
-          <a:noFill/>
-          <a:ln/>
-        </p:spPr>
-        <p:txBody>
-          <a:bodyPr wrap="square" lIns="0" tIns="0" rIns="0" bIns="0" rtlCol="0" anchor="t"/>
-          <a:lstStyle/>
-          <a:p>
-            <a:pPr algn="ctr" indent="0" marL="0">
-              <a:buNone/>
-            </a:pPr>
-            <a:r>
-              <a:rPr lang="en-US" sz="1300" dirty="0">
-                <a:solidFill>
-                  <a:srgbClr val="52514E"/>
-                </a:solidFill>
-                <a:latin typeface="Calibri" pitchFamily="34" charset="0"/>
-                <a:ea typeface="Calibri" pitchFamily="34" charset="-122"/>
-                <a:cs typeface="Calibri" pitchFamily="34" charset="-120"/>
-              </a:rPr>
-              <a:t>Dujuan: class leaves 4 at the same hour FSU shows deep to shallow warm core</a:t>
-            </a:r>
-            <a:endParaRPr lang="en-US" sz="1300" dirty="0"/>
-          </a:p>
-        </p:txBody>
-      </p:sp>
-      <p:sp>
-        <p:nvSpPr>
-          <p:cNvPr id="9" name="Shape 7"/>
-          <p:cNvSpPr/>
-          <p:nvPr/>
-        </p:nvSpPr>
-        <p:spPr>
-          <a:xfrm>
-            <a:off x="457200" y="2697480"/>
-            <a:ext cx="4023360" cy="1554480"/>
-          </a:xfrm>
-          <a:prstGeom prst="roundRect">
-            <a:avLst>
-              <a:gd name="adj" fmla="val 5882"/>
-            </a:avLst>
-          </a:prstGeom>
-          <a:solidFill>
-            <a:srgbClr val="F0EFEC"/>
-          </a:solidFill>
-          <a:ln/>
-        </p:spPr>
-      </p:sp>
-      <p:sp>
-        <p:nvSpPr>
-          <p:cNvPr id="10" name="Text 8"/>
-          <p:cNvSpPr txBox="1"/>
-          <p:nvPr/>
-        </p:nvSpPr>
-        <p:spPr>
-          <a:xfrm>
-            <a:off x="640080" y="2834640"/>
-            <a:ext cx="3657600" cy="548640"/>
-          </a:xfrm>
-          <a:prstGeom prst="rect">
-            <a:avLst/>
-          </a:prstGeom>
-          <a:noFill/>
-          <a:ln/>
-        </p:spPr>
-        <p:txBody>
-          <a:bodyPr wrap="square" lIns="0" tIns="0" rIns="0" bIns="0" rtlCol="0" anchor="b"/>
-          <a:lstStyle/>
-          <a:p>
-            <a:pPr algn="ctr" indent="0" marL="0">
-              <a:buNone/>
-            </a:pPr>
-            <a:r>
-              <a:rPr lang="en-US" sz="3000" b="1" dirty="0">
-                <a:solidFill>
-                  <a:srgbClr val="2A78D6"/>
-                </a:solidFill>
-                <a:latin typeface="Cambria" pitchFamily="34" charset="0"/>
-                <a:ea typeface="Cambria" pitchFamily="34" charset="-122"/>
-                <a:cs typeface="Cambria" pitchFamily="34" charset="-120"/>
-              </a:rPr>
-              <a:t>Class 1</a:t>
-            </a:r>
-            <a:endParaRPr lang="en-US" sz="3000" dirty="0"/>
-          </a:p>
-        </p:txBody>
-      </p:sp>
-      <p:sp>
-        <p:nvSpPr>
-          <p:cNvPr id="11" name="Text 9"/>
-          <p:cNvSpPr txBox="1"/>
-          <p:nvPr/>
-        </p:nvSpPr>
-        <p:spPr>
-          <a:xfrm>
-            <a:off x="731520" y="3474720"/>
-            <a:ext cx="3474720" cy="685800"/>
-          </a:xfrm>
-          <a:prstGeom prst="rect">
-            <a:avLst/>
-          </a:prstGeom>
-          <a:noFill/>
-          <a:ln/>
-        </p:spPr>
-        <p:txBody>
-          <a:bodyPr wrap="square" lIns="0" tIns="0" rIns="0" bIns="0" rtlCol="0" anchor="t"/>
-          <a:lstStyle/>
-          <a:p>
-            <a:pPr algn="ctr" indent="0" marL="0">
-              <a:buNone/>
-            </a:pPr>
-            <a:r>
-              <a:rPr lang="en-US" sz="1300" dirty="0">
-                <a:solidFill>
-                  <a:srgbClr val="52514E"/>
-                </a:solidFill>
-                <a:latin typeface="Calibri" pitchFamily="34" charset="0"/>
-                <a:ea typeface="Calibri" pitchFamily="34" charset="-122"/>
-                <a:cs typeface="Calibri" pitchFamily="34" charset="-120"/>
-              </a:rPr>
-              <a:t>deep North Atlantic low reads cold core</a:t>
-            </a:r>
-            <a:endParaRPr lang="en-US" sz="1300" dirty="0"/>
-          </a:p>
-        </p:txBody>
-      </p:sp>
-      <p:sp>
-        <p:nvSpPr>
-          <p:cNvPr id="12" name="Shape 10"/>
-          <p:cNvSpPr/>
-          <p:nvPr/>
-        </p:nvSpPr>
-        <p:spPr>
-          <a:xfrm>
-            <a:off x="4709160" y="2697480"/>
-            <a:ext cx="4023360" cy="1554480"/>
-          </a:xfrm>
-          <a:prstGeom prst="roundRect">
-            <a:avLst>
-              <a:gd name="adj" fmla="val 5882"/>
-            </a:avLst>
-          </a:prstGeom>
-          <a:solidFill>
-            <a:srgbClr val="F0EFEC"/>
-          </a:solidFill>
-          <a:ln/>
-        </p:spPr>
-      </p:sp>
-      <p:sp>
-        <p:nvSpPr>
-          <p:cNvPr id="13" name="Text 11"/>
-          <p:cNvSpPr txBox="1"/>
-          <p:nvPr/>
-        </p:nvSpPr>
-        <p:spPr>
-          <a:xfrm>
-            <a:off x="4892040" y="2834640"/>
-            <a:ext cx="3657600" cy="548640"/>
-          </a:xfrm>
-          <a:prstGeom prst="rect">
-            <a:avLst/>
-          </a:prstGeom>
-          <a:noFill/>
-          <a:ln/>
-        </p:spPr>
-        <p:txBody>
-          <a:bodyPr wrap="square" lIns="0" tIns="0" rIns="0" bIns="0" rtlCol="0" anchor="b"/>
-          <a:lstStyle/>
-          <a:p>
-            <a:pPr algn="ctr" indent="0" marL="0">
-              <a:buNone/>
-            </a:pPr>
-            <a:r>
-              <a:rPr lang="en-US" sz="3000" b="1" dirty="0">
-                <a:solidFill>
-                  <a:srgbClr val="0B0B0B"/>
-                </a:solidFill>
-                <a:latin typeface="Cambria" pitchFamily="34" charset="0"/>
-                <a:ea typeface="Cambria" pitchFamily="34" charset="-122"/>
-                <a:cs typeface="Cambria" pitchFamily="34" charset="-120"/>
-              </a:rPr>
-              <a:t>about 1.5 s</a:t>
-            </a:r>
-            <a:endParaRPr lang="en-US" sz="3000" dirty="0"/>
-          </a:p>
-        </p:txBody>
-      </p:sp>
-      <p:sp>
-        <p:nvSpPr>
-          <p:cNvPr id="14" name="Text 12"/>
-          <p:cNvSpPr txBox="1"/>
-          <p:nvPr/>
-        </p:nvSpPr>
-        <p:spPr>
-          <a:xfrm>
-            <a:off x="4983480" y="3474720"/>
-            <a:ext cx="3474720" cy="685800"/>
-          </a:xfrm>
-          <a:prstGeom prst="rect">
-            <a:avLst/>
-          </a:prstGeom>
-          <a:noFill/>
-          <a:ln/>
-        </p:spPr>
-        <p:txBody>
-          <a:bodyPr wrap="square" lIns="0" tIns="0" rIns="0" bIns="0" rtlCol="0" anchor="t"/>
-          <a:lstStyle/>
-          <a:p>
-            <a:pPr algn="ctr" indent="0" marL="0">
-              <a:buNone/>
-            </a:pPr>
-            <a:r>
-              <a:rPr lang="en-US" sz="1300" dirty="0">
-                <a:solidFill>
-                  <a:srgbClr val="52514E"/>
-                </a:solidFill>
-                <a:latin typeface="Calibri" pitchFamily="34" charset="0"/>
-                <a:ea typeface="Calibri" pitchFamily="34" charset="-122"/>
-                <a:cs typeface="Calibri" pitchFamily="34" charset="-120"/>
-              </a:rPr>
-              <a:t>per frame, full 0.25 degree global grid</a:t>
-            </a:r>
-            <a:endParaRPr lang="en-US" sz="1300" dirty="0"/>
-          </a:p>
-        </p:txBody>
-      </p:sp>
-      <p:sp>
-        <p:nvSpPr>
-          <p:cNvPr id="15" name="Text 13"/>
+              <a:t>Synthetic demonstration: a warm-core vortex, a tilted cold-core low, and a terrain block.</a:t>
+            </a:r>
+            <a:endParaRPr lang="en-US" sz="1200" dirty="0"/>
+          </a:p>
+        </p:txBody>
+      </p:sp>
+      <p:sp>
+        <p:nvSpPr>
+          <p:cNvPr id="6" name="Text 3"/>
           <p:cNvSpPr txBox="1"/>
           <p:nvPr/>
         </p:nvSpPr>
@@ -3312,7 +3462,7 @@
       </p:sp>
       <p:sp>
         <p:nvSpPr>
-          <p:cNvPr id="16" name="Text 14"/>
+          <p:cNvPr id="7" name="Text 4"/>
           <p:cNvSpPr txBox="1"/>
           <p:nvPr/>
         </p:nvSpPr>
@@ -3363,7 +3513,7 @@
     <p:bg>
       <p:bgPr>
         <a:solidFill>
-          <a:srgbClr val="0F2A44"/>
+          <a:srgbClr val="FFFFFF"/>
         </a:solidFill>
       </p:bgPr>
     </p:bg>
@@ -3389,8 +3539,8 @@
         </p:nvSpPr>
         <p:spPr>
           <a:xfrm>
-            <a:off x="457200" y="365760"/>
-            <a:ext cx="8229600" cy="548640"/>
+            <a:off x="457200" y="274320"/>
+            <a:ext cx="8229600" cy="502920"/>
           </a:xfrm>
           <a:prstGeom prst="rect">
             <a:avLst/>
@@ -3408,28 +3558,52 @@
             <a:r>
               <a:rPr lang="en-US" sz="3600" b="1" dirty="0">
                 <a:solidFill>
-                  <a:srgbClr val="FFFFFF"/>
+                  <a:srgbClr val="0B0B0B"/>
                 </a:solidFill>
                 <a:latin typeface="Cambria" pitchFamily="34" charset="0"/>
                 <a:ea typeface="Cambria" pitchFamily="34" charset="-122"/>
                 <a:cs typeface="Cambria" pitchFamily="34" charset="-120"/>
               </a:rPr>
-              <a:t>Limits and next</a:t>
+              <a:t>Why not the vorticity shortcut</a:t>
             </a:r>
             <a:endParaRPr lang="en-US" sz="3600" dirty="0"/>
           </a:p>
         </p:txBody>
       </p:sp>
-      <p:sp>
-        <p:nvSpPr>
-          <p:cNvPr id="3" name="Text 1"/>
-          <p:cNvSpPr txBox="1"/>
-          <p:nvPr/>
-        </p:nvSpPr>
-        <p:spPr>
-          <a:xfrm>
-            <a:off x="457200" y="1188720"/>
-            <a:ext cx="3931920" cy="411480"/>
+      <p:pic>
+        <p:nvPicPr>
+          <p:cNvPr id="3" name="Image 0" descr="/home/user/awips-tools/docs/cps/figures/fig4_tilt.png">    </p:cNvPr>
+          <p:cNvPicPr>
+            <a:picLocks noChangeAspect="1"/>
+          </p:cNvPicPr>
+          <p:nvPr/>
+        </p:nvPicPr>
+        <p:blipFill>
+          <a:blip r:embed="rId1"/>
+          <a:stretch>
+            <a:fillRect/>
+          </a:stretch>
+        </p:blipFill>
+        <p:spPr>
+          <a:xfrm>
+            <a:off x="5553670" y="891540"/>
+            <a:ext cx="3133130" cy="3474720"/>
+          </a:xfrm>
+          <a:prstGeom prst="rect">
+            <a:avLst/>
+          </a:prstGeom>
+        </p:spPr>
+      </p:pic>
+      <p:sp>
+        <p:nvSpPr>
+          <p:cNvPr id="4" name="Text 1"/>
+          <p:cNvSpPr txBox="1"/>
+          <p:nvPr/>
+        </p:nvSpPr>
+        <p:spPr>
+          <a:xfrm>
+            <a:off x="457200" y="891540"/>
+            <a:ext cx="4822150" cy="1005840"/>
           </a:xfrm>
           <a:prstGeom prst="rect">
             <a:avLst/>
@@ -3445,30 +3619,378 @@
               <a:buNone/>
             </a:pPr>
             <a:r>
-              <a:rPr lang="en-US" sz="2000" b="1" dirty="0">
-                <a:solidFill>
-                  <a:srgbClr val="FFFFFF"/>
+              <a:rPr lang="en-US" sz="1600" dirty="0">
+                <a:solidFill>
+                  <a:srgbClr val="0B0B0B"/>
+                </a:solidFill>
+                <a:latin typeface="Calibri" pitchFamily="34" charset="0"/>
+                <a:ea typeface="Calibri" pitchFamily="34" charset="-122"/>
+                <a:cs typeface="Calibri" pitchFamily="34" charset="-120"/>
+              </a:rPr>
+              <a:t>A tilted low puts its upper trough west of the surface center. Vorticity differencing reads near zero or warm at the center and shows the cold signal as a dipole to the west.</a:t>
+            </a:r>
+            <a:endParaRPr lang="en-US" sz="1600" dirty="0"/>
+          </a:p>
+        </p:txBody>
+      </p:sp>
+      <p:sp>
+        <p:nvSpPr>
+          <p:cNvPr id="5" name="Text 2"/>
+          <p:cNvSpPr txBox="1"/>
+          <p:nvPr/>
+        </p:nvSpPr>
+        <p:spPr>
+          <a:xfrm>
+            <a:off x="457200" y="2034540"/>
+            <a:ext cx="4822150" cy="640080"/>
+          </a:xfrm>
+          <a:prstGeom prst="rect">
+            <a:avLst/>
+          </a:prstGeom>
+          <a:noFill/>
+          <a:ln/>
+        </p:spPr>
+        <p:txBody>
+          <a:bodyPr wrap="square" lIns="0" tIns="0" rIns="0" bIns="0" rtlCol="0" anchor="t"/>
+          <a:lstStyle/>
+          <a:p>
+            <a:pPr algn="l" indent="0" marL="0">
+              <a:buNone/>
+            </a:pPr>
+            <a:r>
+              <a:rPr lang="en-US" sz="1600" dirty="0">
+                <a:solidFill>
+                  <a:srgbClr val="0B0B0B"/>
+                </a:solidFill>
+                <a:latin typeface="Calibri" pitchFamily="34" charset="0"/>
+                <a:ea typeface="Calibri" pitchFamily="34" charset="-122"/>
+                <a:cs typeface="Calibri" pitchFamily="34" charset="-120"/>
+              </a:rPr>
+              <a:t>Hart's 500 km window spans the tilt and reads cold at the center.</a:t>
+            </a:r>
+            <a:endParaRPr lang="en-US" sz="1600" dirty="0"/>
+          </a:p>
+        </p:txBody>
+      </p:sp>
+      <p:sp>
+        <p:nvSpPr>
+          <p:cNvPr id="6" name="Shape 3"/>
+          <p:cNvSpPr/>
+          <p:nvPr/>
+        </p:nvSpPr>
+        <p:spPr>
+          <a:xfrm>
+            <a:off x="457200" y="2857500"/>
+            <a:ext cx="2273915" cy="1005840"/>
+          </a:xfrm>
+          <a:prstGeom prst="roundRect">
+            <a:avLst>
+              <a:gd name="adj" fmla="val 7273"/>
+            </a:avLst>
+          </a:prstGeom>
+          <a:solidFill>
+            <a:srgbClr val="F0EFEC"/>
+          </a:solidFill>
+          <a:ln/>
+        </p:spPr>
+      </p:sp>
+      <p:sp>
+        <p:nvSpPr>
+          <p:cNvPr id="7" name="Text 4"/>
+          <p:cNvSpPr txBox="1"/>
+          <p:nvPr/>
+        </p:nvSpPr>
+        <p:spPr>
+          <a:xfrm>
+            <a:off x="594360" y="2857500"/>
+            <a:ext cx="1999595" cy="1005840"/>
+          </a:xfrm>
+          <a:prstGeom prst="rect">
+            <a:avLst/>
+          </a:prstGeom>
+          <a:noFill/>
+          <a:ln/>
+        </p:spPr>
+        <p:txBody>
+          <a:bodyPr wrap="square" lIns="0" tIns="0" rIns="0" bIns="0" rtlCol="0" anchor="ctr"/>
+          <a:lstStyle/>
+          <a:p>
+            <a:pPr algn="l" indent="0" marL="0">
+              <a:buNone/>
+            </a:pPr>
+            <a:r>
+              <a:rPr lang="en-US" sz="1400" dirty="0">
+                <a:solidFill>
+                  <a:srgbClr val="0B0B0B"/>
+                </a:solidFill>
+                <a:latin typeface="Calibri" pitchFamily="34" charset="0"/>
+                <a:ea typeface="Calibri" pitchFamily="34" charset="-122"/>
+                <a:cs typeface="Calibri" pitchFamily="34" charset="-120"/>
+              </a:rPr>
+              <a:t>Vorticity proxy at center: about 0</a:t>
+            </a:r>
+            <a:endParaRPr lang="en-US" sz="1400" dirty="0"/>
+          </a:p>
+        </p:txBody>
+      </p:sp>
+      <p:sp>
+        <p:nvSpPr>
+          <p:cNvPr id="8" name="Shape 5"/>
+          <p:cNvSpPr/>
+          <p:nvPr/>
+        </p:nvSpPr>
+        <p:spPr>
+          <a:xfrm>
+            <a:off x="3005435" y="2857500"/>
+            <a:ext cx="2273915" cy="1005840"/>
+          </a:xfrm>
+          <a:prstGeom prst="roundRect">
+            <a:avLst>
+              <a:gd name="adj" fmla="val 7273"/>
+            </a:avLst>
+          </a:prstGeom>
+          <a:solidFill>
+            <a:srgbClr val="F0EFEC"/>
+          </a:solidFill>
+          <a:ln/>
+        </p:spPr>
+      </p:sp>
+      <p:sp>
+        <p:nvSpPr>
+          <p:cNvPr id="9" name="Text 6"/>
+          <p:cNvSpPr txBox="1"/>
+          <p:nvPr/>
+        </p:nvSpPr>
+        <p:spPr>
+          <a:xfrm>
+            <a:off x="3142595" y="2857500"/>
+            <a:ext cx="1999595" cy="1005840"/>
+          </a:xfrm>
+          <a:prstGeom prst="rect">
+            <a:avLst/>
+          </a:prstGeom>
+          <a:noFill/>
+          <a:ln/>
+        </p:spPr>
+        <p:txBody>
+          <a:bodyPr wrap="square" lIns="0" tIns="0" rIns="0" bIns="0" rtlCol="0" anchor="ctr"/>
+          <a:lstStyle/>
+          <a:p>
+            <a:pPr algn="l" indent="0" marL="0">
+              <a:buNone/>
+            </a:pPr>
+            <a:r>
+              <a:rPr lang="en-US" sz="1400" dirty="0">
+                <a:solidFill>
+                  <a:srgbClr val="0B0B0B"/>
+                </a:solidFill>
+                <a:latin typeface="Calibri" pitchFamily="34" charset="0"/>
+                <a:ea typeface="Calibri" pitchFamily="34" charset="-122"/>
+                <a:cs typeface="Calibri" pitchFamily="34" charset="-120"/>
+              </a:rPr>
+              <a:t>Hart field at center: </a:t>
+            </a:r>
+            <a:pPr algn="l" indent="0" marL="0">
+              <a:buNone/>
+            </a:pPr>
+            <a:r>
+              <a:rPr lang="en-US" sz="1400" b="1" dirty="0">
+                <a:solidFill>
+                  <a:srgbClr val="2A78D6"/>
+                </a:solidFill>
+                <a:latin typeface="Calibri" pitchFamily="34" charset="0"/>
+                <a:ea typeface="Calibri" pitchFamily="34" charset="-122"/>
+                <a:cs typeface="Calibri" pitchFamily="34" charset="-120"/>
+              </a:rPr>
+              <a:t>minus 285 m</a:t>
+            </a:r>
+            <a:endParaRPr lang="en-US" sz="1400" dirty="0"/>
+          </a:p>
+        </p:txBody>
+      </p:sp>
+      <p:sp>
+        <p:nvSpPr>
+          <p:cNvPr id="10" name="Text 7"/>
+          <p:cNvSpPr txBox="1"/>
+          <p:nvPr/>
+        </p:nvSpPr>
+        <p:spPr>
+          <a:xfrm>
+            <a:off x="457200" y="4754880"/>
+            <a:ext cx="6400800" cy="274320"/>
+          </a:xfrm>
+          <a:prstGeom prst="rect">
+            <a:avLst/>
+          </a:prstGeom>
+          <a:noFill/>
+          <a:ln/>
+        </p:spPr>
+        <p:txBody>
+          <a:bodyPr wrap="square" lIns="0" tIns="0" rIns="0" bIns="0" rtlCol="0" anchor="ctr"/>
+          <a:lstStyle/>
+          <a:p>
+            <a:pPr algn="l" indent="0" marL="0">
+              <a:buNone/>
+            </a:pPr>
+            <a:r>
+              <a:rPr lang="en-US" sz="1100" dirty="0">
+                <a:solidFill>
+                  <a:srgbClr val="52514E"/>
+                </a:solidFill>
+                <a:latin typeface="Calibri" pitchFamily="34" charset="0"/>
+                <a:ea typeface="Calibri" pitchFamily="34" charset="-122"/>
+                <a:cs typeface="Calibri" pitchFamily="34" charset="-120"/>
+              </a:rPr>
+              <a:t>Cyclone Phase Space in AWIPS  |  NOAA/NWS Ocean Prediction Center</a:t>
+            </a:r>
+            <a:endParaRPr lang="en-US" sz="1100" dirty="0"/>
+          </a:p>
+        </p:txBody>
+      </p:sp>
+      <p:sp>
+        <p:nvSpPr>
+          <p:cNvPr id="11" name="Text 8"/>
+          <p:cNvSpPr txBox="1"/>
+          <p:nvPr/>
+        </p:nvSpPr>
+        <p:spPr>
+          <a:xfrm>
+            <a:off x="8229600" y="4754880"/>
+            <a:ext cx="457200" cy="274320"/>
+          </a:xfrm>
+          <a:prstGeom prst="rect">
+            <a:avLst/>
+          </a:prstGeom>
+          <a:noFill/>
+          <a:ln/>
+        </p:spPr>
+        <p:txBody>
+          <a:bodyPr wrap="square" lIns="0" tIns="0" rIns="0" bIns="0" rtlCol="0" anchor="ctr"/>
+          <a:lstStyle/>
+          <a:p>
+            <a:pPr algn="r" indent="0" marL="0">
+              <a:buNone/>
+            </a:pPr>
+            <a:r>
+              <a:rPr lang="en-US" sz="1100" dirty="0">
+                <a:solidFill>
+                  <a:srgbClr val="52514E"/>
+                </a:solidFill>
+                <a:latin typeface="Calibri" pitchFamily="34" charset="0"/>
+                <a:ea typeface="Calibri" pitchFamily="34" charset="-122"/>
+                <a:cs typeface="Calibri" pitchFamily="34" charset="-120"/>
+              </a:rPr>
+              <a:t>7</a:t>
+            </a:r>
+            <a:endParaRPr lang="en-US" sz="1100" dirty="0"/>
+          </a:p>
+        </p:txBody>
+      </p:sp>
+    </p:spTree>
+  </p:cSld>
+  <p:clrMapOvr>
+    <a:masterClrMapping/>
+  </p:clrMapOvr>
+</p:sld>
+</file>
+
+<file path=ppt/slides/slide8.xml><?xml version="1.0" encoding="utf-8"?>
+<p:sld xmlns:a="http://schemas.openxmlformats.org/drawingml/2006/main" xmlns:r="http://schemas.openxmlformats.org/officeDocument/2006/relationships" xmlns:p="http://schemas.openxmlformats.org/presentationml/2006/main">
+  <p:cSld name="Slide 8">
+    <p:bg>
+      <p:bgPr>
+        <a:solidFill>
+          <a:srgbClr val="FFFFFF"/>
+        </a:solidFill>
+      </p:bgPr>
+    </p:bg>
+    <p:spTree>
+      <p:nvGrpSpPr>
+        <p:cNvPr id="1" name=""/>
+        <p:cNvGrpSpPr/>
+        <p:nvPr/>
+      </p:nvGrpSpPr>
+      <p:grpSpPr>
+        <a:xfrm>
+          <a:off x="0" y="0"/>
+          <a:ext cx="0" cy="0"/>
+          <a:chOff x="0" y="0"/>
+          <a:chExt cx="0" cy="0"/>
+        </a:xfrm>
+      </p:grpSpPr>
+      <p:sp>
+        <p:nvSpPr>
+          <p:cNvPr id="2" name="Text 0"/>
+          <p:cNvSpPr txBox="1"/>
+          <p:nvPr/>
+        </p:nvSpPr>
+        <p:spPr>
+          <a:xfrm>
+            <a:off x="457200" y="274320"/>
+            <a:ext cx="8229600" cy="502920"/>
+          </a:xfrm>
+          <a:prstGeom prst="rect">
+            <a:avLst/>
+          </a:prstGeom>
+          <a:noFill/>
+          <a:ln/>
+        </p:spPr>
+        <p:txBody>
+          <a:bodyPr wrap="square" lIns="0" tIns="0" rIns="0" bIns="0" rtlCol="0" anchor="t"/>
+          <a:lstStyle/>
+          <a:p>
+            <a:pPr algn="l" indent="0" marL="0">
+              <a:buNone/>
+            </a:pPr>
+            <a:r>
+              <a:rPr lang="en-US" sz="3600" b="1" dirty="0">
+                <a:solidFill>
+                  <a:srgbClr val="0B0B0B"/>
                 </a:solidFill>
                 <a:latin typeface="Cambria" pitchFamily="34" charset="0"/>
                 <a:ea typeface="Cambria" pitchFamily="34" charset="-122"/>
                 <a:cs typeface="Cambria" pitchFamily="34" charset="-120"/>
               </a:rPr>
-              <a:t>Limits</a:t>
-            </a:r>
-            <a:endParaRPr lang="en-US" sz="2000" dirty="0"/>
-          </a:p>
-        </p:txBody>
-      </p:sp>
-      <p:sp>
-        <p:nvSpPr>
-          <p:cNvPr id="4" name="Text 2"/>
-          <p:cNvSpPr txBox="1"/>
-          <p:nvPr/>
-        </p:nvSpPr>
-        <p:spPr>
-          <a:xfrm>
-            <a:off x="457200" y="1691640"/>
-            <a:ext cx="3931920" cy="2377440"/>
+              <a:t>On shift</a:t>
+            </a:r>
+            <a:endParaRPr lang="en-US" sz="3600" dirty="0"/>
+          </a:p>
+        </p:txBody>
+      </p:sp>
+      <p:pic>
+        <p:nvPicPr>
+          <p:cNvPr id="3" name="Image 0" descr="/home/user/awips-tools/docs/cps/figures/fig6_cave_typhoon.jpg">    </p:cNvPr>
+          <p:cNvPicPr>
+            <a:picLocks noChangeAspect="1"/>
+          </p:cNvPicPr>
+          <p:nvPr/>
+        </p:nvPicPr>
+        <p:blipFill>
+          <a:blip r:embed="rId1"/>
+          <a:stretch>
+            <a:fillRect/>
+          </a:stretch>
+        </p:blipFill>
+        <p:spPr>
+          <a:xfrm>
+            <a:off x="2066544" y="777240"/>
+            <a:ext cx="5010912" cy="2900065"/>
+          </a:xfrm>
+          <a:prstGeom prst="rect">
+            <a:avLst/>
+          </a:prstGeom>
+        </p:spPr>
+      </p:pic>
+      <p:sp>
+        <p:nvSpPr>
+          <p:cNvPr id="4" name="Text 1"/>
+          <p:cNvSpPr txBox="1"/>
+          <p:nvPr/>
+        </p:nvSpPr>
+        <p:spPr>
+          <a:xfrm>
+            <a:off x="457200" y="3749040"/>
+            <a:ext cx="8229600" cy="228600"/>
           </a:xfrm>
           <a:prstGeom prst="rect">
             <a:avLst/>
@@ -3480,98 +4002,183 @@
           <a:bodyPr wrap="square" lIns="0" tIns="0" rIns="0" bIns="0" rtlCol="0" anchor="t"/>
           <a:lstStyle/>
           <a:p>
-            <a:pPr algn="l" marL="342900" indent="-342900">
-              <a:spcAft>
-                <a:spcPts val="1000"/>
-              </a:spcAft>
-              <a:buSzPct val="100000"/>
-              <a:buChar char="•"/>
+            <a:pPr algn="ctr" indent="0" marL="0">
+              <a:buNone/>
+            </a:pPr>
+            <a:r>
+              <a:rPr lang="en-US" sz="1100" i="1" dirty="0">
+                <a:solidFill>
+                  <a:srgbClr val="52514E"/>
+                </a:solidFill>
+                <a:latin typeface="Calibri" pitchFamily="34" charset="0"/>
+                <a:ea typeface="Calibri" pitchFamily="34" charset="-122"/>
+                <a:cs typeface="Calibri" pitchFamily="34" charset="-120"/>
+              </a:rPr>
+              <a:t>Operational CAVE display: lower term, upper term, class, index. Photograph of the live display.</a:t>
+            </a:r>
+            <a:endParaRPr lang="en-US" sz="1100" dirty="0"/>
+          </a:p>
+        </p:txBody>
+      </p:sp>
+      <p:sp>
+        <p:nvSpPr>
+          <p:cNvPr id="5" name="Text 2"/>
+          <p:cNvSpPr txBox="1"/>
+          <p:nvPr/>
+        </p:nvSpPr>
+        <p:spPr>
+          <a:xfrm>
+            <a:off x="457200" y="4023360"/>
+            <a:ext cx="8229600" cy="457200"/>
+          </a:xfrm>
+          <a:prstGeom prst="rect">
+            <a:avLst/>
+          </a:prstGeom>
+          <a:noFill/>
+          <a:ln/>
+        </p:spPr>
+        <p:txBody>
+          <a:bodyPr wrap="square" lIns="0" tIns="0" rIns="0" bIns="0" rtlCol="0" anchor="t"/>
+          <a:lstStyle/>
+          <a:p>
+            <a:pPr algn="l" indent="0" marL="0">
+              <a:buNone/>
             </a:pPr>
             <a:r>
               <a:rPr lang="en-US" sz="1600" dirty="0">
                 <a:solidFill>
-                  <a:srgbClr val="FFFFFF"/>
-                </a:solidFill>
-                <a:latin typeface="Calibri" pitchFamily="34" charset="0"/>
-                <a:ea typeface="Calibri" pitchFamily="34" charset="-122"/>
-                <a:cs typeface="Calibri" pitchFamily="34" charset="-120"/>
-              </a:rPr>
-              <a:t>Standard levels, not Hart's 50 hPa spacing</a:t>
+                  <a:srgbClr val="0B0B0B"/>
+                </a:solidFill>
+                <a:latin typeface="Calibri" pitchFamily="34" charset="0"/>
+                <a:ea typeface="Calibri" pitchFamily="34" charset="-122"/>
+                <a:cs typeface="Calibri" pitchFamily="34" charset="-120"/>
+              </a:rPr>
+              <a:t>Read the class at the center: 4 deep warm, 3 shallow warm, 1 cold, blank means no closed low. Compare models on the hour the class leaves 4.</a:t>
             </a:r>
             <a:endParaRPr lang="en-US" sz="1600" dirty="0"/>
           </a:p>
-          <a:p>
-            <a:pPr algn="l" marL="342900" indent="-342900">
-              <a:spcAft>
-                <a:spcPts val="1000"/>
-              </a:spcAft>
-              <a:buSzPct val="100000"/>
-              <a:buChar char="•"/>
-            </a:pPr>
-            <a:r>
-              <a:rPr lang="en-US" sz="1600" dirty="0">
-                <a:solidFill>
-                  <a:srgbClr val="FFFFFF"/>
-                </a:solidFill>
-                <a:latin typeface="Calibri" pitchFamily="34" charset="0"/>
-                <a:ea typeface="Calibri" pitchFamily="34" charset="-122"/>
-                <a:cs typeface="Calibri" pitchFamily="34" charset="-120"/>
-              </a:rPr>
-              <a:t>Square window: small cold bias on strong gradients</a:t>
-            </a:r>
-            <a:endParaRPr lang="en-US" sz="1600" dirty="0"/>
-          </a:p>
-          <a:p>
-            <a:pPr algn="l" marL="342900" indent="-342900">
-              <a:spcAft>
-                <a:spcPts val="1000"/>
-              </a:spcAft>
-              <a:buSzPct val="100000"/>
-              <a:buChar char="•"/>
-            </a:pPr>
-            <a:r>
-              <a:rPr lang="en-US" sz="1600" dirty="0">
-                <a:solidFill>
-                  <a:srgbClr val="FFFFFF"/>
-                </a:solidFill>
-                <a:latin typeface="Calibri" pitchFamily="34" charset="0"/>
-                <a:ea typeface="Calibri" pitchFamily="34" charset="-122"/>
-                <a:cs typeface="Calibri" pitchFamily="34" charset="-120"/>
-              </a:rPr>
-              <a:t>B and transition onset implemented, not yet validated</a:t>
-            </a:r>
-            <a:endParaRPr lang="en-US" sz="1600" dirty="0"/>
-          </a:p>
-          <a:p>
-            <a:pPr algn="l" marL="342900" indent="-342900">
-              <a:buSzPct val="100000"/>
-              <a:buChar char="•"/>
-            </a:pPr>
-            <a:r>
-              <a:rPr lang="en-US" sz="1600" dirty="0">
-                <a:solidFill>
-                  <a:srgbClr val="FFFFFF"/>
-                </a:solidFill>
-                <a:latin typeface="Calibri" pitchFamily="34" charset="0"/>
-                <a:ea typeface="Calibri" pitchFamily="34" charset="-122"/>
-                <a:cs typeface="Calibri" pitchFamily="34" charset="-120"/>
-              </a:rPr>
-              <a:t>Three cases, not a season</a:t>
-            </a:r>
-            <a:endParaRPr lang="en-US" sz="1600" dirty="0"/>
-          </a:p>
-        </p:txBody>
-      </p:sp>
-      <p:sp>
-        <p:nvSpPr>
-          <p:cNvPr id="5" name="Text 3"/>
-          <p:cNvSpPr txBox="1"/>
-          <p:nvPr/>
-        </p:nvSpPr>
-        <p:spPr>
-          <a:xfrm>
-            <a:off x="4754880" y="1188720"/>
-            <a:ext cx="3931920" cy="411480"/>
+        </p:txBody>
+      </p:sp>
+      <p:sp>
+        <p:nvSpPr>
+          <p:cNvPr id="6" name="Text 3"/>
+          <p:cNvSpPr txBox="1"/>
+          <p:nvPr/>
+        </p:nvSpPr>
+        <p:spPr>
+          <a:xfrm>
+            <a:off x="457200" y="4754880"/>
+            <a:ext cx="6400800" cy="274320"/>
+          </a:xfrm>
+          <a:prstGeom prst="rect">
+            <a:avLst/>
+          </a:prstGeom>
+          <a:noFill/>
+          <a:ln/>
+        </p:spPr>
+        <p:txBody>
+          <a:bodyPr wrap="square" lIns="0" tIns="0" rIns="0" bIns="0" rtlCol="0" anchor="ctr"/>
+          <a:lstStyle/>
+          <a:p>
+            <a:pPr algn="l" indent="0" marL="0">
+              <a:buNone/>
+            </a:pPr>
+            <a:r>
+              <a:rPr lang="en-US" sz="1100" dirty="0">
+                <a:solidFill>
+                  <a:srgbClr val="52514E"/>
+                </a:solidFill>
+                <a:latin typeface="Calibri" pitchFamily="34" charset="0"/>
+                <a:ea typeface="Calibri" pitchFamily="34" charset="-122"/>
+                <a:cs typeface="Calibri" pitchFamily="34" charset="-120"/>
+              </a:rPr>
+              <a:t>Cyclone Phase Space in AWIPS  |  NOAA/NWS Ocean Prediction Center</a:t>
+            </a:r>
+            <a:endParaRPr lang="en-US" sz="1100" dirty="0"/>
+          </a:p>
+        </p:txBody>
+      </p:sp>
+      <p:sp>
+        <p:nvSpPr>
+          <p:cNvPr id="7" name="Text 4"/>
+          <p:cNvSpPr txBox="1"/>
+          <p:nvPr/>
+        </p:nvSpPr>
+        <p:spPr>
+          <a:xfrm>
+            <a:off x="8229600" y="4754880"/>
+            <a:ext cx="457200" cy="274320"/>
+          </a:xfrm>
+          <a:prstGeom prst="rect">
+            <a:avLst/>
+          </a:prstGeom>
+          <a:noFill/>
+          <a:ln/>
+        </p:spPr>
+        <p:txBody>
+          <a:bodyPr wrap="square" lIns="0" tIns="0" rIns="0" bIns="0" rtlCol="0" anchor="ctr"/>
+          <a:lstStyle/>
+          <a:p>
+            <a:pPr algn="r" indent="0" marL="0">
+              <a:buNone/>
+            </a:pPr>
+            <a:r>
+              <a:rPr lang="en-US" sz="1100" dirty="0">
+                <a:solidFill>
+                  <a:srgbClr val="52514E"/>
+                </a:solidFill>
+                <a:latin typeface="Calibri" pitchFamily="34" charset="0"/>
+                <a:ea typeface="Calibri" pitchFamily="34" charset="-122"/>
+                <a:cs typeface="Calibri" pitchFamily="34" charset="-120"/>
+              </a:rPr>
+              <a:t>8</a:t>
+            </a:r>
+            <a:endParaRPr lang="en-US" sz="1100" dirty="0"/>
+          </a:p>
+        </p:txBody>
+      </p:sp>
+    </p:spTree>
+  </p:cSld>
+  <p:clrMapOvr>
+    <a:masterClrMapping/>
+  </p:clrMapOvr>
+</p:sld>
+</file>
+
+<file path=ppt/slides/slide9.xml><?xml version="1.0" encoding="utf-8"?>
+<p:sld xmlns:a="http://schemas.openxmlformats.org/drawingml/2006/main" xmlns:r="http://schemas.openxmlformats.org/officeDocument/2006/relationships" xmlns:p="http://schemas.openxmlformats.org/presentationml/2006/main">
+  <p:cSld name="Slide 9">
+    <p:bg>
+      <p:bgPr>
+        <a:solidFill>
+          <a:srgbClr val="FFFFFF"/>
+        </a:solidFill>
+      </p:bgPr>
+    </p:bg>
+    <p:spTree>
+      <p:nvGrpSpPr>
+        <p:cNvPr id="1" name=""/>
+        <p:cNvGrpSpPr/>
+        <p:nvPr/>
+      </p:nvGrpSpPr>
+      <p:grpSpPr>
+        <a:xfrm>
+          <a:off x="0" y="0"/>
+          <a:ext cx="0" cy="0"/>
+          <a:chOff x="0" y="0"/>
+          <a:chExt cx="0" cy="0"/>
+        </a:xfrm>
+      </p:grpSpPr>
+      <p:sp>
+        <p:nvSpPr>
+          <p:cNvPr id="2" name="Text 0"/>
+          <p:cNvSpPr txBox="1"/>
+          <p:nvPr/>
+        </p:nvSpPr>
+        <p:spPr>
+          <a:xfrm>
+            <a:off x="457200" y="274320"/>
+            <a:ext cx="8229600" cy="502920"/>
           </a:xfrm>
           <a:prstGeom prst="rect">
             <a:avLst/>
@@ -3587,30 +4194,91 @@
               <a:buNone/>
             </a:pPr>
             <a:r>
-              <a:rPr lang="en-US" sz="2000" b="1" dirty="0">
-                <a:solidFill>
-                  <a:srgbClr val="FFFFFF"/>
+              <a:rPr lang="en-US" sz="3600" b="1" dirty="0">
+                <a:solidFill>
+                  <a:srgbClr val="0B0B0B"/>
                 </a:solidFill>
                 <a:latin typeface="Cambria" pitchFamily="34" charset="0"/>
                 <a:ea typeface="Cambria" pitchFamily="34" charset="-122"/>
                 <a:cs typeface="Cambria" pitchFamily="34" charset="-120"/>
               </a:rPr>
-              <a:t>Next</a:t>
-            </a:r>
-            <a:endParaRPr lang="en-US" sz="2000" dirty="0"/>
-          </a:p>
-        </p:txBody>
-      </p:sp>
-      <p:sp>
-        <p:nvSpPr>
-          <p:cNvPr id="6" name="Text 4"/>
-          <p:cNvSpPr txBox="1"/>
-          <p:nvPr/>
-        </p:nvSpPr>
-        <p:spPr>
-          <a:xfrm>
-            <a:off x="4754880" y="1691640"/>
-            <a:ext cx="3931920" cy="2377440"/>
+              <a:t>Validation so far</a:t>
+            </a:r>
+            <a:endParaRPr lang="en-US" sz="3600" dirty="0"/>
+          </a:p>
+        </p:txBody>
+      </p:sp>
+      <p:sp>
+        <p:nvSpPr>
+          <p:cNvPr id="3" name="Shape 1"/>
+          <p:cNvSpPr/>
+          <p:nvPr/>
+        </p:nvSpPr>
+        <p:spPr>
+          <a:xfrm>
+            <a:off x="457200" y="914400"/>
+            <a:ext cx="4023360" cy="1554480"/>
+          </a:xfrm>
+          <a:prstGeom prst="roundRect">
+            <a:avLst>
+              <a:gd name="adj" fmla="val 5882"/>
+            </a:avLst>
+          </a:prstGeom>
+          <a:solidFill>
+            <a:srgbClr val="F0EFEC"/>
+          </a:solidFill>
+          <a:ln/>
+        </p:spPr>
+      </p:sp>
+      <p:sp>
+        <p:nvSpPr>
+          <p:cNvPr id="4" name="Text 2"/>
+          <p:cNvSpPr txBox="1"/>
+          <p:nvPr/>
+        </p:nvSpPr>
+        <p:spPr>
+          <a:xfrm>
+            <a:off x="640080" y="1051560"/>
+            <a:ext cx="3657600" cy="548640"/>
+          </a:xfrm>
+          <a:prstGeom prst="rect">
+            <a:avLst/>
+          </a:prstGeom>
+          <a:noFill/>
+          <a:ln/>
+        </p:spPr>
+        <p:txBody>
+          <a:bodyPr wrap="square" lIns="0" tIns="0" rIns="0" bIns="0" rtlCol="0" anchor="b"/>
+          <a:lstStyle/>
+          <a:p>
+            <a:pPr algn="ctr" indent="0" marL="0">
+              <a:buNone/>
+            </a:pPr>
+            <a:r>
+              <a:rPr lang="en-US" sz="3000" b="1" dirty="0">
+                <a:solidFill>
+                  <a:srgbClr val="E34948"/>
+                </a:solidFill>
+                <a:latin typeface="Cambria" pitchFamily="34" charset="0"/>
+                <a:ea typeface="Cambria" pitchFamily="34" charset="-122"/>
+                <a:cs typeface="Cambria" pitchFamily="34" charset="-120"/>
+              </a:rPr>
+              <a:t>120 m / 180 m</a:t>
+            </a:r>
+            <a:endParaRPr lang="en-US" sz="3000" dirty="0"/>
+          </a:p>
+        </p:txBody>
+      </p:sp>
+      <p:sp>
+        <p:nvSpPr>
+          <p:cNvPr id="5" name="Text 3"/>
+          <p:cNvSpPr txBox="1"/>
+          <p:nvPr/>
+        </p:nvSpPr>
+        <p:spPr>
+          <a:xfrm>
+            <a:off x="731520" y="1691640"/>
+            <a:ext cx="3474720" cy="685800"/>
           </a:xfrm>
           <a:prstGeom prst="rect">
             <a:avLst/>
@@ -3622,66 +4290,45 @@
           <a:bodyPr wrap="square" lIns="0" tIns="0" rIns="0" bIns="0" rtlCol="0" anchor="t"/>
           <a:lstStyle/>
           <a:p>
-            <a:pPr algn="l" marL="342900" indent="-342900">
-              <a:spcAft>
-                <a:spcPts val="1000"/>
-              </a:spcAft>
-              <a:buSzPct val="100000"/>
-              <a:buChar char="•"/>
-            </a:pPr>
-            <a:r>
-              <a:rPr lang="en-US" sz="1600" dirty="0">
-                <a:solidFill>
-                  <a:srgbClr val="FFFFFF"/>
-                </a:solidFill>
-                <a:latin typeface="Calibri" pitchFamily="34" charset="0"/>
-                <a:ea typeface="Calibri" pitchFamily="34" charset="-122"/>
-                <a:cs typeface="Calibri" pitchFamily="34" charset="-120"/>
-              </a:rPr>
-              <a:t>A season of operational use</a:t>
-            </a:r>
-            <a:endParaRPr lang="en-US" sz="1600" dirty="0"/>
-          </a:p>
-          <a:p>
-            <a:pPr algn="l" marL="342900" indent="-342900">
-              <a:spcAft>
-                <a:spcPts val="1000"/>
-              </a:spcAft>
-              <a:buSzPct val="100000"/>
-              <a:buChar char="•"/>
-            </a:pPr>
-            <a:r>
-              <a:rPr lang="en-US" sz="1600" dirty="0">
-                <a:solidFill>
-                  <a:srgbClr val="FFFFFF"/>
-                </a:solidFill>
-                <a:latin typeface="Calibri" pitchFamily="34" charset="0"/>
-                <a:ea typeface="Calibri" pitchFamily="34" charset="-122"/>
-                <a:cs typeface="Calibri" pitchFamily="34" charset="-120"/>
-              </a:rPr>
-              <a:t>Model comparison of transition timing</a:t>
-            </a:r>
-            <a:endParaRPr lang="en-US" sz="1600" dirty="0"/>
-          </a:p>
-          <a:p>
-            <a:pPr algn="l" marL="342900" indent="-342900">
-              <a:buSzPct val="100000"/>
-              <a:buChar char="•"/>
-            </a:pPr>
-            <a:r>
-              <a:rPr lang="en-US" sz="1600" dirty="0">
-                <a:solidFill>
-                  <a:srgbClr val="FFFFFF"/>
-                </a:solidFill>
-                <a:latin typeface="Calibri" pitchFamily="34" charset="0"/>
-                <a:ea typeface="Calibri" pitchFamily="34" charset="-122"/>
-                <a:cs typeface="Calibri" pitchFamily="34" charset="-120"/>
-              </a:rPr>
-              <a:t>Storm-centered diagram inside GFE</a:t>
-            </a:r>
-            <a:endParaRPr lang="en-US" sz="1600" dirty="0"/>
-          </a:p>
-        </p:txBody>
+            <a:pPr algn="ctr" indent="0" marL="0">
+              <a:buNone/>
+            </a:pPr>
+            <a:r>
+              <a:rPr lang="en-US" sz="1300" dirty="0">
+                <a:solidFill>
+                  <a:srgbClr val="52514E"/>
+                </a:solidFill>
+                <a:latin typeface="Calibri" pitchFamily="34" charset="0"/>
+                <a:ea typeface="Calibri" pitchFamily="34" charset="-122"/>
+                <a:cs typeface="Calibri" pitchFamily="34" charset="-120"/>
+              </a:rPr>
+              <a:t>typhoon, lower and upper term, class 4</a:t>
+            </a:r>
+            <a:endParaRPr lang="en-US" sz="1300" dirty="0"/>
+          </a:p>
+        </p:txBody>
+      </p:sp>
+      <p:sp>
+        <p:nvSpPr>
+          <p:cNvPr id="6" name="Shape 4"/>
+          <p:cNvSpPr/>
+          <p:nvPr/>
+        </p:nvSpPr>
+        <p:spPr>
+          <a:xfrm>
+            <a:off x="4709160" y="914400"/>
+            <a:ext cx="4023360" cy="1554480"/>
+          </a:xfrm>
+          <a:prstGeom prst="roundRect">
+            <a:avLst>
+              <a:gd name="adj" fmla="val 5882"/>
+            </a:avLst>
+          </a:prstGeom>
+          <a:solidFill>
+            <a:srgbClr val="F0EFEC"/>
+          </a:solidFill>
+          <a:ln/>
+        </p:spPr>
       </p:sp>
       <p:sp>
         <p:nvSpPr>
@@ -3691,8 +4338,47 @@
         </p:nvSpPr>
         <p:spPr>
           <a:xfrm>
-            <a:off x="457200" y="4434840"/>
-            <a:ext cx="8229600" cy="548640"/>
+            <a:off x="4892040" y="1051560"/>
+            <a:ext cx="3657600" cy="548640"/>
+          </a:xfrm>
+          <a:prstGeom prst="rect">
+            <a:avLst/>
+          </a:prstGeom>
+          <a:noFill/>
+          <a:ln/>
+        </p:spPr>
+        <p:txBody>
+          <a:bodyPr wrap="square" lIns="0" tIns="0" rIns="0" bIns="0" rtlCol="0" anchor="b"/>
+          <a:lstStyle/>
+          <a:p>
+            <a:pPr algn="ctr" indent="0" marL="0">
+              <a:buNone/>
+            </a:pPr>
+            <a:r>
+              <a:rPr lang="en-US" sz="3000" b="1" dirty="0">
+                <a:solidFill>
+                  <a:srgbClr val="0B0B0B"/>
+                </a:solidFill>
+                <a:latin typeface="Cambria" pitchFamily="34" charset="0"/>
+                <a:ea typeface="Cambria" pitchFamily="34" charset="-122"/>
+                <a:cs typeface="Cambria" pitchFamily="34" charset="-120"/>
+              </a:rPr>
+              <a:t>18Z 21 Sep</a:t>
+            </a:r>
+            <a:endParaRPr lang="en-US" sz="3000" dirty="0"/>
+          </a:p>
+        </p:txBody>
+      </p:sp>
+      <p:sp>
+        <p:nvSpPr>
+          <p:cNvPr id="8" name="Text 6"/>
+          <p:cNvSpPr txBox="1"/>
+          <p:nvPr/>
+        </p:nvSpPr>
+        <p:spPr>
+          <a:xfrm>
+            <a:off x="4983480" y="1691640"/>
+            <a:ext cx="3474720" cy="685800"/>
           </a:xfrm>
           <a:prstGeom prst="rect">
             <a:avLst/>
@@ -3704,38 +4390,299 @@
           <a:bodyPr wrap="square" lIns="0" tIns="0" rIns="0" bIns="0" rtlCol="0" anchor="t"/>
           <a:lstStyle/>
           <a:p>
+            <a:pPr algn="ctr" indent="0" marL="0">
+              <a:buNone/>
+            </a:pPr>
+            <a:r>
+              <a:rPr lang="en-US" sz="1300" dirty="0">
+                <a:solidFill>
+                  <a:srgbClr val="52514E"/>
+                </a:solidFill>
+                <a:latin typeface="Calibri" pitchFamily="34" charset="0"/>
+                <a:ea typeface="Calibri" pitchFamily="34" charset="-122"/>
+                <a:cs typeface="Calibri" pitchFamily="34" charset="-120"/>
+              </a:rPr>
+              <a:t>Dujuan: class leaves 4 at the same hour FSU shows deep to shallow warm core</a:t>
+            </a:r>
+            <a:endParaRPr lang="en-US" sz="1300" dirty="0"/>
+          </a:p>
+        </p:txBody>
+      </p:sp>
+      <p:sp>
+        <p:nvSpPr>
+          <p:cNvPr id="9" name="Shape 7"/>
+          <p:cNvSpPr/>
+          <p:nvPr/>
+        </p:nvSpPr>
+        <p:spPr>
+          <a:xfrm>
+            <a:off x="457200" y="2697480"/>
+            <a:ext cx="4023360" cy="1554480"/>
+          </a:xfrm>
+          <a:prstGeom prst="roundRect">
+            <a:avLst>
+              <a:gd name="adj" fmla="val 5882"/>
+            </a:avLst>
+          </a:prstGeom>
+          <a:solidFill>
+            <a:srgbClr val="F0EFEC"/>
+          </a:solidFill>
+          <a:ln/>
+        </p:spPr>
+      </p:sp>
+      <p:sp>
+        <p:nvSpPr>
+          <p:cNvPr id="10" name="Text 8"/>
+          <p:cNvSpPr txBox="1"/>
+          <p:nvPr/>
+        </p:nvSpPr>
+        <p:spPr>
+          <a:xfrm>
+            <a:off x="640080" y="2834640"/>
+            <a:ext cx="3657600" cy="548640"/>
+          </a:xfrm>
+          <a:prstGeom prst="rect">
+            <a:avLst/>
+          </a:prstGeom>
+          <a:noFill/>
+          <a:ln/>
+        </p:spPr>
+        <p:txBody>
+          <a:bodyPr wrap="square" lIns="0" tIns="0" rIns="0" bIns="0" rtlCol="0" anchor="b"/>
+          <a:lstStyle/>
+          <a:p>
+            <a:pPr algn="ctr" indent="0" marL="0">
+              <a:buNone/>
+            </a:pPr>
+            <a:r>
+              <a:rPr lang="en-US" sz="3000" b="1" dirty="0">
+                <a:solidFill>
+                  <a:srgbClr val="2A78D6"/>
+                </a:solidFill>
+                <a:latin typeface="Cambria" pitchFamily="34" charset="0"/>
+                <a:ea typeface="Cambria" pitchFamily="34" charset="-122"/>
+                <a:cs typeface="Cambria" pitchFamily="34" charset="-120"/>
+              </a:rPr>
+              <a:t>Class 1</a:t>
+            </a:r>
+            <a:endParaRPr lang="en-US" sz="3000" dirty="0"/>
+          </a:p>
+        </p:txBody>
+      </p:sp>
+      <p:sp>
+        <p:nvSpPr>
+          <p:cNvPr id="11" name="Text 9"/>
+          <p:cNvSpPr txBox="1"/>
+          <p:nvPr/>
+        </p:nvSpPr>
+        <p:spPr>
+          <a:xfrm>
+            <a:off x="731520" y="3474720"/>
+            <a:ext cx="3474720" cy="685800"/>
+          </a:xfrm>
+          <a:prstGeom prst="rect">
+            <a:avLst/>
+          </a:prstGeom>
+          <a:noFill/>
+          <a:ln/>
+        </p:spPr>
+        <p:txBody>
+          <a:bodyPr wrap="square" lIns="0" tIns="0" rIns="0" bIns="0" rtlCol="0" anchor="t"/>
+          <a:lstStyle/>
+          <a:p>
+            <a:pPr algn="ctr" indent="0" marL="0">
+              <a:buNone/>
+            </a:pPr>
+            <a:r>
+              <a:rPr lang="en-US" sz="1300" dirty="0">
+                <a:solidFill>
+                  <a:srgbClr val="52514E"/>
+                </a:solidFill>
+                <a:latin typeface="Calibri" pitchFamily="34" charset="0"/>
+                <a:ea typeface="Calibri" pitchFamily="34" charset="-122"/>
+                <a:cs typeface="Calibri" pitchFamily="34" charset="-120"/>
+              </a:rPr>
+              <a:t>deep North Atlantic low reads cold core</a:t>
+            </a:r>
+            <a:endParaRPr lang="en-US" sz="1300" dirty="0"/>
+          </a:p>
+        </p:txBody>
+      </p:sp>
+      <p:sp>
+        <p:nvSpPr>
+          <p:cNvPr id="12" name="Shape 10"/>
+          <p:cNvSpPr/>
+          <p:nvPr/>
+        </p:nvSpPr>
+        <p:spPr>
+          <a:xfrm>
+            <a:off x="4709160" y="2697480"/>
+            <a:ext cx="4023360" cy="1554480"/>
+          </a:xfrm>
+          <a:prstGeom prst="roundRect">
+            <a:avLst>
+              <a:gd name="adj" fmla="val 5882"/>
+            </a:avLst>
+          </a:prstGeom>
+          <a:solidFill>
+            <a:srgbClr val="F0EFEC"/>
+          </a:solidFill>
+          <a:ln/>
+        </p:spPr>
+      </p:sp>
+      <p:sp>
+        <p:nvSpPr>
+          <p:cNvPr id="13" name="Text 11"/>
+          <p:cNvSpPr txBox="1"/>
+          <p:nvPr/>
+        </p:nvSpPr>
+        <p:spPr>
+          <a:xfrm>
+            <a:off x="4892040" y="2834640"/>
+            <a:ext cx="3657600" cy="548640"/>
+          </a:xfrm>
+          <a:prstGeom prst="rect">
+            <a:avLst/>
+          </a:prstGeom>
+          <a:noFill/>
+          <a:ln/>
+        </p:spPr>
+        <p:txBody>
+          <a:bodyPr wrap="square" lIns="0" tIns="0" rIns="0" bIns="0" rtlCol="0" anchor="b"/>
+          <a:lstStyle/>
+          <a:p>
+            <a:pPr algn="ctr" indent="0" marL="0">
+              <a:buNone/>
+            </a:pPr>
+            <a:r>
+              <a:rPr lang="en-US" sz="3000" b="1" dirty="0">
+                <a:solidFill>
+                  <a:srgbClr val="0B0B0B"/>
+                </a:solidFill>
+                <a:latin typeface="Cambria" pitchFamily="34" charset="0"/>
+                <a:ea typeface="Cambria" pitchFamily="34" charset="-122"/>
+                <a:cs typeface="Cambria" pitchFamily="34" charset="-120"/>
+              </a:rPr>
+              <a:t>about 1.5 s</a:t>
+            </a:r>
+            <a:endParaRPr lang="en-US" sz="3000" dirty="0"/>
+          </a:p>
+        </p:txBody>
+      </p:sp>
+      <p:sp>
+        <p:nvSpPr>
+          <p:cNvPr id="14" name="Text 12"/>
+          <p:cNvSpPr txBox="1"/>
+          <p:nvPr/>
+        </p:nvSpPr>
+        <p:spPr>
+          <a:xfrm>
+            <a:off x="4983480" y="3474720"/>
+            <a:ext cx="3474720" cy="685800"/>
+          </a:xfrm>
+          <a:prstGeom prst="rect">
+            <a:avLst/>
+          </a:prstGeom>
+          <a:noFill/>
+          <a:ln/>
+        </p:spPr>
+        <p:txBody>
+          <a:bodyPr wrap="square" lIns="0" tIns="0" rIns="0" bIns="0" rtlCol="0" anchor="t"/>
+          <a:lstStyle/>
+          <a:p>
+            <a:pPr algn="ctr" indent="0" marL="0">
+              <a:buNone/>
+            </a:pPr>
+            <a:r>
+              <a:rPr lang="en-US" sz="1300" dirty="0">
+                <a:solidFill>
+                  <a:srgbClr val="52514E"/>
+                </a:solidFill>
+                <a:latin typeface="Calibri" pitchFamily="34" charset="0"/>
+                <a:ea typeface="Calibri" pitchFamily="34" charset="-122"/>
+                <a:cs typeface="Calibri" pitchFamily="34" charset="-120"/>
+              </a:rPr>
+              <a:t>per frame, full 0.25 degree global grid</a:t>
+            </a:r>
+            <a:endParaRPr lang="en-US" sz="1300" dirty="0"/>
+          </a:p>
+        </p:txBody>
+      </p:sp>
+      <p:sp>
+        <p:nvSpPr>
+          <p:cNvPr id="15" name="Text 13"/>
+          <p:cNvSpPr txBox="1"/>
+          <p:nvPr/>
+        </p:nvSpPr>
+        <p:spPr>
+          <a:xfrm>
+            <a:off x="457200" y="4754880"/>
+            <a:ext cx="6400800" cy="274320"/>
+          </a:xfrm>
+          <a:prstGeom prst="rect">
+            <a:avLst/>
+          </a:prstGeom>
+          <a:noFill/>
+          <a:ln/>
+        </p:spPr>
+        <p:txBody>
+          <a:bodyPr wrap="square" lIns="0" tIns="0" rIns="0" bIns="0" rtlCol="0" anchor="ctr"/>
+          <a:lstStyle/>
+          <a:p>
             <a:pPr algn="l" indent="0" marL="0">
               <a:buNone/>
             </a:pPr>
             <a:r>
-              <a:rPr lang="en-US" sz="1500" dirty="0">
-                <a:solidFill>
-                  <a:srgbClr val="CADCFC"/>
-                </a:solidFill>
-                <a:latin typeface="Calibri" pitchFamily="34" charset="0"/>
-                <a:ea typeface="Calibri" pitchFamily="34" charset="-122"/>
-                <a:cs typeface="Calibri" pitchFamily="34" charset="-120"/>
-              </a:rPr>
-              <a:t>github.com/jkrek17/awips-tools, directory D2D</a:t>
-            </a:r>
-            <a:endParaRPr lang="en-US" sz="1500" dirty="0"/>
-          </a:p>
-          <a:p>
-            <a:pPr algn="l" indent="0" marL="0">
-              <a:buNone/>
-            </a:pPr>
-            <a:r>
-              <a:rPr lang="en-US" sz="1500" dirty="0">
-                <a:solidFill>
-                  <a:srgbClr val="CADCFC"/>
-                </a:solidFill>
-                <a:latin typeface="Calibri" pitchFamily="34" charset="0"/>
-                <a:ea typeface="Calibri" pitchFamily="34" charset="-122"/>
-                <a:cs typeface="Calibri" pitchFamily="34" charset="-120"/>
-              </a:rPr>
-              <a:t>Questions</a:t>
-            </a:r>
-            <a:endParaRPr lang="en-US" sz="1500" dirty="0"/>
+              <a:rPr lang="en-US" sz="1100" dirty="0">
+                <a:solidFill>
+                  <a:srgbClr val="52514E"/>
+                </a:solidFill>
+                <a:latin typeface="Calibri" pitchFamily="34" charset="0"/>
+                <a:ea typeface="Calibri" pitchFamily="34" charset="-122"/>
+                <a:cs typeface="Calibri" pitchFamily="34" charset="-120"/>
+              </a:rPr>
+              <a:t>Cyclone Phase Space in AWIPS  |  NOAA/NWS Ocean Prediction Center</a:t>
+            </a:r>
+            <a:endParaRPr lang="en-US" sz="1100" dirty="0"/>
+          </a:p>
+        </p:txBody>
+      </p:sp>
+      <p:sp>
+        <p:nvSpPr>
+          <p:cNvPr id="16" name="Text 14"/>
+          <p:cNvSpPr txBox="1"/>
+          <p:nvPr/>
+        </p:nvSpPr>
+        <p:spPr>
+          <a:xfrm>
+            <a:off x="8229600" y="4754880"/>
+            <a:ext cx="457200" cy="274320"/>
+          </a:xfrm>
+          <a:prstGeom prst="rect">
+            <a:avLst/>
+          </a:prstGeom>
+          <a:noFill/>
+          <a:ln/>
+        </p:spPr>
+        <p:txBody>
+          <a:bodyPr wrap="square" lIns="0" tIns="0" rIns="0" bIns="0" rtlCol="0" anchor="ctr"/>
+          <a:lstStyle/>
+          <a:p>
+            <a:pPr algn="r" indent="0" marL="0">
+              <a:buNone/>
+            </a:pPr>
+            <a:r>
+              <a:rPr lang="en-US" sz="1100" dirty="0">
+                <a:solidFill>
+                  <a:srgbClr val="52514E"/>
+                </a:solidFill>
+                <a:latin typeface="Calibri" pitchFamily="34" charset="0"/>
+                <a:ea typeface="Calibri" pitchFamily="34" charset="-122"/>
+                <a:cs typeface="Calibri" pitchFamily="34" charset="-120"/>
+              </a:rPr>
+              <a:t>9</a:t>
+            </a:r>
+            <a:endParaRPr lang="en-US" sz="1100" dirty="0"/>
           </a:p>
         </p:txBody>
       </p:sp>

</xml_diff>

<commit_message>
Rebuild talk deck for the joint Hart classification
Slides 6, 8 and 9 now describe HCPSclass in place of the retired core
class and ET stage fields, matching the updated user and technical guides.

Co-Authored-By: Claude Fable 5.1 <noreply@anthropic.com>
Claude-Session: https://claude.ai/code/session_019q8NWWmgCfoxLvyzmCH4VN
</commit_message>
<xml_diff>
--- a/D2D/docs/TALK.pptx
+++ b/D2D/docs/TALK.pptx
@@ -954,7 +954,7 @@
           <a:p>
             <a:r>
               <a:rPr lang="en-US" dirty="0"/>
-              <a:t>Put those together and you get Hart's two diagrams. On the left, B against the lower thermal wind: symmetric or frontal, warm or cold. On the right, lower against upper thermal wind: deep warm, shallow warm, or cold. A hurricane starts in the deep warm corner. During transition it crosses the B line first, then loses the upper warm core, then the lower one, and ends in the cold corner. Some storms then hook back toward shallow warm core: that is a warm seclusion re-forming a warm core at the surface, and those are the ones that deepen unexpectedly over cold water. For a marine center, transition is when the wind field expands, so these crossings are the forecast question.</a:t>
+              <a:t>Put those together and you get Hart's two diagrams. On the left, B against the lower thermal wind: symmetric or frontal, warm or cold. On the right, lower against upper thermal wind: deep warm, shallow warm, or cold. A hurricane starts in the deep warm corner. During transition it crosses the B line first, then loses the upper warm core, then the lower one, and ends in the cold corner. Some storms then hook back toward shallow warm core: that is a warm seclusion re-forming a warm core at the surface, and those are the ones that deepen unexpectedly over cold water. The operational product we built turns all three numbers into one, so a forecaster reads a single class instead of two diagrams. For a marine center, transition is when the wind field expands, so these crossings are the forecast question.</a:t>
             </a:r>
             <a:endParaRPr lang="en-US" dirty="0"/>
           </a:p>
@@ -1219,7 +1219,7 @@
           <a:p>
             <a:r>
               <a:rPr lang="en-US" dirty="0"/>
-              <a:t>This is the operational display. Four panels: the lower and upper terms, a category field, and an index. The category reads at the storm's center: 4 is deep warm core, 3 shallow, 1 cold, blank means no closed low. Step through the frames and the first hour the category leaves 4 is the loss of the deep warm core. Load a second model beside it and where they disagree on that hour is your transition uncertainty. That is a product nobody had before, because it needed a tracker for every model.</a:t>
+              <a:t>This is the operational display. Four panels: the lower and upper terms, a joint class field, and an index. The class reads at the storm's center, one number for one of Hart's seven named states: symmetric or frontal, deep or shallow warm core, cold core, or a rare mid-level vortex. Step through the frames on a transitioning storm and the class climbs 0, then 2, then 3, then 4; a warm seclusion runs 4 and back to 1. Load a second model beside it and compare the hour each first reaches 2 or 3, and the hour each first reaches 4 or 5; where they disagree is your transition uncertainty. That is a product nobody had before, because it needed a tracker for every model.</a:t>
             </a:r>
             <a:endParaRPr lang="en-US" dirty="0"/>
           </a:p>
@@ -1307,7 +1307,7 @@
           <a:p>
             <a:r>
               <a:rPr lang="en-US" dirty="0"/>
-              <a:t>Three checks so far. A typhoon at 984 millibars read 120 and 180 meters, class 4, comparable to what Hart published for hurricanes. For Typhoon Dujuan, the hour our class dropped below 4 matched the hour FSU's page showed the same GFS run moving from deep to shallow warm core. And a deep North Atlantic low classified cold core, which the vorticity shortcut could not do. Greenland and the Rockies come out blank rather than contaminated. Compute cost is about a second per frame on the full global grid.</a:t>
+              <a:t>Three checks so far. A typhoon at 984 millibars read 120 and 180 meters, a deep warm core (class 4 in our earlier two-field product, class 0 or 2 in the joint field depending on B), comparable to what Hart published for hurricanes. For Typhoon Dujuan, the hour the storm's classification left its deep warm core state matched the hour FSU's page showed the same GFS run moving from deep to shallow warm core. And a deep North Atlantic low classified cold core, which the vorticity shortcut could not do. Greenland and the Rockies come out blank rather than contaminated. Compute cost is about a second per frame on the full global grid.</a:t>
             </a:r>
             <a:endParaRPr lang="en-US" dirty="0"/>
           </a:p>
@@ -3271,8 +3271,8 @@
         </p:blipFill>
         <p:spPr>
           <a:xfrm>
-            <a:off x="457200" y="858260"/>
-            <a:ext cx="4572000" cy="3541281"/>
+            <a:off x="457200" y="879280"/>
+            <a:ext cx="4572000" cy="3499240"/>
           </a:xfrm>
           <a:prstGeom prst="rect">
             <a:avLst/>
@@ -3287,7 +3287,7 @@
         </p:nvSpPr>
         <p:spPr>
           <a:xfrm>
-            <a:off x="5303520" y="858260"/>
+            <a:off x="5303520" y="879280"/>
             <a:ext cx="3383280" cy="2651760"/>
           </a:xfrm>
           <a:prstGeom prst="rect">
@@ -3390,8 +3390,8 @@
         </p:nvSpPr>
         <p:spPr>
           <a:xfrm>
-            <a:off x="5303520" y="3647180"/>
-            <a:ext cx="3383280" cy="640080"/>
+            <a:off x="5303520" y="3622480"/>
+            <a:ext cx="3383280" cy="777240"/>
           </a:xfrm>
           <a:prstGeom prst="rect">
             <a:avLst/>
@@ -3415,7 +3415,7 @@
                 <a:ea typeface="Calibri" pitchFamily="34" charset="-122"/>
                 <a:cs typeface="Calibri" pitchFamily="34" charset="-120"/>
               </a:rPr>
-              <a:t>Synthetic demonstration: a warm-core vortex, a tilted cold-core low, and a terrain block.</a:t>
+              <a:t>Synthetic demonstration: a warm-core vortex, a tilted cold-core low, a terrain block, and the joint class in panel (d).</a:t>
             </a:r>
             <a:endParaRPr lang="en-US" sz="1200" dirty="0"/>
           </a:p>
@@ -4028,7 +4028,7 @@
         </p:nvSpPr>
         <p:spPr>
           <a:xfrm>
-            <a:off x="457200" y="4023360"/>
+            <a:off x="457200" y="4005072"/>
             <a:ext cx="8229600" cy="457200"/>
           </a:xfrm>
           <a:prstGeom prst="rect">
@@ -4045,7 +4045,7 @@
               <a:buNone/>
             </a:pPr>
             <a:r>
-              <a:rPr lang="en-US" sz="1600" dirty="0">
+              <a:rPr lang="en-US" sz="1400" dirty="0">
                 <a:solidFill>
                   <a:srgbClr val="0B0B0B"/>
                 </a:solidFill>
@@ -4053,9 +4053,9 @@
                 <a:ea typeface="Calibri" pitchFamily="34" charset="-122"/>
                 <a:cs typeface="Calibri" pitchFamily="34" charset="-120"/>
               </a:rPr>
-              <a:t>Read the class at the center: 4 deep warm, 3 shallow warm, 1 cold, blank means no closed low. Compare models on the hour the class leaves 4.</a:t>
-            </a:r>
-            <a:endParaRPr lang="en-US" sz="1600" dirty="0"/>
+              <a:t>Read one number at the center: 0 hurricane, 2 and 3 transition under way, 4 and 5 cold core, 1 after a warm seclusion. Compare models on the hour the class first reaches 2, and the hour it first reaches 4.</a:t>
+            </a:r>
+            <a:endParaRPr lang="en-US" sz="1400" dirty="0"/>
           </a:p>
         </p:txBody>
       </p:sp>
@@ -4302,7 +4302,7 @@
                 <a:ea typeface="Calibri" pitchFamily="34" charset="-122"/>
                 <a:cs typeface="Calibri" pitchFamily="34" charset="-120"/>
               </a:rPr>
-              <a:t>typhoon, lower and upper term, class 4</a:t>
+              <a:t>typhoon, lower and upper term, deep warm core</a:t>
             </a:r>
             <a:endParaRPr lang="en-US" sz="1300" dirty="0"/>
           </a:p>
@@ -4463,7 +4463,7 @@
                 <a:ea typeface="Cambria" pitchFamily="34" charset="-122"/>
                 <a:cs typeface="Cambria" pitchFamily="34" charset="-120"/>
               </a:rPr>
-              <a:t>Class 1</a:t>
+              <a:t>Cold core</a:t>
             </a:r>
             <a:endParaRPr lang="en-US" sz="3000" dirty="0"/>
           </a:p>

</xml_diff>

<commit_message>
Abstract, talk and deck: present the height-based method on its own terms
Co-Authored-By: Claude Fable 5.1 <noreply@anthropic.com>
Claude-Session: https://claude.ai/code/session_019q8NWWmgCfoxLvyzmCH4VN
</commit_message>
<xml_diff>
--- a/D2D/docs/TALK.pptx
+++ b/D2D/docs/TALK.pptx
@@ -1131,7 +1131,7 @@
           <a:p>
             <a:r>
               <a:rPr lang="en-US" dirty="0"/>
-              <a:t>We tried a cheaper version first, differencing vorticity between levels. It fails in a specific way worth knowing. A baroclinic low is tilted: its upper trough sits west of the surface center. At the surface low the upper vorticity is weak, so the proxy reads warm, and the cold signal shows up displaced to the west as a dipole. Hart's window spans the tilt and reads cold at the center. On a synthetic tilted low the proxy reads near zero at the center and the Hart field reads minus 285 meters.</a:t>
+              <a:t>Here is why measuring the height field directly matters, on a synthetic case. Build a cold-core cyclone whose upper trough sits well to the west of its surface center, tilted the way many real baroclinic lows are. One panel shows that geometry: the 925 and 300 hectopascal height contours, offset from each other by the tilt. The other three are what the AWIPS field actually plots for that storm: the lower and upper thermal wind terms, and the joint class. Hart's 500 kilometer window is wide enough to take in the tilted upper trough from the surface center, so both terms read strongly cold there and the class comes out cold core, right where the surface low actually sits.</a:t>
             </a:r>
             <a:endParaRPr lang="en-US" dirty="0"/>
           </a:p>
@@ -1307,7 +1307,7 @@
           <a:p>
             <a:r>
               <a:rPr lang="en-US" dirty="0"/>
-              <a:t>Three checks so far. A typhoon at 984 millibars read 120 and 180 meters, a deep warm core (class 4 in our earlier two-field product, class 0 or 2 in the joint field depending on B), comparable to what Hart published for hurricanes. For Typhoon Dujuan, the hour the storm's classification left its deep warm core state matched the hour FSU's page showed the same GFS run moving from deep to shallow warm core. And a deep North Atlantic low classified cold core, which the vorticity shortcut could not do. Greenland and the Rockies come out blank rather than contaminated. Compute cost is about a second per frame on the full global grid.</a:t>
+              <a:t>Three checks so far. A typhoon at 984 millibars read 120 and 180 meters, a deep warm core, class 0 or 2 in the joint field depending on B, comparable to what Hart published for hurricanes. For Typhoon Dujuan, the hour the storm's classification left its deep warm core state matched the hour FSU's page showed the same GFS run moving from deep to shallow warm core. And a deep North Atlantic low classified cold core. Greenland and the Rockies come out blank rather than contaminated. Compute cost is about a second per frame on the full global grid.</a:t>
             </a:r>
             <a:endParaRPr lang="en-US" dirty="0"/>
           </a:p>
@@ -3564,7 +3564,7 @@
                 <a:ea typeface="Cambria" pitchFamily="34" charset="-122"/>
                 <a:cs typeface="Cambria" pitchFamily="34" charset="-120"/>
               </a:rPr>
-              <a:t>Why not the vorticity shortcut</a:t>
+              <a:t>A tilted cold core</a:t>
             </a:r>
             <a:endParaRPr lang="en-US" sz="3600" dirty="0"/>
           </a:p>
@@ -3603,7 +3603,7 @@
         <p:spPr>
           <a:xfrm>
             <a:off x="457200" y="891540"/>
-            <a:ext cx="4822150" cy="1005840"/>
+            <a:ext cx="4822150" cy="1280160"/>
           </a:xfrm>
           <a:prstGeom prst="rect">
             <a:avLst/>
@@ -3627,7 +3627,7 @@
                 <a:ea typeface="Calibri" pitchFamily="34" charset="-122"/>
                 <a:cs typeface="Calibri" pitchFamily="34" charset="-120"/>
               </a:rPr>
-              <a:t>A tilted low puts its upper trough west of the surface center. Vorticity differencing reads near zero or warm at the center and shows the cold signal as a dipole to the west.</a:t>
+              <a:t>Synthetic cold-core low with its upper trough displaced west of the surface center: tilt geometry (925 and 300 hPa height), then HVTL, HVTU, and the joint class.</a:t>
             </a:r>
             <a:endParaRPr lang="en-US" sz="1600" dirty="0"/>
           </a:p>
@@ -3641,8 +3641,8 @@
         </p:nvSpPr>
         <p:spPr>
           <a:xfrm>
-            <a:off x="457200" y="2034540"/>
-            <a:ext cx="4822150" cy="640080"/>
+            <a:off x="457200" y="2308860"/>
+            <a:ext cx="4822150" cy="822960"/>
           </a:xfrm>
           <a:prstGeom prst="rect">
             <a:avLst/>
@@ -3666,7 +3666,7 @@
                 <a:ea typeface="Calibri" pitchFamily="34" charset="-122"/>
                 <a:cs typeface="Calibri" pitchFamily="34" charset="-120"/>
               </a:rPr>
-              <a:t>Hart's 500 km window spans the tilt and reads cold at the center.</a:t>
+              <a:t>Hart's 500 km window spans the tilt, so both thermal wind terms read cold at the surface center.</a:t>
             </a:r>
             <a:endParaRPr lang="en-US" sz="1600" dirty="0"/>
           </a:p>
@@ -3680,8 +3680,8 @@
         </p:nvSpPr>
         <p:spPr>
           <a:xfrm>
-            <a:off x="457200" y="2857500"/>
-            <a:ext cx="2273915" cy="1005840"/>
+            <a:off x="457200" y="3314700"/>
+            <a:ext cx="4822150" cy="1005840"/>
           </a:xfrm>
           <a:prstGeom prst="roundRect">
             <a:avLst>
@@ -3702,8 +3702,8 @@
         </p:nvSpPr>
         <p:spPr>
           <a:xfrm>
-            <a:off x="594360" y="2857500"/>
-            <a:ext cx="1999595" cy="1005840"/>
+            <a:off x="594360" y="3314700"/>
+            <a:ext cx="4547830" cy="1005840"/>
           </a:xfrm>
           <a:prstGeom prst="rect">
             <a:avLst/>
@@ -3727,7 +3727,35 @@
                 <a:ea typeface="Calibri" pitchFamily="34" charset="-122"/>
                 <a:cs typeface="Calibri" pitchFamily="34" charset="-120"/>
               </a:rPr>
-              <a:t>Vorticity proxy at center: about 0</a:t>
+              <a:t>Class at center: </a:t>
+            </a:r>
+            <a:pPr algn="l" indent="0" marL="0">
+              <a:buNone/>
+            </a:pPr>
+            <a:r>
+              <a:rPr lang="en-US" sz="1400" b="1" dirty="0">
+                <a:solidFill>
+                  <a:srgbClr val="2A78D6"/>
+                </a:solidFill>
+                <a:latin typeface="Calibri" pitchFamily="34" charset="0"/>
+                <a:ea typeface="Calibri" pitchFamily="34" charset="-122"/>
+                <a:cs typeface="Calibri" pitchFamily="34" charset="-120"/>
+              </a:rPr>
+              <a:t>cold core</a:t>
+            </a:r>
+            <a:pPr algn="l" indent="0" marL="0">
+              <a:buNone/>
+            </a:pPr>
+            <a:r>
+              <a:rPr lang="en-US" sz="1400" dirty="0">
+                <a:solidFill>
+                  <a:srgbClr val="0B0B0B"/>
+                </a:solidFill>
+                <a:latin typeface="Calibri" pitchFamily="34" charset="0"/>
+                <a:ea typeface="Calibri" pitchFamily="34" charset="-122"/>
+                <a:cs typeface="Calibri" pitchFamily="34" charset="-120"/>
+              </a:rPr>
+              <a:t>, not warm</a:t>
             </a:r>
             <a:endParaRPr lang="en-US" sz="1400" dirty="0"/>
           </a:p>
@@ -3735,82 +3763,7 @@
       </p:sp>
       <p:sp>
         <p:nvSpPr>
-          <p:cNvPr id="8" name="Shape 5"/>
-          <p:cNvSpPr/>
-          <p:nvPr/>
-        </p:nvSpPr>
-        <p:spPr>
-          <a:xfrm>
-            <a:off x="3005435" y="2857500"/>
-            <a:ext cx="2273915" cy="1005840"/>
-          </a:xfrm>
-          <a:prstGeom prst="roundRect">
-            <a:avLst>
-              <a:gd name="adj" fmla="val 7273"/>
-            </a:avLst>
-          </a:prstGeom>
-          <a:solidFill>
-            <a:srgbClr val="F0EFEC"/>
-          </a:solidFill>
-          <a:ln/>
-        </p:spPr>
-      </p:sp>
-      <p:sp>
-        <p:nvSpPr>
-          <p:cNvPr id="9" name="Text 6"/>
-          <p:cNvSpPr txBox="1"/>
-          <p:nvPr/>
-        </p:nvSpPr>
-        <p:spPr>
-          <a:xfrm>
-            <a:off x="3142595" y="2857500"/>
-            <a:ext cx="1999595" cy="1005840"/>
-          </a:xfrm>
-          <a:prstGeom prst="rect">
-            <a:avLst/>
-          </a:prstGeom>
-          <a:noFill/>
-          <a:ln/>
-        </p:spPr>
-        <p:txBody>
-          <a:bodyPr wrap="square" lIns="0" tIns="0" rIns="0" bIns="0" rtlCol="0" anchor="ctr"/>
-          <a:lstStyle/>
-          <a:p>
-            <a:pPr algn="l" indent="0" marL="0">
-              <a:buNone/>
-            </a:pPr>
-            <a:r>
-              <a:rPr lang="en-US" sz="1400" dirty="0">
-                <a:solidFill>
-                  <a:srgbClr val="0B0B0B"/>
-                </a:solidFill>
-                <a:latin typeface="Calibri" pitchFamily="34" charset="0"/>
-                <a:ea typeface="Calibri" pitchFamily="34" charset="-122"/>
-                <a:cs typeface="Calibri" pitchFamily="34" charset="-120"/>
-              </a:rPr>
-              <a:t>Hart field at center: </a:t>
-            </a:r>
-            <a:pPr algn="l" indent="0" marL="0">
-              <a:buNone/>
-            </a:pPr>
-            <a:r>
-              <a:rPr lang="en-US" sz="1400" b="1" dirty="0">
-                <a:solidFill>
-                  <a:srgbClr val="2A78D6"/>
-                </a:solidFill>
-                <a:latin typeface="Calibri" pitchFamily="34" charset="0"/>
-                <a:ea typeface="Calibri" pitchFamily="34" charset="-122"/>
-                <a:cs typeface="Calibri" pitchFamily="34" charset="-120"/>
-              </a:rPr>
-              <a:t>minus 285 m</a:t>
-            </a:r>
-            <a:endParaRPr lang="en-US" sz="1400" dirty="0"/>
-          </a:p>
-        </p:txBody>
-      </p:sp>
-      <p:sp>
-        <p:nvSpPr>
-          <p:cNvPr id="10" name="Text 7"/>
+          <p:cNvPr id="8" name="Text 5"/>
           <p:cNvSpPr txBox="1"/>
           <p:nvPr/>
         </p:nvSpPr>
@@ -3849,7 +3802,7 @@
       </p:sp>
       <p:sp>
         <p:nvSpPr>
-          <p:cNvPr id="11" name="Text 8"/>
+          <p:cNvPr id="9" name="Text 6"/>
           <p:cNvSpPr txBox="1"/>
           <p:nvPr/>
         </p:nvSpPr>

</xml_diff>

<commit_message>
Corrections for scientific review: FSU page characterization, class naming, 24 h smoothing difference
The Florida State page is described accurately as storm-centered
diagrams for tracker-identified cyclones rather than as tropical-only.
The joint class is described as the intersection of the quadrants of
Hart's two diagrams, not as Hart's named structures; code 6 is labeled
lower cold, upper warm. Hart's 24 h running mean is listed among the
differences from the storm-centered diagrams. Figure quadrant labels
and the talk updated to match.

Co-Authored-By: Claude Fable 5.1 <noreply@anthropic.com>
Claude-Session: https://claude.ai/code/session_019q8NWWmgCfoxLvyzmCH4VN
</commit_message>
<xml_diff>
--- a/D2D/docs/TALK.pptx
+++ b/D2D/docs/TALK.pptx
@@ -1042,7 +1042,7 @@
           <a:p>
             <a:r>
               <a:rPr lang="en-US" dirty="0"/>
-              <a:t>Until now the only operational access was FSU's web page: static plots, computed externally, for tracked tropical cyclones only. The hybrid, post-tropical, and non-tropical systems that OPC actually warns on aren't on it.
+              <a:t>Until now the operational access was the FSU cyclone phase page: storm-centered diagrams for the cyclones its tracker finds, in a fixed set of models, outside the workstation. What OPC needs is the same diagnostic inside D2D, on every model we run, for any low we point at.
 We reformulated the parameters as gridded fields and implemented them as AWIPS derived parameters. At every grid point the code evaluates the height range inside a 500 kilometer window at each level and regresses it against log pressure. That is Hart's exact quantity, everywhere instead of at one tracked center. It needs only geopotential height on standard levels, surface pressure, and winds for the motion in B, so it works on every model in D2D with no tracker and no advisory. A closed-low detector on the 1000 hPa height blanks everything that isn't a real low, and terrain is masked below ground.</a:t>
             </a:r>
             <a:endParaRPr lang="en-US" dirty="0"/>
@@ -1219,7 +1219,7 @@
           <a:p>
             <a:r>
               <a:rPr lang="en-US" dirty="0"/>
-              <a:t>This is the operational display. Four panels: the lower and upper terms, a joint class field, and an index. The class reads at the storm's center, one number for one of Hart's seven named states: symmetric or frontal, deep or shallow warm core, cold core, or a rare mid-level vortex. Step through the frames on a transitioning storm and the class climbs 0, then 2, then 3, then 4; a warm seclusion runs 4 and back to 1. Load a second model beside it and compare the hour each first reaches 2 or 3, and the hour each first reaches 4 or 5; where they disagree is your transition uncertainty. That is a product nobody had before, because it needed a tracker for every model.</a:t>
+              <a:t>This is the operational display. Four panels: the lower and upper terms, a joint class field, and an index. The class reads at the storm's center, one number for one of seven classes built from Hart's two diagrams: symmetric or frontal, deep or shallow warm core, cold core, or a rare mid-level vortex. Step through the frames on a transitioning storm and the class climbs 0, then 2, then 3, then 4; a warm seclusion runs 4 and back to 1. Load a second model beside it and compare the hour each first reaches 2 or 3, and the hour each first reaches 4 or 5; where they disagree is your transition uncertainty. That is a product nobody had before, because it needed a tracker for every model.</a:t>
             </a:r>
             <a:endParaRPr lang="en-US" dirty="0"/>
           </a:p>
@@ -4355,7 +4355,7 @@
                 <a:ea typeface="Calibri" pitchFamily="34" charset="-122"/>
                 <a:cs typeface="Calibri" pitchFamily="34" charset="-120"/>
               </a:rPr>
-              <a:t>Dujuan: class leaves 4 at the same hour FSU shows deep to shallow warm core</a:t>
+              <a:t>Dujuan: class leaves deep warm core at the same hour FSU shows deep to shallow warm core</a:t>
             </a:r>
             <a:endParaRPr lang="en-US" sz="1300" dirty="0"/>
           </a:p>

</xml_diff>

<commit_message>
Talk and deck updated to the corrected article
Window-averaged motion proxy, onset and completion read from HB and
HVTL crossings, warm seclusion path, 2.6 s timing, Hart's quadrant
name for code 6, cropped photograph, enlarged figure panels, citations
and an honest validation slide.

Co-Authored-By: Claude Fable 5.1 <noreply@anthropic.com>
Claude-Session: https://claude.ai/code/session_019q8NWWmgCfoxLvyzmCH4VN
</commit_message>
<xml_diff>
--- a/D2D/docs/TALK.pptx
+++ b/D2D/docs/TALK.pptx
@@ -776,8 +776,8 @@
           <a:p>
             <a:r>
               <a:rPr lang="en-US" dirty="0"/>
-              <a:t>Here is what the thermal wind terms actually measure. Take a cross-section through a storm. The height of a pressure surface dips over the low. In a warm-core storm, a hurricane, the column is warm, so it is thick, so the dip is deepest at the surface and fills in with altitude. The pressure surfaces flatten out aloft. In a cold-core low the column is cold and thin, so the dip deepens with altitude and the trough is strongest at the top.
-Hart measures that with one number per level: the height range inside the circle, max minus min. Then he looks at how that range changes with height. Shrinking upward is warm core, positive. Growing upward is cold core, negative. He does it twice, once for the lower troposphere and once for the upper, and that split is what lets you tell a hurricane, warm all the way up, from a subtropical storm or a warm seclusion, which is warm only in the lower layer.</a:t>
+              <a:t>Here is what the thermal wind terms measure. Take a cross-section through a storm: the height of a pressure surface dips over the low. In a warm-core storm, a hurricane, the column is warm and thick, so the dip is deepest at the surface and fills in with altitude; the pressure surfaces flatten out aloft. In a cold-core low the column is cold and thin, so the dip deepens with altitude and the trough is strongest at the top.
+Hart measures that with one number per level: the height range inside the circle, max minus min, then how that range changes with height. Shrinking upward is warm core, positive; growing upward is cold core, negative. He does it twice, lower and upper troposphere, and that split tells a hurricane, warm all the way up, from a subtropical storm or warm seclusion, warm only in the lower layer.</a:t>
             </a:r>
             <a:endParaRPr lang="en-US" dirty="0"/>
           </a:p>
@@ -865,8 +865,8 @@
           <a:p>
             <a:r>
               <a:rPr lang="en-US" dirty="0"/>
-              <a:t>The third number, B, is about the environment rather than the core. Thickness between two pressure levels is a measure of the mean temperature of the layer. Draw the 500 kilometer circle around the storm, split it into left and right of the direction of motion, and subtract the mean thickness of the two halves.
-For a hurricane the thickness contours close around the storm, both halves are the same, and B is near zero. For a storm that has moved into a front, warm air sits on one flank and cold air on the other, and B is large. Hart's threshold is 10 meters. Evans and Hart use the hour B first exceeds it as the objective onset of extratropical transition, and the hour the lower thermal wind turns negative as completion.</a:t>
+              <a:t>The third number, B, is about the environment rather than the core. Thickness between two pressure levels measures a layer's mean temperature. The motion here is the deep-layer mean wind, averaged over that same 500 kilometer window: inside a symmetric vortex the storm's own circulation cancels out, leaving the environmental flow, with a floor of 2 meters per second. Split the circle left and right of that flow and subtract the mean thickness of the two halves.
+For a hurricane both halves are the same and B is near zero. For a storm that has moved into a front, warm air sits on one flank and cold on the other, and B is large. Hart's threshold is 10 meters. Onset is read as the frame HB crosses 10 meters, completion as the frame HVTL crosses zero, from animating those two fields; HCPSclass is just the summary.</a:t>
             </a:r>
             <a:endParaRPr lang="en-US" dirty="0"/>
           </a:p>
@@ -954,7 +954,7 @@
           <a:p>
             <a:r>
               <a:rPr lang="en-US" dirty="0"/>
-              <a:t>Put those together and you get Hart's two diagrams. On the left, B against the lower thermal wind: symmetric or frontal, warm or cold. On the right, lower against upper thermal wind: deep warm, shallow warm, or cold. A hurricane starts in the deep warm corner. During transition it crosses the B line first, then loses the upper warm core, then the lower one, and ends in the cold corner. Some storms then hook back toward shallow warm core: that is a warm seclusion re-forming a warm core at the surface, and those are the ones that deepen unexpectedly over cold water. The operational product we built turns all three numbers into one, so a forecaster reads a single class instead of two diagrams. For a marine center, transition is when the wind field expands, so these crossings are the forecast question.</a:t>
+              <a:t>Put those together and you get Hart's two diagrams. On the left, B against the lower thermal wind: symmetric or frontal, warm or cold. On the right, lower against upper thermal wind: deep warm, shallow warm, or cold. A hurricane starts in the deep warm corner; during transition it crosses the B line first, loses the upper warm core, then the lower one, and ends in the cold corner. Some storms hook back toward shallow warm core: a warm seclusion re-forming a warm core at the surface, the ones that deepen unexpectedly over cold water. The product we built turns all three numbers into one, so a forecaster reads a single class instead of two diagrams. For a marine center, transition is when the wind field expands, so these crossings are the forecast question.</a:t>
             </a:r>
             <a:endParaRPr lang="en-US" dirty="0"/>
           </a:p>
@@ -1042,8 +1042,8 @@
           <a:p>
             <a:r>
               <a:rPr lang="en-US" dirty="0"/>
-              <a:t>Until now the operational access was the FSU cyclone phase page: storm-centered diagrams for the cyclones its tracker finds, in a fixed set of models, outside the workstation. What OPC needs is the same diagnostic inside D2D, on every model we run, for any low we point at.
-We reformulated the parameters as gridded fields and implemented them as AWIPS derived parameters. At every grid point the code evaluates the height range inside a 500 kilometer window at each level and regresses it against log pressure. That is Hart's exact quantity, everywhere instead of at one tracked center. It needs only geopotential height on standard levels, surface pressure, and winds for the motion in B, so it works on every model in D2D with no tracker and no advisory. A closed-low detector on the 1000 hPa height blanks everything that isn't a real low, and terrain is masked below ground.</a:t>
+              <a:t>Until now, operational access was the FSU cyclone phase page: storm-centered diagrams for tracker-identified cyclones, in a fixed set of models, outside the workstation. What OPC needs is the same diagnostic inside D2D, on every model we run, for any low we point at.
+We reformulated the parameters as gridded fields and implemented them as AWIPS derived parameters. At every grid point the code evaluates the height range inside a 500 kilometer window at each level and regresses it against log pressure: Hart's own definition, evaluated everywhere instead of at one tracked center. The square window and standard levels keep the magnitudes close to his, not identical. It needs geopotential height on standard levels and surface pressure; the frontal term also needs winds at four levels. That runs on any model in D2D carrying those fields, with no tracker and no advisory. A closed-low detector on the 1000 hPa height keeps the class off open ocean and open troughs in the cases we've tested, and terrain is masked below ground.</a:t>
             </a:r>
             <a:endParaRPr lang="en-US" dirty="0"/>
           </a:p>
@@ -1131,7 +1131,7 @@
           <a:p>
             <a:r>
               <a:rPr lang="en-US" dirty="0"/>
-              <a:t>Here is why measuring the height field directly matters, on a synthetic case. Build a cold-core cyclone whose upper trough sits well to the west of its surface center, tilted the way many real baroclinic lows are. One panel shows that geometry: the 925 and 300 hectopascal height contours, offset from each other by the tilt. The other three are what the AWIPS field actually plots for that storm: the lower and upper thermal wind terms, and the joint class. Hart's 500 kilometer window is wide enough to take in the tilted upper trough from the surface center, so both terms read strongly cold there and the class comes out cold core, right where the surface low actually sits.</a:t>
+              <a:t>Here is why measuring the height field directly matters, on a synthetic case. Build a cold-core cyclone whose upper trough sits 393 kilometers west of its surface center, tilted the way many real baroclinic lows are, under a uniform 8 meter per second westerly steering flow. One panel shows that geometry: the 925 and 300 hectopascal height contours, offset by the tilt. The others show the upper thermal wind term and the joint class. Hart's 500 kilometer window is wide enough to take in the tilted upper trough from the surface center, so both thermal wind terms read strongly cold there, HVTL minus 285 meters and HVTU minus 284, and the class comes out 5, symmetric cold core, right where the surface low sits.</a:t>
             </a:r>
             <a:endParaRPr lang="en-US" dirty="0"/>
           </a:p>
@@ -1219,7 +1219,7 @@
           <a:p>
             <a:r>
               <a:rPr lang="en-US" dirty="0"/>
-              <a:t>This is the operational display. Four panels: the lower and upper terms, a joint class field, and an index. The class reads at the storm's center, one number for one of seven classes built from Hart's two diagrams: symmetric or frontal, deep or shallow warm core, cold core, or a rare mid-level vortex. Step through the frames on a transitioning storm and the class climbs 0, then 2, then 3, then 4; a warm seclusion runs 4 and back to 1. Load a second model beside it and compare the hour each first reaches 2 or 3, and the hour each first reaches 4 or 5; where they disagree is your transition uncertainty. That is a product nobody had before, because it needed a tracker for every model.</a:t>
+              <a:t>This is the operational display: four fields, HVTL, HVTU, the joint class, and the index. The photograph shows the two thermal wind panels, HVTL and HVTU, on a typhoon forecast. The class reads at the storm's center, one number for one of seven classes built from Hart's two diagrams: symmetric or frontal, deep or shallow warm core, cold core, or shallow cold core, lower cold and upper warm, a rare state. Step through the frames on a transitioning storm and the class climbs 0, then 2, then 3, then 4; a warm seclusion runs it from 4 to 3, or to 1 if B falls too. Load a second model beside it and compare the hour each HB crosses 10 meters and each HVTL crosses zero; where they disagree is your transition uncertainty. That's not something we've had inside our own workstation before, because it needed a tracker for every model.</a:t>
             </a:r>
             <a:endParaRPr lang="en-US" dirty="0"/>
           </a:p>
@@ -1307,7 +1307,7 @@
           <a:p>
             <a:r>
               <a:rPr lang="en-US" dirty="0"/>
-              <a:t>Three checks so far. A typhoon at 984 millibars read 120 and 180 meters, a deep warm core, class 0 or 2 in the joint field depending on B, comparable to what Hart published for hurricanes. For Typhoon Dujuan, the hour the storm's classification left its deep warm core state matched the hour FSU's page showed the same GFS run moving from deep to shallow warm core. And a deep North Atlantic low classified cold core. Greenland and the Rockies come out blank rather than contaminated. Compute cost is about a second per frame on the full global grid.</a:t>
+              <a:t>Three checks so far, all GFS cases from one model cycle: a smoke test, not a calibration. A typhoon at 984 millibars read 120 and 180 meters, a deep warm core; our bands differ from Hart's, so we don't compare that magnitude to his published values. For Typhoon Dujuan, the 2026 September 17, 1200 UTC GFS run valid 21 September 1800 UTC: the hour the class left its deep warm core state matched the hour FSU's page showed deep to shallow warm core, within one 6 hour frame. A deep North Atlantic low in the same cycle classified cold core; its values weren't recorded, so that case needs re-sampling. Greenland and the Rockies come out blank rather than contaminated. Compute cost is about 2.6 seconds per forecast hour on the full global grid, the median of four runs, ranging 2.4 to 3.0 seconds.</a:t>
             </a:r>
             <a:endParaRPr lang="en-US" dirty="0"/>
           </a:p>
@@ -1766,8 +1766,8 @@
         </p:nvSpPr>
         <p:spPr>
           <a:xfrm>
-            <a:off x="457200" y="4251960"/>
-            <a:ext cx="3931920" cy="365760"/>
+            <a:off x="457200" y="4160520"/>
+            <a:ext cx="4206240" cy="640080"/>
           </a:xfrm>
           <a:prstGeom prst="rect">
             <a:avLst/>
@@ -1780,6 +1780,9 @@
           <a:lstStyle/>
           <a:p>
             <a:pPr algn="l" indent="0" marL="0">
+              <a:spcAft>
+                <a:spcPts val="200"/>
+              </a:spcAft>
               <a:buNone/>
             </a:pPr>
             <a:r>
@@ -1791,7 +1794,24 @@
                 <a:ea typeface="Calibri" pitchFamily="34" charset="-122"/>
                 <a:cs typeface="Calibri" pitchFamily="34" charset="-120"/>
               </a:rPr>
-              <a:t>Jason Krekeler, NOAA/NWS Ocean Prediction Center, September 2026</a:t>
+              <a:t>Jason Krekeler</a:t>
+            </a:r>
+            <a:endParaRPr lang="en-US" sz="1400" dirty="0"/>
+          </a:p>
+          <a:p>
+            <a:pPr algn="l" indent="0" marL="0">
+              <a:buNone/>
+            </a:pPr>
+            <a:r>
+              <a:rPr lang="en-US" sz="1400" dirty="0">
+                <a:solidFill>
+                  <a:srgbClr val="CADCFC"/>
+                </a:solidFill>
+                <a:latin typeface="Calibri" pitchFamily="34" charset="0"/>
+                <a:ea typeface="Calibri" pitchFamily="34" charset="-122"/>
+                <a:cs typeface="Calibri" pitchFamily="34" charset="-120"/>
+              </a:rPr>
+              <a:t>NOAA/NWS Ocean Prediction Center, September 2026</a:t>
             </a:r>
             <a:endParaRPr lang="en-US" sz="1400" dirty="0"/>
           </a:p>
@@ -1813,8 +1833,8 @@
         </p:blipFill>
         <p:spPr>
           <a:xfrm>
-            <a:off x="4846320" y="1460411"/>
-            <a:ext cx="3840480" cy="2222678"/>
+            <a:off x="4663440" y="1953958"/>
+            <a:ext cx="4206240" cy="1235583"/>
           </a:xfrm>
           <a:prstGeom prst="rect">
             <a:avLst/>
@@ -2163,8 +2183,8 @@
         </p:nvSpPr>
         <p:spPr>
           <a:xfrm>
-            <a:off x="457200" y="4434840"/>
-            <a:ext cx="8229600" cy="548640"/>
+            <a:off x="457200" y="4160520"/>
+            <a:ext cx="8229600" cy="219456"/>
           </a:xfrm>
           <a:prstGeom prst="rect">
             <a:avLst/>
@@ -2180,7 +2200,7 @@
               <a:buNone/>
             </a:pPr>
             <a:r>
-              <a:rPr lang="en-US" sz="1500" dirty="0">
+              <a:rPr lang="en-US" sz="1200" dirty="0">
                 <a:solidFill>
                   <a:srgbClr val="CADCFC"/>
                 </a:solidFill>
@@ -2188,26 +2208,126 @@
                 <a:ea typeface="Calibri" pitchFamily="34" charset="-122"/>
                 <a:cs typeface="Calibri" pitchFamily="34" charset="-120"/>
               </a:rPr>
+              <a:t>Jason Krekeler, NOAA/NWS Ocean Prediction Center</a:t>
+            </a:r>
+            <a:endParaRPr lang="en-US" sz="1200" dirty="0"/>
+          </a:p>
+        </p:txBody>
+      </p:sp>
+      <p:sp>
+        <p:nvSpPr>
+          <p:cNvPr id="8" name="Text 6"/>
+          <p:cNvSpPr txBox="1"/>
+          <p:nvPr/>
+        </p:nvSpPr>
+        <p:spPr>
+          <a:xfrm>
+            <a:off x="457200" y="4379976"/>
+            <a:ext cx="8229600" cy="219456"/>
+          </a:xfrm>
+          <a:prstGeom prst="rect">
+            <a:avLst/>
+          </a:prstGeom>
+          <a:noFill/>
+          <a:ln/>
+        </p:spPr>
+        <p:txBody>
+          <a:bodyPr wrap="square" lIns="0" tIns="0" rIns="0" bIns="0" rtlCol="0" anchor="t"/>
+          <a:lstStyle/>
+          <a:p>
+            <a:pPr algn="l" indent="0" marL="0">
+              <a:buNone/>
+            </a:pPr>
+            <a:r>
+              <a:rPr lang="en-US" sz="1200" dirty="0">
+                <a:solidFill>
+                  <a:srgbClr val="CADCFC"/>
+                </a:solidFill>
+                <a:latin typeface="Calibri" pitchFamily="34" charset="0"/>
+                <a:ea typeface="Calibri" pitchFamily="34" charset="-122"/>
+                <a:cs typeface="Calibri" pitchFamily="34" charset="-120"/>
+              </a:rPr>
               <a:t>github.com/jkrek17/awips-tools, directory D2D</a:t>
             </a:r>
-            <a:endParaRPr lang="en-US" sz="1500" dirty="0"/>
-          </a:p>
+            <a:endParaRPr lang="en-US" sz="1200" dirty="0"/>
+          </a:p>
+        </p:txBody>
+      </p:sp>
+      <p:sp>
+        <p:nvSpPr>
+          <p:cNvPr id="9" name="Text 7"/>
+          <p:cNvSpPr txBox="1"/>
+          <p:nvPr/>
+        </p:nvSpPr>
+        <p:spPr>
+          <a:xfrm>
+            <a:off x="457200" y="4599432"/>
+            <a:ext cx="8229600" cy="292608"/>
+          </a:xfrm>
+          <a:prstGeom prst="rect">
+            <a:avLst/>
+          </a:prstGeom>
+          <a:noFill/>
+          <a:ln/>
+        </p:spPr>
+        <p:txBody>
+          <a:bodyPr wrap="square" lIns="0" tIns="0" rIns="0" bIns="0" rtlCol="0" anchor="t"/>
+          <a:lstStyle/>
           <a:p>
             <a:pPr algn="l" indent="0" marL="0">
               <a:buNone/>
             </a:pPr>
             <a:r>
-              <a:rPr lang="en-US" sz="1500" dirty="0">
-                <a:solidFill>
-                  <a:srgbClr val="CADCFC"/>
-                </a:solidFill>
-                <a:latin typeface="Calibri" pitchFamily="34" charset="0"/>
-                <a:ea typeface="Calibri" pitchFamily="34" charset="-122"/>
-                <a:cs typeface="Calibri" pitchFamily="34" charset="-120"/>
-              </a:rPr>
-              <a:t>Questions</a:t>
-            </a:r>
-            <a:endParaRPr lang="en-US" sz="1500" dirty="0"/>
+              <a:rPr lang="en-US" sz="1800" b="1" dirty="0">
+                <a:solidFill>
+                  <a:srgbClr val="FFFFFF"/>
+                </a:solidFill>
+                <a:latin typeface="Cambria" pitchFamily="34" charset="0"/>
+                <a:ea typeface="Cambria" pitchFamily="34" charset="-122"/>
+                <a:cs typeface="Cambria" pitchFamily="34" charset="-120"/>
+              </a:rPr>
+              <a:t>Questions?</a:t>
+            </a:r>
+            <a:endParaRPr lang="en-US" sz="1800" dirty="0"/>
+          </a:p>
+        </p:txBody>
+      </p:sp>
+      <p:sp>
+        <p:nvSpPr>
+          <p:cNvPr id="10" name="Text 8"/>
+          <p:cNvSpPr txBox="1"/>
+          <p:nvPr/>
+        </p:nvSpPr>
+        <p:spPr>
+          <a:xfrm>
+            <a:off x="457200" y="4919472"/>
+            <a:ext cx="8229600" cy="201168"/>
+          </a:xfrm>
+          <a:prstGeom prst="rect">
+            <a:avLst/>
+          </a:prstGeom>
+          <a:noFill/>
+          <a:ln/>
+        </p:spPr>
+        <p:txBody>
+          <a:bodyPr wrap="square" lIns="0" tIns="0" rIns="0" bIns="0" rtlCol="0" anchor="t"/>
+          <a:lstStyle/>
+          <a:p>
+            <a:pPr algn="l" indent="0" marL="0">
+              <a:buNone/>
+            </a:pPr>
+            <a:r>
+              <a:rPr lang="en-US" sz="750" dirty="0">
+                <a:solidFill>
+                  <a:srgbClr val="52514E"/>
+                </a:solidFill>
+                <a:latin typeface="Calibri" pitchFamily="34" charset="0"/>
+                <a:ea typeface="Calibri" pitchFamily="34" charset="-122"/>
+                <a:cs typeface="Calibri" pitchFamily="34" charset="-120"/>
+              </a:rPr>
+              <a:t>References: Hart (2003), Mon. Wea. Rev. 131, 585–616. Evans and Hart (2003), Mon. Wea. Rev. 131, 909–925. Hart et al. (2006), Mon. Wea. Rev. 134, 553–578.</a:t>
+            </a:r>
+            <a:endParaRPr lang="en-US" sz="750" dirty="0"/>
           </a:p>
         </p:txBody>
       </p:sp>
@@ -2284,7 +2404,7 @@
       </p:sp>
       <p:pic>
         <p:nvPicPr>
-          <p:cNvPr id="3" name="Image 0" descr="/home/user/awips-tools/docs/cps/figures/fig10_two_diagrams.png">    </p:cNvPr>
+          <p:cNvPr id="3" name="Image 0" descr="/tmp/claude-0/-home-user-awips-tools/3a4711f2-52b1-52e4-8d45-df8bae2bffec/scratchpad/crops/fig10_panel_b.png">    </p:cNvPr>
           <p:cNvPicPr>
             <a:picLocks noChangeAspect="1"/>
           </p:cNvPicPr>
@@ -2298,8 +2418,8 @@
         </p:blipFill>
         <p:spPr>
           <a:xfrm>
-            <a:off x="3931920" y="1418754"/>
-            <a:ext cx="4754880" cy="2420292"/>
+            <a:off x="4846320" y="845820"/>
+            <a:ext cx="3566160" cy="3566160"/>
           </a:xfrm>
           <a:prstGeom prst="rect">
             <a:avLst/>
@@ -2314,7 +2434,7 @@
         </p:nvSpPr>
         <p:spPr>
           <a:xfrm>
-            <a:off x="457200" y="1418754"/>
+            <a:off x="457200" y="845820"/>
             <a:ext cx="3200400" cy="2743200"/>
           </a:xfrm>
           <a:prstGeom prst="rect">
@@ -2396,6 +2516,45 @@
         </p:nvSpPr>
         <p:spPr>
           <a:xfrm>
+            <a:off x="457200" y="4553712"/>
+            <a:ext cx="2743200" cy="182880"/>
+          </a:xfrm>
+          <a:prstGeom prst="rect">
+            <a:avLst/>
+          </a:prstGeom>
+          <a:noFill/>
+          <a:ln/>
+        </p:spPr>
+        <p:txBody>
+          <a:bodyPr wrap="square" lIns="0" tIns="0" rIns="0" bIns="0" rtlCol="0" anchor="t"/>
+          <a:lstStyle/>
+          <a:p>
+            <a:pPr algn="l" indent="0" marL="0">
+              <a:buNone/>
+            </a:pPr>
+            <a:r>
+              <a:rPr lang="en-US" sz="900" i="1" dirty="0">
+                <a:solidFill>
+                  <a:srgbClr val="52514E"/>
+                </a:solidFill>
+                <a:latin typeface="Calibri" pitchFamily="34" charset="0"/>
+                <a:ea typeface="Calibri" pitchFamily="34" charset="-122"/>
+                <a:cs typeface="Calibri" pitchFamily="34" charset="-120"/>
+              </a:rPr>
+              <a:t>Hart (2003)</a:t>
+            </a:r>
+            <a:endParaRPr lang="en-US" sz="900" dirty="0"/>
+          </a:p>
+        </p:txBody>
+      </p:sp>
+      <p:sp>
+        <p:nvSpPr>
+          <p:cNvPr id="6" name="Text 3"/>
+          <p:cNvSpPr txBox="1"/>
+          <p:nvPr/>
+        </p:nvSpPr>
+        <p:spPr>
+          <a:xfrm>
             <a:off x="457200" y="4754880"/>
             <a:ext cx="6400800" cy="274320"/>
           </a:xfrm>
@@ -2429,7 +2588,7 @@
       </p:sp>
       <p:sp>
         <p:nvSpPr>
-          <p:cNvPr id="6" name="Text 3"/>
+          <p:cNvPr id="7" name="Text 4"/>
           <p:cNvSpPr txBox="1"/>
           <p:nvPr/>
         </p:nvSpPr>
@@ -2608,6 +2767,45 @@
         </p:nvSpPr>
         <p:spPr>
           <a:xfrm>
+            <a:off x="457200" y="4553712"/>
+            <a:ext cx="2743200" cy="182880"/>
+          </a:xfrm>
+          <a:prstGeom prst="rect">
+            <a:avLst/>
+          </a:prstGeom>
+          <a:noFill/>
+          <a:ln/>
+        </p:spPr>
+        <p:txBody>
+          <a:bodyPr wrap="square" lIns="0" tIns="0" rIns="0" bIns="0" rtlCol="0" anchor="t"/>
+          <a:lstStyle/>
+          <a:p>
+            <a:pPr algn="l" indent="0" marL="0">
+              <a:buNone/>
+            </a:pPr>
+            <a:r>
+              <a:rPr lang="en-US" sz="900" i="1" dirty="0">
+                <a:solidFill>
+                  <a:srgbClr val="52514E"/>
+                </a:solidFill>
+                <a:latin typeface="Calibri" pitchFamily="34" charset="0"/>
+                <a:ea typeface="Calibri" pitchFamily="34" charset="-122"/>
+                <a:cs typeface="Calibri" pitchFamily="34" charset="-120"/>
+              </a:rPr>
+              <a:t>Hart (2003)</a:t>
+            </a:r>
+            <a:endParaRPr lang="en-US" sz="900" dirty="0"/>
+          </a:p>
+        </p:txBody>
+      </p:sp>
+      <p:sp>
+        <p:nvSpPr>
+          <p:cNvPr id="6" name="Text 3"/>
+          <p:cNvSpPr txBox="1"/>
+          <p:nvPr/>
+        </p:nvSpPr>
+        <p:spPr>
+          <a:xfrm>
             <a:off x="457200" y="4754880"/>
             <a:ext cx="6400800" cy="274320"/>
           </a:xfrm>
@@ -2641,7 +2839,7 @@
       </p:sp>
       <p:sp>
         <p:nvSpPr>
-          <p:cNvPr id="6" name="Text 3"/>
+          <p:cNvPr id="7" name="Text 4"/>
           <p:cNvSpPr txBox="1"/>
           <p:nvPr/>
         </p:nvSpPr>
@@ -2765,8 +2963,8 @@
         </p:blipFill>
         <p:spPr>
           <a:xfrm>
-            <a:off x="457200" y="1406005"/>
-            <a:ext cx="5120640" cy="2445789"/>
+            <a:off x="457200" y="1624379"/>
+            <a:ext cx="4206240" cy="2009041"/>
           </a:xfrm>
           <a:prstGeom prst="rect">
             <a:avLst/>
@@ -2781,8 +2979,8 @@
         </p:nvSpPr>
         <p:spPr>
           <a:xfrm>
-            <a:off x="5852160" y="914400"/>
-            <a:ext cx="2834640" cy="2468880"/>
+            <a:off x="4937760" y="777240"/>
+            <a:ext cx="3749040" cy="2651760"/>
           </a:xfrm>
           <a:prstGeom prst="rect">
             <a:avLst/>
@@ -2802,7 +3000,7 @@
               <a:buChar char="•"/>
             </a:pPr>
             <a:r>
-              <a:rPr lang="en-US" sz="1500" dirty="0">
+              <a:rPr lang="en-US" sz="1300" dirty="0">
                 <a:solidFill>
                   <a:srgbClr val="0B0B0B"/>
                 </a:solidFill>
@@ -2810,9 +3008,9 @@
                 <a:ea typeface="Calibri" pitchFamily="34" charset="-122"/>
                 <a:cs typeface="Calibri" pitchFamily="34" charset="-120"/>
               </a:rPr>
-              <a:t>Thickness is the layer's mean temperature</a:t>
-            </a:r>
-            <a:endParaRPr lang="en-US" sz="1500" dirty="0"/>
+              <a:t>Thickness measures a layer's mean temperature</a:t>
+            </a:r>
+            <a:endParaRPr lang="en-US" sz="1300" dirty="0"/>
           </a:p>
           <a:p>
             <a:pPr algn="l" marL="342900" indent="-342900">
@@ -2823,7 +3021,7 @@
               <a:buChar char="•"/>
             </a:pPr>
             <a:r>
-              <a:rPr lang="en-US" sz="1500" dirty="0">
+              <a:rPr lang="en-US" sz="1300" dirty="0">
                 <a:solidFill>
                   <a:srgbClr val="0B0B0B"/>
                 </a:solidFill>
@@ -2831,9 +3029,30 @@
                 <a:ea typeface="Calibri" pitchFamily="34" charset="-122"/>
                 <a:cs typeface="Calibri" pitchFamily="34" charset="-120"/>
               </a:rPr>
-              <a:t>Split the 500 km circle left and right of the motion, subtract</a:t>
-            </a:r>
-            <a:endParaRPr lang="en-US" sz="1500" dirty="0"/>
+              <a:t>Motion: deep-layer mean wind averaged over the window (vortex's own circulation cancels; floor 2 m/s)</a:t>
+            </a:r>
+            <a:endParaRPr lang="en-US" sz="1300" dirty="0"/>
+          </a:p>
+          <a:p>
+            <a:pPr algn="l" marL="342900" indent="-342900">
+              <a:spcAft>
+                <a:spcPts val="1000"/>
+              </a:spcAft>
+              <a:buSzPct val="100000"/>
+              <a:buChar char="•"/>
+            </a:pPr>
+            <a:r>
+              <a:rPr lang="en-US" sz="1300" dirty="0">
+                <a:solidFill>
+                  <a:srgbClr val="0B0B0B"/>
+                </a:solidFill>
+                <a:latin typeface="Calibri" pitchFamily="34" charset="0"/>
+                <a:ea typeface="Calibri" pitchFamily="34" charset="-122"/>
+                <a:cs typeface="Calibri" pitchFamily="34" charset="-120"/>
+              </a:rPr>
+              <a:t>Split left and right of that flow, subtract mean thickness</a:t>
+            </a:r>
+            <a:endParaRPr lang="en-US" sz="1300" dirty="0"/>
           </a:p>
           <a:p>
             <a:pPr algn="l" marL="342900" indent="-342900">
@@ -2841,7 +3060,7 @@
               <a:buChar char="•"/>
             </a:pPr>
             <a:r>
-              <a:rPr lang="en-US" sz="1500" dirty="0">
+              <a:rPr lang="en-US" sz="1300" dirty="0">
                 <a:solidFill>
                   <a:srgbClr val="0B0B0B"/>
                 </a:solidFill>
@@ -2849,9 +3068,9 @@
                 <a:ea typeface="Calibri" pitchFamily="34" charset="-122"/>
                 <a:cs typeface="Calibri" pitchFamily="34" charset="-120"/>
               </a:rPr>
-              <a:t>Symmetric storm: B near 0. Storm in a front: B large. Threshold 10 m</a:t>
-            </a:r>
-            <a:endParaRPr lang="en-US" sz="1500" dirty="0"/>
+              <a:t>B near 0 if symmetric; large in a front. Threshold 10 m</a:t>
+            </a:r>
+            <a:endParaRPr lang="en-US" sz="1300" dirty="0"/>
           </a:p>
         </p:txBody>
       </p:sp>
@@ -2863,8 +3082,8 @@
         </p:nvSpPr>
         <p:spPr>
           <a:xfrm>
-            <a:off x="5852160" y="3520440"/>
-            <a:ext cx="2834640" cy="914400"/>
+            <a:off x="4937760" y="3703320"/>
+            <a:ext cx="3749040" cy="868680"/>
           </a:xfrm>
           <a:prstGeom prst="rect">
             <a:avLst/>
@@ -2888,7 +3107,7 @@
                 <a:ea typeface="Calibri" pitchFamily="34" charset="-122"/>
                 <a:cs typeface="Calibri" pitchFamily="34" charset="-120"/>
               </a:rPr>
-              <a:t>Evans and Hart (2003): onset when B passes 10 m, completion when the lower term turns negative.</a:t>
+              <a:t>Onset: HB crosses 10 m. Completion: HVTL crosses zero. Watched by animating those two fields; HCPSclass is the summary.</a:t>
             </a:r>
             <a:endParaRPr lang="en-US" sz="1200" dirty="0"/>
           </a:p>
@@ -3114,6 +3333,45 @@
         </p:nvSpPr>
         <p:spPr>
           <a:xfrm>
+            <a:off x="457200" y="4553712"/>
+            <a:ext cx="2743200" cy="182880"/>
+          </a:xfrm>
+          <a:prstGeom prst="rect">
+            <a:avLst/>
+          </a:prstGeom>
+          <a:noFill/>
+          <a:ln/>
+        </p:spPr>
+        <p:txBody>
+          <a:bodyPr wrap="square" lIns="0" tIns="0" rIns="0" bIns="0" rtlCol="0" anchor="t"/>
+          <a:lstStyle/>
+          <a:p>
+            <a:pPr algn="l" indent="0" marL="0">
+              <a:buNone/>
+            </a:pPr>
+            <a:r>
+              <a:rPr lang="en-US" sz="900" i="1" dirty="0">
+                <a:solidFill>
+                  <a:srgbClr val="52514E"/>
+                </a:solidFill>
+                <a:latin typeface="Calibri" pitchFamily="34" charset="0"/>
+                <a:ea typeface="Calibri" pitchFamily="34" charset="-122"/>
+                <a:cs typeface="Calibri" pitchFamily="34" charset="-120"/>
+              </a:rPr>
+              <a:t>Hart (2003)</a:t>
+            </a:r>
+            <a:endParaRPr lang="en-US" sz="900" dirty="0"/>
+          </a:p>
+        </p:txBody>
+      </p:sp>
+      <p:sp>
+        <p:nvSpPr>
+          <p:cNvPr id="6" name="Text 3"/>
+          <p:cNvSpPr txBox="1"/>
+          <p:nvPr/>
+        </p:nvSpPr>
+        <p:spPr>
+          <a:xfrm>
             <a:off x="457200" y="4754880"/>
             <a:ext cx="6400800" cy="274320"/>
           </a:xfrm>
@@ -3147,7 +3405,7 @@
       </p:sp>
       <p:sp>
         <p:nvSpPr>
-          <p:cNvPr id="6" name="Text 3"/>
+          <p:cNvPr id="7" name="Text 4"/>
           <p:cNvSpPr txBox="1"/>
           <p:nvPr/>
         </p:nvSpPr>
@@ -3257,7 +3515,7 @@
       </p:sp>
       <p:pic>
         <p:nvPicPr>
-          <p:cNvPr id="3" name="Image 0" descr="/home/user/awips-tools/docs/cps/figures/fig3_gridded.png">    </p:cNvPr>
+          <p:cNvPr id="3" name="Image 0" descr="/tmp/claude-0/-home-user-awips-tools/3a4711f2-52b1-52e4-8d45-df8bae2bffec/scratchpad/crops/fig3_panel_b.png">    </p:cNvPr>
           <p:cNvPicPr>
             <a:picLocks noChangeAspect="1"/>
           </p:cNvPicPr>
@@ -3271,24 +3529,48 @@
         </p:blipFill>
         <p:spPr>
           <a:xfrm>
-            <a:off x="457200" y="879280"/>
-            <a:ext cx="4572000" cy="3499240"/>
+            <a:off x="674618" y="777240"/>
+            <a:ext cx="3082915" cy="2743200"/>
           </a:xfrm>
           <a:prstGeom prst="rect">
             <a:avLst/>
           </a:prstGeom>
         </p:spPr>
       </p:pic>
-      <p:sp>
-        <p:nvSpPr>
-          <p:cNvPr id="4" name="Text 1"/>
-          <p:cNvSpPr txBox="1"/>
-          <p:nvPr/>
-        </p:nvSpPr>
-        <p:spPr>
-          <a:xfrm>
-            <a:off x="5303520" y="879280"/>
-            <a:ext cx="3383280" cy="2651760"/>
+      <p:pic>
+        <p:nvPicPr>
+          <p:cNvPr id="4" name="Image 1" descr="/tmp/claude-0/-home-user-awips-tools/3a4711f2-52b1-52e4-8d45-df8bae2bffec/scratchpad/crops/fig3_panel_d.png">    </p:cNvPr>
+          <p:cNvPicPr>
+            <a:picLocks noChangeAspect="1"/>
+          </p:cNvPicPr>
+          <p:nvPr/>
+        </p:nvPicPr>
+        <p:blipFill>
+          <a:blip r:embed="rId2"/>
+          <a:stretch>
+            <a:fillRect/>
+          </a:stretch>
+        </p:blipFill>
+        <p:spPr>
+          <a:xfrm>
+            <a:off x="4031853" y="777240"/>
+            <a:ext cx="4437529" cy="2743200"/>
+          </a:xfrm>
+          <a:prstGeom prst="rect">
+            <a:avLst/>
+          </a:prstGeom>
+        </p:spPr>
+      </p:pic>
+      <p:sp>
+        <p:nvSpPr>
+          <p:cNvPr id="5" name="Text 1"/>
+          <p:cNvSpPr txBox="1"/>
+          <p:nvPr/>
+        </p:nvSpPr>
+        <p:spPr>
+          <a:xfrm>
+            <a:off x="457200" y="3575304"/>
+            <a:ext cx="8229600" cy="256032"/>
           </a:xfrm>
           <a:prstGeom prst="rect">
             <a:avLst/>
@@ -3300,15 +3582,50 @@
           <a:bodyPr wrap="square" lIns="0" tIns="0" rIns="0" bIns="0" rtlCol="0" anchor="t"/>
           <a:lstStyle/>
           <a:p>
-            <a:pPr algn="l" marL="342900" indent="-342900">
-              <a:spcAft>
-                <a:spcPts val="1000"/>
-              </a:spcAft>
-              <a:buSzPct val="100000"/>
-              <a:buChar char="•"/>
-            </a:pPr>
-            <a:r>
-              <a:rPr lang="en-US" sz="1600" dirty="0">
+            <a:pPr algn="ctr" indent="0" marL="0">
+              <a:buNone/>
+            </a:pPr>
+            <a:r>
+              <a:rPr lang="en-US" sz="1200" i="1" dirty="0">
+                <a:solidFill>
+                  <a:srgbClr val="52514E"/>
+                </a:solidFill>
+                <a:latin typeface="Calibri" pitchFamily="34" charset="0"/>
+                <a:ea typeface="Calibri" pitchFamily="34" charset="-122"/>
+                <a:cs typeface="Calibri" pitchFamily="34" charset="-120"/>
+              </a:rPr>
+              <a:t>(b) HVTL, masked over the terrain block. (d) HCPSclass, the joint class field, at every grid point.</a:t>
+            </a:r>
+            <a:endParaRPr lang="en-US" sz="1200" dirty="0"/>
+          </a:p>
+        </p:txBody>
+      </p:sp>
+      <p:sp>
+        <p:nvSpPr>
+          <p:cNvPr id="6" name="Text 2"/>
+          <p:cNvSpPr txBox="1"/>
+          <p:nvPr/>
+        </p:nvSpPr>
+        <p:spPr>
+          <a:xfrm>
+            <a:off x="457200" y="3867912"/>
+            <a:ext cx="8229600" cy="685800"/>
+          </a:xfrm>
+          <a:prstGeom prst="rect">
+            <a:avLst/>
+          </a:prstGeom>
+          <a:noFill/>
+          <a:ln/>
+        </p:spPr>
+        <p:txBody>
+          <a:bodyPr wrap="square" lIns="0" tIns="0" rIns="0" bIns="0" rtlCol="0" anchor="t"/>
+          <a:lstStyle/>
+          <a:p>
+            <a:pPr algn="ctr" indent="0" marL="0">
+              <a:buNone/>
+            </a:pPr>
+            <a:r>
+              <a:rPr lang="en-US" sz="1300" dirty="0">
                 <a:solidFill>
                   <a:srgbClr val="0B0B0B"/>
                 </a:solidFill>
@@ -3316,114 +3633,15 @@
                 <a:ea typeface="Calibri" pitchFamily="34" charset="-122"/>
                 <a:cs typeface="Calibri" pitchFamily="34" charset="-120"/>
               </a:rPr>
-              <a:t>Hart's height-range regression at every grid point</a:t>
-            </a:r>
-            <a:endParaRPr lang="en-US" sz="1600" dirty="0"/>
-          </a:p>
-          <a:p>
-            <a:pPr algn="l" marL="342900" indent="-342900">
-              <a:spcAft>
-                <a:spcPts val="1000"/>
-              </a:spcAft>
-              <a:buSzPct val="100000"/>
-              <a:buChar char="•"/>
-            </a:pPr>
-            <a:r>
-              <a:rPr lang="en-US" sz="1600" dirty="0">
-                <a:solidFill>
-                  <a:srgbClr val="0B0B0B"/>
-                </a:solidFill>
-                <a:latin typeface="Calibri" pitchFamily="34" charset="0"/>
-                <a:ea typeface="Calibri" pitchFamily="34" charset="-122"/>
-                <a:cs typeface="Calibri" pitchFamily="34" charset="-120"/>
-              </a:rPr>
-              <a:t>500 km window, standard levels, surface pressure for terrain</a:t>
-            </a:r>
-            <a:endParaRPr lang="en-US" sz="1600" dirty="0"/>
-          </a:p>
-          <a:p>
-            <a:pPr algn="l" marL="342900" indent="-342900">
-              <a:spcAft>
-                <a:spcPts val="1000"/>
-              </a:spcAft>
-              <a:buSzPct val="100000"/>
-              <a:buChar char="•"/>
-            </a:pPr>
-            <a:r>
-              <a:rPr lang="en-US" sz="1600" dirty="0">
-                <a:solidFill>
-                  <a:srgbClr val="0B0B0B"/>
-                </a:solidFill>
-                <a:latin typeface="Calibri" pitchFamily="34" charset="0"/>
-                <a:ea typeface="Calibri" pitchFamily="34" charset="-122"/>
-                <a:cs typeface="Calibri" pitchFamily="34" charset="-120"/>
-              </a:rPr>
-              <a:t>Closed-low detector: only real lows get a class</a:t>
-            </a:r>
-            <a:endParaRPr lang="en-US" sz="1600" dirty="0"/>
-          </a:p>
-          <a:p>
-            <a:pPr algn="l" marL="342900" indent="-342900">
-              <a:buSzPct val="100000"/>
-              <a:buChar char="•"/>
-            </a:pPr>
-            <a:r>
-              <a:rPr lang="en-US" sz="1600" dirty="0">
-                <a:solidFill>
-                  <a:srgbClr val="0B0B0B"/>
-                </a:solidFill>
-                <a:latin typeface="Calibri" pitchFamily="34" charset="0"/>
-                <a:ea typeface="Calibri" pitchFamily="34" charset="-122"/>
-                <a:cs typeface="Calibri" pitchFamily="34" charset="-120"/>
-              </a:rPr>
-              <a:t>Every model in D2D, no tracker, no advisory</a:t>
-            </a:r>
-            <a:endParaRPr lang="en-US" sz="1600" dirty="0"/>
-          </a:p>
-        </p:txBody>
-      </p:sp>
-      <p:sp>
-        <p:nvSpPr>
-          <p:cNvPr id="5" name="Text 2"/>
-          <p:cNvSpPr txBox="1"/>
-          <p:nvPr/>
-        </p:nvSpPr>
-        <p:spPr>
-          <a:xfrm>
-            <a:off x="5303520" y="3622480"/>
-            <a:ext cx="3383280" cy="777240"/>
-          </a:xfrm>
-          <a:prstGeom prst="rect">
-            <a:avLst/>
-          </a:prstGeom>
-          <a:noFill/>
-          <a:ln/>
-        </p:spPr>
-        <p:txBody>
-          <a:bodyPr wrap="square" lIns="0" tIns="0" rIns="0" bIns="0" rtlCol="0" anchor="t"/>
-          <a:lstStyle/>
-          <a:p>
-            <a:pPr algn="l" indent="0" marL="0">
-              <a:buNone/>
-            </a:pPr>
-            <a:r>
-              <a:rPr lang="en-US" sz="1200" dirty="0">
-                <a:solidFill>
-                  <a:srgbClr val="52514E"/>
-                </a:solidFill>
-                <a:latin typeface="Calibri" pitchFamily="34" charset="0"/>
-                <a:ea typeface="Calibri" pitchFamily="34" charset="-122"/>
-                <a:cs typeface="Calibri" pitchFamily="34" charset="-120"/>
-              </a:rPr>
-              <a:t>Synthetic demonstration: a warm-core vortex, a tilted cold-core low, a terrain block, and the joint class in panel (d).</a:t>
-            </a:r>
-            <a:endParaRPr lang="en-US" sz="1200" dirty="0"/>
-          </a:p>
-        </p:txBody>
-      </p:sp>
-      <p:sp>
-        <p:nvSpPr>
-          <p:cNvPr id="6" name="Text 3"/>
+              <a:t>500 km window, standard levels, surface pressure; four wind levels too for B. Closed-low detector keeps the class off open ocean and open troughs tested. Any model with those fields, no tracker, no advisory.</a:t>
+            </a:r>
+            <a:endParaRPr lang="en-US" sz="1300" dirty="0"/>
+          </a:p>
+        </p:txBody>
+      </p:sp>
+      <p:sp>
+        <p:nvSpPr>
+          <p:cNvPr id="7" name="Text 3"/>
           <p:cNvSpPr txBox="1"/>
           <p:nvPr/>
         </p:nvSpPr>
@@ -3462,7 +3680,7 @@
       </p:sp>
       <p:sp>
         <p:nvSpPr>
-          <p:cNvPr id="7" name="Text 4"/>
+          <p:cNvPr id="8" name="Text 4"/>
           <p:cNvSpPr txBox="1"/>
           <p:nvPr/>
         </p:nvSpPr>
@@ -3572,7 +3790,7 @@
       </p:sp>
       <p:pic>
         <p:nvPicPr>
-          <p:cNvPr id="3" name="Image 0" descr="/home/user/awips-tools/docs/cps/figures/fig4_tilt.png">    </p:cNvPr>
+          <p:cNvPr id="3" name="Image 0" descr="/tmp/claude-0/-home-user-awips-tools/3a4711f2-52b1-52e4-8d45-df8bae2bffec/scratchpad/crops/fig4_panel_a.png">    </p:cNvPr>
           <p:cNvPicPr>
             <a:picLocks noChangeAspect="1"/>
           </p:cNvPicPr>
@@ -3586,24 +3804,48 @@
         </p:blipFill>
         <p:spPr>
           <a:xfrm>
-            <a:off x="5553670" y="891540"/>
-            <a:ext cx="3133130" cy="3474720"/>
+            <a:off x="1259277" y="777240"/>
+            <a:ext cx="3175563" cy="2468880"/>
           </a:xfrm>
           <a:prstGeom prst="rect">
             <a:avLst/>
           </a:prstGeom>
         </p:spPr>
       </p:pic>
-      <p:sp>
-        <p:nvSpPr>
-          <p:cNvPr id="4" name="Text 1"/>
-          <p:cNvSpPr txBox="1"/>
-          <p:nvPr/>
-        </p:nvSpPr>
-        <p:spPr>
-          <a:xfrm>
-            <a:off x="457200" y="891540"/>
-            <a:ext cx="4822150" cy="1280160"/>
+      <p:pic>
+        <p:nvPicPr>
+          <p:cNvPr id="4" name="Image 1" descr="/tmp/claude-0/-home-user-awips-tools/3a4711f2-52b1-52e4-8d45-df8bae2bffec/scratchpad/crops/fig4_panel_c.png">    </p:cNvPr>
+          <p:cNvPicPr>
+            <a:picLocks noChangeAspect="1"/>
+          </p:cNvPicPr>
+          <p:nvPr/>
+        </p:nvPicPr>
+        <p:blipFill>
+          <a:blip r:embed="rId2"/>
+          <a:stretch>
+            <a:fillRect/>
+          </a:stretch>
+        </p:blipFill>
+        <p:spPr>
+          <a:xfrm>
+            <a:off x="4709160" y="777240"/>
+            <a:ext cx="3175563" cy="2468880"/>
+          </a:xfrm>
+          <a:prstGeom prst="rect">
+            <a:avLst/>
+          </a:prstGeom>
+        </p:spPr>
+      </p:pic>
+      <p:sp>
+        <p:nvSpPr>
+          <p:cNvPr id="5" name="Text 1"/>
+          <p:cNvSpPr txBox="1"/>
+          <p:nvPr/>
+        </p:nvSpPr>
+        <p:spPr>
+          <a:xfrm>
+            <a:off x="457200" y="3300984"/>
+            <a:ext cx="8229600" cy="502920"/>
           </a:xfrm>
           <a:prstGeom prst="rect">
             <a:avLst/>
@@ -3615,11 +3857,11 @@
           <a:bodyPr wrap="square" lIns="0" tIns="0" rIns="0" bIns="0" rtlCol="0" anchor="t"/>
           <a:lstStyle/>
           <a:p>
-            <a:pPr algn="l" indent="0" marL="0">
-              <a:buNone/>
-            </a:pPr>
-            <a:r>
-              <a:rPr lang="en-US" sz="1600" dirty="0">
+            <a:pPr algn="ctr" indent="0" marL="0">
+              <a:buNone/>
+            </a:pPr>
+            <a:r>
+              <a:rPr lang="en-US" sz="1300" dirty="0">
                 <a:solidFill>
                   <a:srgbClr val="0B0B0B"/>
                 </a:solidFill>
@@ -3627,65 +3869,26 @@
                 <a:ea typeface="Calibri" pitchFamily="34" charset="-122"/>
                 <a:cs typeface="Calibri" pitchFamily="34" charset="-120"/>
               </a:rPr>
-              <a:t>Synthetic cold-core low with its upper trough displaced west of the surface center: tilt geometry (925 and 300 hPa height), then HVTL, HVTU, and the joint class.</a:t>
-            </a:r>
-            <a:endParaRPr lang="en-US" sz="1600" dirty="0"/>
-          </a:p>
-        </p:txBody>
-      </p:sp>
-      <p:sp>
-        <p:nvSpPr>
-          <p:cNvPr id="5" name="Text 2"/>
-          <p:cNvSpPr txBox="1"/>
-          <p:nvPr/>
-        </p:nvSpPr>
-        <p:spPr>
-          <a:xfrm>
-            <a:off x="457200" y="2308860"/>
-            <a:ext cx="4822150" cy="822960"/>
-          </a:xfrm>
-          <a:prstGeom prst="rect">
-            <a:avLst/>
-          </a:prstGeom>
-          <a:noFill/>
-          <a:ln/>
-        </p:spPr>
-        <p:txBody>
-          <a:bodyPr wrap="square" lIns="0" tIns="0" rIns="0" bIns="0" rtlCol="0" anchor="t"/>
-          <a:lstStyle/>
-          <a:p>
-            <a:pPr algn="l" indent="0" marL="0">
-              <a:buNone/>
-            </a:pPr>
-            <a:r>
-              <a:rPr lang="en-US" sz="1600" dirty="0">
-                <a:solidFill>
-                  <a:srgbClr val="0B0B0B"/>
-                </a:solidFill>
-                <a:latin typeface="Calibri" pitchFamily="34" charset="0"/>
-                <a:ea typeface="Calibri" pitchFamily="34" charset="-122"/>
-                <a:cs typeface="Calibri" pitchFamily="34" charset="-120"/>
-              </a:rPr>
-              <a:t>Hart's 500 km window spans the tilt, so both thermal wind terms read cold at the surface center.</a:t>
-            </a:r>
-            <a:endParaRPr lang="en-US" sz="1600" dirty="0"/>
-          </a:p>
-        </p:txBody>
-      </p:sp>
-      <p:sp>
-        <p:nvSpPr>
-          <p:cNvPr id="6" name="Shape 3"/>
+              <a:t>(a) Tilt geometry: 300 hPa minimum 393 km west of center, 8 m/s westerly steering. (c) HVTU there: -284 m; HVTL also -285 m (not shown).</a:t>
+            </a:r>
+            <a:endParaRPr lang="en-US" sz="1300" dirty="0"/>
+          </a:p>
+        </p:txBody>
+      </p:sp>
+      <p:sp>
+        <p:nvSpPr>
+          <p:cNvPr id="6" name="Shape 2"/>
           <p:cNvSpPr/>
           <p:nvPr/>
         </p:nvSpPr>
         <p:spPr>
           <a:xfrm>
-            <a:off x="457200" y="3314700"/>
-            <a:ext cx="4822150" cy="1005840"/>
+            <a:off x="2468880" y="3867912"/>
+            <a:ext cx="4206240" cy="457200"/>
           </a:xfrm>
           <a:prstGeom prst="roundRect">
             <a:avLst>
-              <a:gd name="adj" fmla="val 7273"/>
+              <a:gd name="adj" fmla="val 16000"/>
             </a:avLst>
           </a:prstGeom>
           <a:solidFill>
@@ -3696,14 +3899,14 @@
       </p:sp>
       <p:sp>
         <p:nvSpPr>
-          <p:cNvPr id="7" name="Text 4"/>
-          <p:cNvSpPr txBox="1"/>
-          <p:nvPr/>
-        </p:nvSpPr>
-        <p:spPr>
-          <a:xfrm>
-            <a:off x="594360" y="3314700"/>
-            <a:ext cx="4547830" cy="1005840"/>
+          <p:cNvPr id="7" name="Text 3"/>
+          <p:cNvSpPr txBox="1"/>
+          <p:nvPr/>
+        </p:nvSpPr>
+        <p:spPr>
+          <a:xfrm>
+            <a:off x="2606040" y="3867912"/>
+            <a:ext cx="3931920" cy="457200"/>
           </a:xfrm>
           <a:prstGeom prst="rect">
             <a:avLst/>
@@ -3715,7 +3918,7 @@
           <a:bodyPr wrap="square" lIns="0" tIns="0" rIns="0" bIns="0" rtlCol="0" anchor="ctr"/>
           <a:lstStyle/>
           <a:p>
-            <a:pPr algn="l" indent="0" marL="0">
+            <a:pPr algn="ctr" indent="0" marL="0">
               <a:buNone/>
             </a:pPr>
             <a:r>
@@ -3729,7 +3932,7 @@
               </a:rPr>
               <a:t>Class at center: </a:t>
             </a:r>
-            <a:pPr algn="l" indent="0" marL="0">
+            <a:pPr algn="ctr" indent="0" marL="0">
               <a:buNone/>
             </a:pPr>
             <a:r>
@@ -3741,21 +3944,7 @@
                 <a:ea typeface="Calibri" pitchFamily="34" charset="-122"/>
                 <a:cs typeface="Calibri" pitchFamily="34" charset="-120"/>
               </a:rPr>
-              <a:t>cold core</a:t>
-            </a:r>
-            <a:pPr algn="l" indent="0" marL="0">
-              <a:buNone/>
-            </a:pPr>
-            <a:r>
-              <a:rPr lang="en-US" sz="1400" dirty="0">
-                <a:solidFill>
-                  <a:srgbClr val="0B0B0B"/>
-                </a:solidFill>
-                <a:latin typeface="Calibri" pitchFamily="34" charset="0"/>
-                <a:ea typeface="Calibri" pitchFamily="34" charset="-122"/>
-                <a:cs typeface="Calibri" pitchFamily="34" charset="-120"/>
-              </a:rPr>
-              <a:t>, not warm</a:t>
+              <a:t>5, symmetric cold core</a:t>
             </a:r>
             <a:endParaRPr lang="en-US" sz="1400" dirty="0"/>
           </a:p>
@@ -3763,7 +3952,7 @@
       </p:sp>
       <p:sp>
         <p:nvSpPr>
-          <p:cNvPr id="8" name="Text 5"/>
+          <p:cNvPr id="8" name="Text 4"/>
           <p:cNvSpPr txBox="1"/>
           <p:nvPr/>
         </p:nvSpPr>
@@ -3802,7 +3991,7 @@
       </p:sp>
       <p:sp>
         <p:nvSpPr>
-          <p:cNvPr id="9" name="Text 6"/>
+          <p:cNvPr id="9" name="Text 5"/>
           <p:cNvSpPr txBox="1"/>
           <p:nvPr/>
         </p:nvSpPr>
@@ -3926,8 +4115,8 @@
         </p:blipFill>
         <p:spPr>
           <a:xfrm>
-            <a:off x="2066544" y="777240"/>
-            <a:ext cx="5010912" cy="2900065"/>
+            <a:off x="914400" y="777240"/>
+            <a:ext cx="7315200" cy="2148840"/>
           </a:xfrm>
           <a:prstGeom prst="rect">
             <a:avLst/>
@@ -3942,8 +4131,8 @@
         </p:nvSpPr>
         <p:spPr>
           <a:xfrm>
-            <a:off x="457200" y="3749040"/>
-            <a:ext cx="8229600" cy="228600"/>
+            <a:off x="457200" y="2999232"/>
+            <a:ext cx="8229600" cy="256032"/>
           </a:xfrm>
           <a:prstGeom prst="rect">
             <a:avLst/>
@@ -3967,7 +4156,7 @@
                 <a:ea typeface="Calibri" pitchFamily="34" charset="-122"/>
                 <a:cs typeface="Calibri" pitchFamily="34" charset="-120"/>
               </a:rPr>
-              <a:t>Operational CAVE display: lower term, upper term, class, index. Photograph of the live display.</a:t>
+              <a:t>Operational CAVE display: HVTL (left) and HVTU (right), photographed from the monitor.</a:t>
             </a:r>
             <a:endParaRPr lang="en-US" sz="1100" dirty="0"/>
           </a:p>
@@ -3981,8 +4170,8 @@
         </p:nvSpPr>
         <p:spPr>
           <a:xfrm>
-            <a:off x="457200" y="4005072"/>
-            <a:ext cx="8229600" cy="457200"/>
+            <a:off x="457200" y="3429000"/>
+            <a:ext cx="8229600" cy="1143000"/>
           </a:xfrm>
           <a:prstGeom prst="rect">
             <a:avLst/>
@@ -4006,7 +4195,7 @@
                 <a:ea typeface="Calibri" pitchFamily="34" charset="-122"/>
                 <a:cs typeface="Calibri" pitchFamily="34" charset="-120"/>
               </a:rPr>
-              <a:t>Read one number at the center: 0 hurricane, 2 and 3 transition under way, 4 and 5 cold core, 1 after a warm seclusion. Compare models on the hour the class first reaches 2, and the hour it first reaches 4.</a:t>
+              <a:t>Read one number at the center: 0 hurricane, 2 to 3 transition under way, 4 cold core, 6 shallow cold core (rare: lower cold, upper warm), 1 after a warm seclusion (4 to 3, or 4 to 1 if B falls too). Compare models on the hour HB crosses 10 m and the hour HVTL crosses zero.</a:t>
             </a:r>
             <a:endParaRPr lang="en-US" sz="1400" dirty="0"/>
           </a:p>
@@ -4255,7 +4444,7 @@
                 <a:ea typeface="Calibri" pitchFamily="34" charset="-122"/>
                 <a:cs typeface="Calibri" pitchFamily="34" charset="-120"/>
               </a:rPr>
-              <a:t>typhoon, lower and upper term, deep warm core</a:t>
+              <a:t>typhoon, lower and upper term, deep warm core (not compared to Hart's values; bands differ)</a:t>
             </a:r>
             <a:endParaRPr lang="en-US" sz="1300" dirty="0"/>
           </a:p>
@@ -4316,7 +4505,7 @@
                 <a:ea typeface="Cambria" pitchFamily="34" charset="-122"/>
                 <a:cs typeface="Cambria" pitchFamily="34" charset="-120"/>
               </a:rPr>
-              <a:t>18Z 21 Sep</a:t>
+              <a:t>17 Sep 12Z run</a:t>
             </a:r>
             <a:endParaRPr lang="en-US" sz="3000" dirty="0"/>
           </a:p>
@@ -4355,7 +4544,7 @@
                 <a:ea typeface="Calibri" pitchFamily="34" charset="-122"/>
                 <a:cs typeface="Calibri" pitchFamily="34" charset="-120"/>
               </a:rPr>
-              <a:t>Dujuan: class leaves deep warm core at the same hour FSU shows deep to shallow warm core</a:t>
+              <a:t>Dujuan: class leaves deep warm core the same hour FSU shows deep to shallow, within 6 h</a:t>
             </a:r>
             <a:endParaRPr lang="en-US" sz="1300" dirty="0"/>
           </a:p>
@@ -4455,7 +4644,7 @@
                 <a:ea typeface="Calibri" pitchFamily="34" charset="-122"/>
                 <a:cs typeface="Calibri" pitchFamily="34" charset="-120"/>
               </a:rPr>
-              <a:t>deep North Atlantic low reads cold core</a:t>
+              <a:t>deep North Atlantic low reads cold core; values not recorded, re-sampling</a:t>
             </a:r>
             <a:endParaRPr lang="en-US" sz="1300" dirty="0"/>
           </a:p>
@@ -4516,7 +4705,7 @@
                 <a:ea typeface="Cambria" pitchFamily="34" charset="-122"/>
                 <a:cs typeface="Cambria" pitchFamily="34" charset="-120"/>
               </a:rPr>
-              <a:t>about 1.5 s</a:t>
+              <a:t>about 2.6 s</a:t>
             </a:r>
             <a:endParaRPr lang="en-US" sz="3000" dirty="0"/>
           </a:p>
@@ -4555,7 +4744,7 @@
                 <a:ea typeface="Calibri" pitchFamily="34" charset="-122"/>
                 <a:cs typeface="Calibri" pitchFamily="34" charset="-120"/>
               </a:rPr>
-              <a:t>per frame, full 0.25 degree global grid</a:t>
+              <a:t>per forecast hour, 0.25° global grid (median of 4 runs, 2.4–3.0 s)</a:t>
             </a:r>
             <a:endParaRPr lang="en-US" sz="1300" dirty="0"/>
           </a:p>

</xml_diff>

<commit_message>
Talk and deck: results slide leads with the sampled life-cycle case
Co-Authored-By: Claude Fable 5.1 <noreply@anthropic.com>
Claude-Session: https://claude.ai/code/session_019q8NWWmgCfoxLvyzmCH4VN
</commit_message>
<xml_diff>
--- a/D2D/docs/TALK.pptx
+++ b/D2D/docs/TALK.pptx
@@ -4405,7 +4405,7 @@
                 <a:ea typeface="Cambria" pitchFamily="34" charset="-122"/>
                 <a:cs typeface="Cambria" pitchFamily="34" charset="-120"/>
               </a:rPr>
-              <a:t>120 m / 180 m</a:t>
+              <a:t>0 → 2 → 3 → 1</a:t>
             </a:r>
             <a:endParaRPr lang="en-US" sz="3000" dirty="0"/>
           </a:p>
@@ -4444,7 +4444,7 @@
                 <a:ea typeface="Calibri" pitchFamily="34" charset="-122"/>
                 <a:cs typeface="Calibri" pitchFamily="34" charset="-120"/>
               </a:rPr>
-              <a:t>typhoon, lower and upper term, deep warm core (not compared to Hart's values; bands differ)</a:t>
+              <a:t>one typhoon, GFS 20 Sep 06Z: deep warm at 0 h, onset by 24 h (B 13 m), upper core lost by 48 h, seclusion by 96 h (lower +241 m, upper −295 m, B 0.5 m)</a:t>
             </a:r>
             <a:endParaRPr lang="en-US" sz="1300" dirty="0"/>
           </a:p>
@@ -4505,7 +4505,7 @@
                 <a:ea typeface="Cambria" pitchFamily="34" charset="-122"/>
                 <a:cs typeface="Cambria" pitchFamily="34" charset="-120"/>
               </a:rPr>
-              <a:t>17 Sep 12Z run</a:t>
+              <a:t>Matches FSU</a:t>
             </a:r>
             <a:endParaRPr lang="en-US" sz="3000" dirty="0"/>
           </a:p>
@@ -4544,7 +4544,7 @@
                 <a:ea typeface="Calibri" pitchFamily="34" charset="-122"/>
                 <a:cs typeface="Calibri" pitchFamily="34" charset="-120"/>
               </a:rPr>
-              <a:t>Dujuan: class leaves deep warm core the same hour FSU shows deep to shallow, within 6 h</a:t>
+              <a:t>Hart's own diagrams for the storm trace the same sequence; cold-phase upper term −290 m vs his −300 m</a:t>
             </a:r>
             <a:endParaRPr lang="en-US" sz="1300" dirty="0"/>
           </a:p>
@@ -4605,7 +4605,7 @@
                 <a:ea typeface="Cambria" pitchFamily="34" charset="-122"/>
                 <a:cs typeface="Cambria" pitchFamily="34" charset="-120"/>
               </a:rPr>
-              <a:t>Cold core</a:t>
+              <a:t>+3 m</a:t>
             </a:r>
             <a:endParaRPr lang="en-US" sz="3000" dirty="0"/>
           </a:p>
@@ -4644,7 +4644,7 @@
                 <a:ea typeface="Calibri" pitchFamily="34" charset="-122"/>
                 <a:cs typeface="Calibri" pitchFamily="34" charset="-120"/>
               </a:rPr>
-              <a:t>deep North Atlantic low reads cold core; values not recorded, re-sampling</a:t>
+              <a:t>the one class 6 frame at 120 h has an upper term of +3 m: a threshold artifact, read as class 4</a:t>
             </a:r>
             <a:endParaRPr lang="en-US" sz="1300" dirty="0"/>
           </a:p>

</xml_diff>

<commit_message>
Replace the CAVE photograph with screen captures
Figure 9 is now a six-frame montage of the HCPSclass field through one
typhoon's life cycle and Figure 10 the four-panel procedure at 48 h,
both cropped from full-screen D2D captures by make_cave_figures.py.
Later figures renumber 11 to 13. The photograph and its crop code are
removed, the talk deck uses the four-panel capture on slides 1 and 8,
and the README log attributes the 12 and 30 h frames to the 18Z run.

Co-Authored-By: Claude Fable 5.1 <noreply@anthropic.com>
Claude-Session: https://claude.ai/code/session_019q8NWWmgCfoxLvyzmCH4VN
</commit_message>
<xml_diff>
--- a/D2D/docs/TALK.pptx
+++ b/D2D/docs/TALK.pptx
@@ -1219,7 +1219,7 @@
           <a:p>
             <a:r>
               <a:rPr lang="en-US" dirty="0"/>
-              <a:t>This is the operational display: four fields, HVTL, HVTU, the joint class, and the index. The photograph shows the two thermal wind panels, HVTL and HVTU, on a typhoon forecast. The class reads at the storm's center, one number for one of seven classes built from Hart's two diagrams: symmetric or frontal, deep or shallow warm core, cold core, or shallow cold core, lower cold and upper warm, a rare state. Step through the frames on a transitioning storm and the class climbs 0, then 2, then 3, then 4; a warm seclusion runs it from 4 to 3, or to 1 if B falls too. Load a second model beside it and compare the hour each HB crosses 10 meters and each HVTL crosses zero; where they disagree is your transition uncertainty. That's not something we've had inside our own workstation before, because it needed a tracker for every model.</a:t>
+              <a:t>This is the operational display: four fields, HVTL, HVTU, the joint class, and the index. The capture is the 48 hour frame of the 20 September run, the storm east of Japan at 976 millibars, class 3, with B at 36, the lower term at 114 and the upper at minus 102. The class reads at the storm's center, one number for one of seven classes built from Hart's two diagrams: symmetric or frontal, deep or shallow warm core, cold core, or shallow cold core, lower cold and upper warm, a rare state. Step through the frames on a transitioning storm and the class climbs 0, then 2, then 3, then 4; a warm seclusion runs it from 4 to 3, or to 1 if B falls too. Load a second model beside it and compare the hour each HB crosses 10 meters and each HVTL crosses zero; where they disagree is your transition uncertainty. That's not something we've had inside our own workstation before, because it needed a tracker for every model.</a:t>
             </a:r>
             <a:endParaRPr lang="en-US" dirty="0"/>
           </a:p>
@@ -1819,7 +1819,7 @@
       </p:sp>
       <p:pic>
         <p:nvPicPr>
-          <p:cNvPr id="5" name="Image 0" descr="/home/user/awips-tools/docs/cps/figures/fig6_cave_typhoon.jpg">    </p:cNvPr>
+          <p:cNvPr id="5" name="Image 0" descr="/home/user/awips-tools/docs/cps/figures/fig10_cave_4panel.jpg">    </p:cNvPr>
           <p:cNvPicPr>
             <a:picLocks noChangeAspect="1"/>
           </p:cNvPicPr>
@@ -1833,8 +1833,8 @@
         </p:blipFill>
         <p:spPr>
           <a:xfrm>
-            <a:off x="4663440" y="1953958"/>
-            <a:ext cx="4206240" cy="1235583"/>
+            <a:off x="4663440" y="1550568"/>
+            <a:ext cx="4206240" cy="2042363"/>
           </a:xfrm>
           <a:prstGeom prst="rect">
             <a:avLst/>
@@ -4101,7 +4101,7 @@
       </p:sp>
       <p:pic>
         <p:nvPicPr>
-          <p:cNvPr id="3" name="Image 0" descr="/home/user/awips-tools/docs/cps/figures/fig6_cave_typhoon.jpg">    </p:cNvPr>
+          <p:cNvPr id="3" name="Image 0" descr="/home/user/awips-tools/docs/cps/figures/fig10_cave_4panel.jpg">    </p:cNvPr>
           <p:cNvPicPr>
             <a:picLocks noChangeAspect="1"/>
           </p:cNvPicPr>
@@ -4115,8 +4115,8 @@
         </p:blipFill>
         <p:spPr>
           <a:xfrm>
-            <a:off x="914400" y="777240"/>
-            <a:ext cx="7315200" cy="2148840"/>
+            <a:off x="457200" y="914400"/>
+            <a:ext cx="5394960" cy="2619553"/>
           </a:xfrm>
           <a:prstGeom prst="rect">
             <a:avLst/>
@@ -4131,8 +4131,8 @@
         </p:nvSpPr>
         <p:spPr>
           <a:xfrm>
-            <a:off x="457200" y="2999232"/>
-            <a:ext cx="8229600" cy="256032"/>
+            <a:off x="457200" y="3607105"/>
+            <a:ext cx="5394960" cy="548640"/>
           </a:xfrm>
           <a:prstGeom prst="rect">
             <a:avLst/>
@@ -4144,11 +4144,11 @@
           <a:bodyPr wrap="square" lIns="0" tIns="0" rIns="0" bIns="0" rtlCol="0" anchor="t"/>
           <a:lstStyle/>
           <a:p>
-            <a:pPr algn="ctr" indent="0" marL="0">
-              <a:buNone/>
-            </a:pPr>
-            <a:r>
-              <a:rPr lang="en-US" sz="1100" i="1" dirty="0">
+            <a:pPr algn="l" indent="0" marL="0">
+              <a:buNone/>
+            </a:pPr>
+            <a:r>
+              <a:rPr lang="en-US" sz="1000" i="1" dirty="0">
                 <a:solidFill>
                   <a:srgbClr val="52514E"/>
                 </a:solidFill>
@@ -4156,9 +4156,9 @@
                 <a:ea typeface="Calibri" pitchFamily="34" charset="-122"/>
                 <a:cs typeface="Calibri" pitchFamily="34" charset="-120"/>
               </a:rPr>
-              <a:t>Operational CAVE display: HVTL (left) and HVTU (right), photographed from the monitor.</a:t>
-            </a:r>
-            <a:endParaRPr lang="en-US" sz="1100" dirty="0"/>
+              <a:t>CAVE four-panel procedure, 48 h of the 20 Sep 06Z GFS: class (top left), B (top right), HVTL and HVTU (bottom left), index (bottom right). Storm at 976 mb: class 3, B 36 m, HVTL +114 m, HVTU -102 m.</a:t>
+            </a:r>
+            <a:endParaRPr lang="en-US" sz="1000" dirty="0"/>
           </a:p>
         </p:txBody>
       </p:sp>
@@ -4170,8 +4170,8 @@
         </p:nvSpPr>
         <p:spPr>
           <a:xfrm>
-            <a:off x="457200" y="3429000"/>
-            <a:ext cx="8229600" cy="1143000"/>
+            <a:off x="6126480" y="914400"/>
+            <a:ext cx="2560320" cy="3291840"/>
           </a:xfrm>
           <a:prstGeom prst="rect">
             <a:avLst/>
@@ -4187,7 +4187,7 @@
               <a:buNone/>
             </a:pPr>
             <a:r>
-              <a:rPr lang="en-US" sz="1400" dirty="0">
+              <a:rPr lang="en-US" sz="1300" dirty="0">
                 <a:solidFill>
                   <a:srgbClr val="0B0B0B"/>
                 </a:solidFill>
@@ -4195,9 +4195,32 @@
                 <a:ea typeface="Calibri" pitchFamily="34" charset="-122"/>
                 <a:cs typeface="Calibri" pitchFamily="34" charset="-120"/>
               </a:rPr>
-              <a:t>Read one number at the center: 0 hurricane, 2 to 3 transition under way, 4 cold core, 6 shallow cold core (rare: lower cold, upper warm), 1 after a warm seclusion (4 to 3, or 4 to 1 if B falls too). Compare models on the hour HB crosses 10 m and the hour HVTL crosses zero.</a:t>
-            </a:r>
-            <a:endParaRPr lang="en-US" sz="1400" dirty="0"/>
+              <a:t>Read one number at the center: 0 hurricane, 2 to 3 transition under way, 4 cold core, 6 shallow cold core (rare: lower cold, upper warm), 1 after a warm seclusion (4 to 3, or 4 to 1 if B falls too).</a:t>
+            </a:r>
+            <a:endParaRPr lang="en-US" sz="1300" dirty="0"/>
+          </a:p>
+          <a:p>
+            <a:pPr algn="l" indent="0" marL="0">
+              <a:buNone/>
+            </a:pPr>
+            <a:endParaRPr lang="en-US" sz="1300" dirty="0"/>
+          </a:p>
+          <a:p>
+            <a:pPr algn="l" indent="0" marL="0">
+              <a:buNone/>
+            </a:pPr>
+            <a:r>
+              <a:rPr lang="en-US" sz="1300" dirty="0">
+                <a:solidFill>
+                  <a:srgbClr val="0B0B0B"/>
+                </a:solidFill>
+                <a:latin typeface="Calibri" pitchFamily="34" charset="0"/>
+                <a:ea typeface="Calibri" pitchFamily="34" charset="-122"/>
+                <a:cs typeface="Calibri" pitchFamily="34" charset="-120"/>
+              </a:rPr>
+              <a:t>Compare models on the hour HB crosses 10 m and the hour HVTL crosses zero.</a:t>
+            </a:r>
+            <a:endParaRPr lang="en-US" sz="1300" dirty="0"/>
           </a:p>
         </p:txBody>
       </p:sp>

</xml_diff>

<commit_message>
Use Hart's term "asymmetric" for the B > 10 m classes
Hart labels the B > 10 m half of his phase space "asymmetric (frontal)"
and the other half "symmetric (nonfrontal)". The article, guides,
README, talk, figure scripts, code docstrings, tests, definition XML
long name, style-rule and colormap comments now use "asymmetric" as
the class term, with "frontal" kept as a one-time gloss in the class
table, the executive summary, the user guide and the README, and
wherever the word carries its ordinary meteorological meaning.
Figures with quadrant labels are regenerated; the numbers are
unchanged.

Co-Authored-By: Claude Fable 5.1 <noreply@anthropic.com>
Claude-Session: https://claude.ai/code/session_019q8NWWmgCfoxLvyzmCH4VN
</commit_message>
<xml_diff>
--- a/D2D/docs/TALK.pptx
+++ b/D2D/docs/TALK.pptx
@@ -688,7 +688,7 @@
           <a:p>
             <a:r>
               <a:rPr lang="en-US" dirty="0"/>
-              <a:t>The science is Bob Hart's cyclone phase space from 2003. It describes a cyclone with three numbers from the height field alone, all taken inside a 500 kilometer circle around the center. Two are thermal wind terms, one for the lower troposphere and one for the upper, and they say whether the core is warmer or colder than its surroundings. The third, B, says whether the storm is frontal. Together they place any cyclone on a diagram, and a storm traces a path through it as it evolves.</a:t>
+              <a:t>The science is Bob Hart's cyclone phase space from 2003. It describes a cyclone with three numbers from the height field alone, all taken inside a 500 kilometer circle around the center. Two are thermal wind terms, one for the lower troposphere and one for the upper, and they say whether the core is warmer or colder than its surroundings. The third, B, says whether the storm is asymmetric. Together they place any cyclone on a diagram, and a storm traces a path through it as it evolves.</a:t>
             </a:r>
             <a:endParaRPr lang="en-US" dirty="0"/>
           </a:p>
@@ -954,7 +954,7 @@
           <a:p>
             <a:r>
               <a:rPr lang="en-US" dirty="0"/>
-              <a:t>Put those together and you get Hart's two diagrams. On the left, B against the lower thermal wind: symmetric or frontal, warm or cold. On the right, lower against upper thermal wind: deep warm, shallow warm, or cold. A hurricane starts in the deep warm corner; during transition it crosses the B line first, loses the upper warm core, then the lower one, and ends in the cold corner. Some storms hook back toward shallow warm core: a warm seclusion re-forming a warm core at the surface, the ones that deepen unexpectedly over cold water. The product we built turns all three numbers into one, so a forecaster reads a single class instead of two diagrams. For a marine center, transition is when the wind field expands, so these crossings are the forecast question.</a:t>
+              <a:t>Put those together and you get Hart's two diagrams. On the left, B against the lower thermal wind: symmetric or asymmetric, warm or cold. On the right, lower against upper thermal wind: deep warm, shallow warm, or cold. A hurricane starts in the deep warm corner; during transition it crosses the B line first, loses the upper warm core, then the lower one, and ends in the cold corner. Some storms hook back toward shallow warm core: a warm seclusion re-forming a warm core at the surface, the ones that deepen unexpectedly over cold water. The product we built turns all three numbers into one, so a forecaster reads a single class instead of two diagrams. For a marine center, transition is when the wind field expands, so these crossings are the forecast question.</a:t>
             </a:r>
             <a:endParaRPr lang="en-US" dirty="0"/>
           </a:p>
@@ -1043,7 +1043,7 @@
             <a:r>
               <a:rPr lang="en-US" dirty="0"/>
               <a:t>Until now, operational access was the FSU cyclone phase page: storm-centered diagrams for tracker-identified cyclones, in a fixed set of models, outside the workstation. What OPC needs is the same diagnostic inside D2D, on every model we run, for any low we point at.
-We reformulated the parameters as gridded fields and implemented them as AWIPS derived parameters. At every grid point the code evaluates the height range inside a 500 kilometer window at each level and regresses it against log pressure: Hart's own definition, evaluated everywhere instead of at one tracked center. The square window and standard levels keep the magnitudes close to his, not identical. It needs geopotential height on standard levels and surface pressure; the frontal term also needs winds at four levels. That runs on any model in D2D carrying those fields, with no tracker and no advisory. A closed-low detector on the 1000 hPa height keeps the class off open ocean and open troughs in the cases we've tested, and terrain is masked below ground.</a:t>
+We reformulated the parameters as gridded fields and implemented them as AWIPS derived parameters. At every grid point the code evaluates the height range inside a 500 kilometer window at each level and regresses it against log pressure: Hart's own definition, evaluated everywhere instead of at one tracked center. The square window and standard levels keep the magnitudes close to his, not identical. It needs geopotential height on standard levels and surface pressure; the asymmetric term also needs winds at four levels. That runs on any model in D2D carrying those fields, with no tracker and no advisory. A closed-low detector on the 1000 hPa height keeps the class off open ocean and open troughs in the cases we've tested, and terrain is masked below ground.</a:t>
             </a:r>
             <a:endParaRPr lang="en-US" dirty="0"/>
           </a:p>
@@ -1219,7 +1219,7 @@
           <a:p>
             <a:r>
               <a:rPr lang="en-US" dirty="0"/>
-              <a:t>This is the operational display: four fields, HVTL, HVTU, the joint class, and the index. The capture is the 48 hour frame of the 20 September run, the storm east of Japan at 976 millibars, class 3, with B at 36, the lower term at 114 and the upper at minus 102. The class reads at the storm's center, one number for one of seven classes built from Hart's two diagrams: symmetric or frontal, deep or shallow warm core, cold core, or shallow cold core, lower cold and upper warm, a rare state. Step through the frames on a transitioning storm and the class climbs 0, then 2, then 3, then 4; a warm seclusion runs it from 4 to 3, or to 1 if B falls too. Load a second model beside it and compare the hour each HB crosses 10 meters and each HVTL crosses zero; where they disagree is your transition uncertainty. That's not something we've had inside our own workstation before, because it needed a tracker for every model.</a:t>
+              <a:t>This is the operational display: four fields, HVTL, HVTU, the joint class, and the index. The capture is the 48 hour frame of the 20 September run, the storm east of Japan at 976 millibars, class 3, with B at 36, the lower term at 114 and the upper at minus 102. The class reads at the storm's center, one number for one of seven classes built from Hart's two diagrams: symmetric or asymmetric, deep or shallow warm core, cold core, or shallow cold core, lower cold and upper warm, a rare state. Step through the frames on a transitioning storm and the class climbs 0, then 2, then 3, then 4; a warm seclusion runs it from 4 to 3, or to 1 if B falls too. Load a second model beside it and compare the hour each HB crosses 10 meters and each HVTL crosses zero; where they disagree is your transition uncertainty. That's not something we've had inside our own workstation before, because it needed a tracker for every model.</a:t>
             </a:r>
             <a:endParaRPr lang="en-US" dirty="0"/>
           </a:p>
@@ -2484,7 +2484,7 @@
                 <a:ea typeface="Calibri" pitchFamily="34" charset="-122"/>
                 <a:cs typeface="Calibri" pitchFamily="34" charset="-120"/>
               </a:rPr>
-              <a:t>B: is the storm frontal</a:t>
+              <a:t>B: is the storm asymmetric</a:t>
             </a:r>
             <a:endParaRPr lang="en-US" sz="1700" dirty="0"/>
           </a:p>

</xml_diff>